<commit_message>
add FMI3 FMUs, update slides
</commit_message>
<xml_diff>
--- a/part1/Introduction-to-FMI.pptx
+++ b/part1/Introduction-to-FMI.pptx
@@ -5,10 +5,10 @@
     <p:sldMasterId id="2147483649" r:id="rId3"/>
   </p:sldMasterIdLst>
   <p:notesMasterIdLst>
-    <p:notesMasterId r:id="rId35"/>
+    <p:notesMasterId r:id="rId37"/>
   </p:notesMasterIdLst>
   <p:handoutMasterIdLst>
-    <p:handoutMasterId r:id="rId36"/>
+    <p:handoutMasterId r:id="rId38"/>
   </p:handoutMasterIdLst>
   <p:sldIdLst>
     <p:sldId id="314" r:id="rId4"/>
@@ -37,14 +37,19 @@
     <p:sldId id="461" r:id="rId27"/>
     <p:sldId id="463" r:id="rId28"/>
     <p:sldId id="462" r:id="rId29"/>
-    <p:sldId id="466" r:id="rId30"/>
-    <p:sldId id="474" r:id="rId31"/>
-    <p:sldId id="471" r:id="rId32"/>
-    <p:sldId id="476" r:id="rId33"/>
-    <p:sldId id="477" r:id="rId34"/>
+    <p:sldId id="479" r:id="rId30"/>
+    <p:sldId id="478" r:id="rId31"/>
+    <p:sldId id="466" r:id="rId32"/>
+    <p:sldId id="474" r:id="rId33"/>
+    <p:sldId id="471" r:id="rId34"/>
+    <p:sldId id="476" r:id="rId35"/>
+    <p:sldId id="477" r:id="rId36"/>
   </p:sldIdLst>
   <p:sldSz cx="12192000" cy="6858000"/>
   <p:notesSz cx="6858000" cy="9144000"/>
+  <p:custDataLst>
+    <p:tags r:id="rId39"/>
+  </p:custDataLst>
   <p:defaultTextStyle>
     <a:defPPr>
       <a:defRPr lang="de-DE"/>
@@ -582,7 +587,7 @@
               <a:pPr>
                 <a:defRPr/>
               </a:pPr>
-              <a:t>7/2/2024</a:t>
+              <a:t>7/23/2025</a:t>
             </a:fld>
             <a:endParaRPr lang="en-US"/>
           </a:p>
@@ -1387,7 +1392,7 @@
                   <a:srgbClr val="5E676E"/>
                 </a:solidFill>
               </a:rPr>
-              <a:t>© 2024 FMI Modelica Association Project | www.fmi-standard.org</a:t>
+              <a:t>© 2025 FMI Modelica Association Project | www.fmi-standard.org</a:t>
             </a:r>
           </a:p>
         </p:txBody>
@@ -2861,7 +2866,7 @@
                   <a:srgbClr val="C00000"/>
                 </a:solidFill>
               </a:rPr>
-              <a:t>© 2024 Modelica Association Project FMI | www.fmi-standard.org</a:t>
+              <a:t>© 2025 Modelica Association Project FMI | www.fmi-standard.org</a:t>
             </a:r>
           </a:p>
         </p:txBody>
@@ -3938,7 +3943,7 @@
         </p:nvSpPr>
         <p:spPr>
           <a:xfrm>
-            <a:off x="9619757" y="5961260"/>
+            <a:off x="9534916" y="5961260"/>
             <a:ext cx="4823460" cy="738664"/>
           </a:xfrm>
           <a:prstGeom prst="rect">
@@ -3982,7 +3987,7 @@
                 <a:cs typeface="+mn-cs"/>
                 <a:hlinkClick r:id="rId4"/>
               </a:rPr>
-              <a:t>fmi-beginners-tutorial-2024/tree/main</a:t>
+              <a:t>fmi-beginners-tutorial-2025/tree/main</a:t>
             </a:r>
             <a:endParaRPr lang="en-US" sz="1200" dirty="0">
               <a:solidFill>
@@ -4041,10 +4046,10 @@
       </p:pic>
       <p:pic>
         <p:nvPicPr>
-          <p:cNvPr id="11" name="Grafik 10">
+          <p:cNvPr id="10" name="Grafik 9">
             <a:extLst>
               <a:ext uri="{FF2B5EF4-FFF2-40B4-BE49-F238E27FC236}">
-                <a16:creationId xmlns:a16="http://schemas.microsoft.com/office/drawing/2014/main" id="{97285DC0-C233-4B14-D5B7-A7C1834C11C6}"/>
+                <a16:creationId xmlns:a16="http://schemas.microsoft.com/office/drawing/2014/main" id="{80177D94-F5B4-0EF9-4E60-66E4A4E91314}"/>
               </a:ext>
             </a:extLst>
           </p:cNvPr>
@@ -4059,9 +4064,6 @@
               <a:ext uri="{28A0092B-C50C-407E-A947-70E740481C1C}">
                 <a14:useLocalDpi xmlns:a14="http://schemas.microsoft.com/office/drawing/2010/main" val="0"/>
               </a:ext>
-              <a:ext uri="{96DAC541-7B7A-43D3-8B79-37D633B846F1}">
-                <asvg:svgBlip xmlns:asvg="http://schemas.microsoft.com/office/drawing/2016/SVG/main" r:embed="rId7"/>
-              </a:ext>
             </a:extLst>
           </a:blip>
           <a:stretch>
@@ -4070,8 +4072,8 @@
         </p:blipFill>
         <p:spPr>
           <a:xfrm>
-            <a:off x="9787923" y="4049318"/>
-            <a:ext cx="1974090" cy="1974090"/>
+            <a:off x="9619757" y="3935135"/>
+            <a:ext cx="1942707" cy="1942707"/>
           </a:xfrm>
           <a:prstGeom prst="rect">
             <a:avLst/>
@@ -14484,6 +14486,282 @@
 <file path=ppt/slides/slide27.xml><?xml version="1.0" encoding="utf-8"?>
 <p:sld xmlns:a="http://schemas.openxmlformats.org/drawingml/2006/main" xmlns:r="http://schemas.openxmlformats.org/officeDocument/2006/relationships" xmlns:p="http://schemas.openxmlformats.org/presentationml/2006/main">
   <p:cSld>
+    <p:spTree>
+      <p:nvGrpSpPr>
+        <p:cNvPr id="1" name=""/>
+        <p:cNvGrpSpPr/>
+        <p:nvPr/>
+      </p:nvGrpSpPr>
+      <p:grpSpPr>
+        <a:xfrm>
+          <a:off x="0" y="0"/>
+          <a:ext cx="0" cy="0"/>
+          <a:chOff x="0" y="0"/>
+          <a:chExt cx="0" cy="0"/>
+        </a:xfrm>
+      </p:grpSpPr>
+      <p:sp>
+        <p:nvSpPr>
+          <p:cNvPr id="2" name="Inhaltsplatzhalter 1">
+            <a:extLst>
+              <a:ext uri="{FF2B5EF4-FFF2-40B4-BE49-F238E27FC236}">
+                <a16:creationId xmlns:a16="http://schemas.microsoft.com/office/drawing/2014/main" id="{46108B23-BD53-2C8A-D4AA-B3CEF98FA52C}"/>
+              </a:ext>
+            </a:extLst>
+          </p:cNvPr>
+          <p:cNvSpPr>
+            <a:spLocks noGrp="1"/>
+          </p:cNvSpPr>
+          <p:nvPr>
+            <p:ph idx="1"/>
+          </p:nvPr>
+        </p:nvSpPr>
+        <p:spPr/>
+        <p:txBody>
+          <a:bodyPr/>
+          <a:lstStyle/>
+          <a:p>
+            <a:endParaRPr lang="en-US"/>
+          </a:p>
+        </p:txBody>
+      </p:sp>
+      <p:sp>
+        <p:nvSpPr>
+          <p:cNvPr id="3" name="Titel 2">
+            <a:extLst>
+              <a:ext uri="{FF2B5EF4-FFF2-40B4-BE49-F238E27FC236}">
+                <a16:creationId xmlns:a16="http://schemas.microsoft.com/office/drawing/2014/main" id="{C92BA9CF-FE05-F0DC-4EA6-66E8BBCEC5C4}"/>
+              </a:ext>
+            </a:extLst>
+          </p:cNvPr>
+          <p:cNvSpPr>
+            <a:spLocks noGrp="1"/>
+          </p:cNvSpPr>
+          <p:nvPr>
+            <p:ph type="title"/>
+          </p:nvPr>
+        </p:nvSpPr>
+        <p:spPr/>
+        <p:txBody>
+          <a:bodyPr/>
+          <a:lstStyle/>
+          <a:p>
+            <a:r>
+              <a:rPr lang="en-US" dirty="0"/>
+              <a:t>Array variables</a:t>
+            </a:r>
+          </a:p>
+        </p:txBody>
+      </p:sp>
+      <p:pic>
+        <p:nvPicPr>
+          <p:cNvPr id="5" name="Grafik 4">
+            <a:extLst>
+              <a:ext uri="{FF2B5EF4-FFF2-40B4-BE49-F238E27FC236}">
+                <a16:creationId xmlns:a16="http://schemas.microsoft.com/office/drawing/2014/main" id="{2DAF8738-9BFF-3F3E-E1E7-46A076B8D4A7}"/>
+              </a:ext>
+            </a:extLst>
+          </p:cNvPr>
+          <p:cNvPicPr>
+            <a:picLocks noChangeAspect="1"/>
+          </p:cNvPicPr>
+          <p:nvPr/>
+        </p:nvPicPr>
+        <p:blipFill>
+          <a:blip r:embed="rId2"/>
+          <a:stretch>
+            <a:fillRect/>
+          </a:stretch>
+        </p:blipFill>
+        <p:spPr>
+          <a:xfrm>
+            <a:off x="1267289" y="1835945"/>
+            <a:ext cx="9657421" cy="3186110"/>
+          </a:xfrm>
+          <a:prstGeom prst="rect">
+            <a:avLst/>
+          </a:prstGeom>
+        </p:spPr>
+      </p:pic>
+    </p:spTree>
+    <p:extLst>
+      <p:ext uri="{BB962C8B-B14F-4D97-AF65-F5344CB8AC3E}">
+        <p14:creationId xmlns:p14="http://schemas.microsoft.com/office/powerpoint/2010/main" val="3534557293"/>
+      </p:ext>
+    </p:extLst>
+  </p:cSld>
+  <p:clrMapOvr>
+    <a:masterClrMapping/>
+  </p:clrMapOvr>
+  <p:transition/>
+</p:sld>
+</file>
+
+<file path=ppt/slides/slide28.xml><?xml version="1.0" encoding="utf-8"?>
+<p:sld xmlns:a="http://schemas.openxmlformats.org/drawingml/2006/main" xmlns:r="http://schemas.openxmlformats.org/officeDocument/2006/relationships" xmlns:p="http://schemas.openxmlformats.org/presentationml/2006/main">
+  <p:cSld>
+    <p:spTree>
+      <p:nvGrpSpPr>
+        <p:cNvPr id="1" name=""/>
+        <p:cNvGrpSpPr/>
+        <p:nvPr/>
+      </p:nvGrpSpPr>
+      <p:grpSpPr>
+        <a:xfrm>
+          <a:off x="0" y="0"/>
+          <a:ext cx="0" cy="0"/>
+          <a:chOff x="0" y="0"/>
+          <a:chExt cx="0" cy="0"/>
+        </a:xfrm>
+      </p:grpSpPr>
+      <p:sp>
+        <p:nvSpPr>
+          <p:cNvPr id="2" name="Inhaltsplatzhalter 1">
+            <a:extLst>
+              <a:ext uri="{FF2B5EF4-FFF2-40B4-BE49-F238E27FC236}">
+                <a16:creationId xmlns:a16="http://schemas.microsoft.com/office/drawing/2014/main" id="{CA0C9647-08D2-E5CE-ABEA-2ADBFAAA620D}"/>
+              </a:ext>
+            </a:extLst>
+          </p:cNvPr>
+          <p:cNvSpPr>
+            <a:spLocks noGrp="1"/>
+          </p:cNvSpPr>
+          <p:nvPr>
+            <p:ph idx="1"/>
+          </p:nvPr>
+        </p:nvSpPr>
+        <p:spPr/>
+        <p:txBody>
+          <a:bodyPr/>
+          <a:lstStyle/>
+          <a:p>
+            <a:r>
+              <a:rPr lang="en-US" dirty="0">
+                <a:hlinkClick r:id="rId2"/>
+              </a:rPr>
+              <a:t>https://github.com/t-sommer/fmi3-features</a:t>
+            </a:r>
+            <a:r>
+              <a:rPr lang="en-US" dirty="0"/>
+              <a:t> </a:t>
+            </a:r>
+          </a:p>
+          <a:p>
+            <a:endParaRPr lang="en-US" dirty="0"/>
+          </a:p>
+          <a:p>
+            <a:r>
+              <a:rPr lang="en-US" dirty="0"/>
+              <a:t>FMI 3 with events</a:t>
+            </a:r>
+          </a:p>
+        </p:txBody>
+      </p:sp>
+      <p:sp>
+        <p:nvSpPr>
+          <p:cNvPr id="3" name="Titel 2">
+            <a:extLst>
+              <a:ext uri="{FF2B5EF4-FFF2-40B4-BE49-F238E27FC236}">
+                <a16:creationId xmlns:a16="http://schemas.microsoft.com/office/drawing/2014/main" id="{E27E7D4E-0399-C144-13E6-67D458BADC01}"/>
+              </a:ext>
+            </a:extLst>
+          </p:cNvPr>
+          <p:cNvSpPr>
+            <a:spLocks noGrp="1"/>
+          </p:cNvSpPr>
+          <p:nvPr>
+            <p:ph type="title"/>
+          </p:nvPr>
+        </p:nvSpPr>
+        <p:spPr/>
+        <p:txBody>
+          <a:bodyPr/>
+          <a:lstStyle/>
+          <a:p>
+            <a:r>
+              <a:rPr lang="en-US" dirty="0"/>
+              <a:t>FMI 3 examples</a:t>
+            </a:r>
+          </a:p>
+        </p:txBody>
+      </p:sp>
+      <p:pic>
+        <p:nvPicPr>
+          <p:cNvPr id="5" name="Grafik 4">
+            <a:extLst>
+              <a:ext uri="{FF2B5EF4-FFF2-40B4-BE49-F238E27FC236}">
+                <a16:creationId xmlns:a16="http://schemas.microsoft.com/office/drawing/2014/main" id="{B60B9856-0C40-B144-B991-1D0059278770}"/>
+              </a:ext>
+            </a:extLst>
+          </p:cNvPr>
+          <p:cNvPicPr>
+            <a:picLocks noChangeAspect="1"/>
+          </p:cNvPicPr>
+          <p:nvPr/>
+        </p:nvPicPr>
+        <p:blipFill>
+          <a:blip r:embed="rId3"/>
+          <a:stretch>
+            <a:fillRect/>
+          </a:stretch>
+        </p:blipFill>
+        <p:spPr>
+          <a:xfrm>
+            <a:off x="6169439" y="3923722"/>
+            <a:ext cx="4369728" cy="2061773"/>
+          </a:xfrm>
+          <a:prstGeom prst="rect">
+            <a:avLst/>
+          </a:prstGeom>
+        </p:spPr>
+      </p:pic>
+      <p:pic>
+        <p:nvPicPr>
+          <p:cNvPr id="7" name="Grafik 6">
+            <a:extLst>
+              <a:ext uri="{FF2B5EF4-FFF2-40B4-BE49-F238E27FC236}">
+                <a16:creationId xmlns:a16="http://schemas.microsoft.com/office/drawing/2014/main" id="{855D4E45-CD58-87FA-1832-8488EC427C6D}"/>
+              </a:ext>
+            </a:extLst>
+          </p:cNvPr>
+          <p:cNvPicPr>
+            <a:picLocks noChangeAspect="1"/>
+          </p:cNvPicPr>
+          <p:nvPr/>
+        </p:nvPicPr>
+        <p:blipFill>
+          <a:blip r:embed="rId4"/>
+          <a:stretch>
+            <a:fillRect/>
+          </a:stretch>
+        </p:blipFill>
+        <p:spPr>
+          <a:xfrm>
+            <a:off x="610612" y="3789574"/>
+            <a:ext cx="4583009" cy="1831293"/>
+          </a:xfrm>
+          <a:prstGeom prst="rect">
+            <a:avLst/>
+          </a:prstGeom>
+        </p:spPr>
+      </p:pic>
+    </p:spTree>
+    <p:extLst>
+      <p:ext uri="{BB962C8B-B14F-4D97-AF65-F5344CB8AC3E}">
+        <p14:creationId xmlns:p14="http://schemas.microsoft.com/office/powerpoint/2010/main" val="3711406455"/>
+      </p:ext>
+    </p:extLst>
+  </p:cSld>
+  <p:clrMapOvr>
+    <a:masterClrMapping/>
+  </p:clrMapOvr>
+  <p:transition/>
+</p:sld>
+</file>
+
+<file path=ppt/slides/slide29.xml><?xml version="1.0" encoding="utf-8"?>
+<p:sld xmlns:a="http://schemas.openxmlformats.org/drawingml/2006/main" xmlns:r="http://schemas.openxmlformats.org/officeDocument/2006/relationships" xmlns:p="http://schemas.openxmlformats.org/presentationml/2006/main">
+  <p:cSld>
     <p:bg>
       <p:bgPr>
         <a:solidFill>
@@ -14580,7 +14858,350 @@
 </p:sld>
 </file>
 
-<file path=ppt/slides/slide28.xml><?xml version="1.0" encoding="utf-8"?>
+<file path=ppt/slides/slide3.xml><?xml version="1.0" encoding="utf-8"?>
+<p:sld xmlns:a="http://schemas.openxmlformats.org/drawingml/2006/main" xmlns:r="http://schemas.openxmlformats.org/officeDocument/2006/relationships" xmlns:p="http://schemas.openxmlformats.org/presentationml/2006/main">
+  <p:cSld>
+    <p:spTree>
+      <p:nvGrpSpPr>
+        <p:cNvPr id="1" name=""/>
+        <p:cNvGrpSpPr/>
+        <p:nvPr/>
+      </p:nvGrpSpPr>
+      <p:grpSpPr>
+        <a:xfrm>
+          <a:off x="0" y="0"/>
+          <a:ext cx="0" cy="0"/>
+          <a:chOff x="0" y="0"/>
+          <a:chExt cx="0" cy="0"/>
+        </a:xfrm>
+      </p:grpSpPr>
+      <p:sp>
+        <p:nvSpPr>
+          <p:cNvPr id="5" name="Inhaltsplatzhalter 4">
+            <a:extLst>
+              <a:ext uri="{FF2B5EF4-FFF2-40B4-BE49-F238E27FC236}">
+                <a16:creationId xmlns:a16="http://schemas.microsoft.com/office/drawing/2014/main" id="{67430165-842A-5F14-A591-01F55A119BD9}"/>
+              </a:ext>
+            </a:extLst>
+          </p:cNvPr>
+          <p:cNvSpPr>
+            <a:spLocks noGrp="1"/>
+          </p:cNvSpPr>
+          <p:nvPr>
+            <p:ph idx="1"/>
+          </p:nvPr>
+        </p:nvSpPr>
+        <p:spPr/>
+        <p:txBody>
+          <a:bodyPr/>
+          <a:lstStyle/>
+          <a:p>
+            <a:r>
+              <a:rPr lang="en-US" sz="4000" b="1" dirty="0"/>
+              <a:t>Introduction to FMI</a:t>
+            </a:r>
+            <a:endParaRPr lang="en-US" dirty="0"/>
+          </a:p>
+        </p:txBody>
+      </p:sp>
+      <p:sp>
+        <p:nvSpPr>
+          <p:cNvPr id="4" name="Titel 3">
+            <a:extLst>
+              <a:ext uri="{FF2B5EF4-FFF2-40B4-BE49-F238E27FC236}">
+                <a16:creationId xmlns:a16="http://schemas.microsoft.com/office/drawing/2014/main" id="{B1C8FE56-2E01-097C-45C4-D3BC2A5ADD27}"/>
+              </a:ext>
+            </a:extLst>
+          </p:cNvPr>
+          <p:cNvSpPr>
+            <a:spLocks noGrp="1"/>
+          </p:cNvSpPr>
+          <p:nvPr>
+            <p:ph type="title"/>
+          </p:nvPr>
+        </p:nvSpPr>
+        <p:spPr/>
+        <p:txBody>
+          <a:bodyPr/>
+          <a:lstStyle/>
+          <a:p>
+            <a:r>
+              <a:rPr lang="en-US" dirty="0"/>
+              <a:t> </a:t>
+            </a:r>
+          </a:p>
+        </p:txBody>
+      </p:sp>
+      <p:pic>
+        <p:nvPicPr>
+          <p:cNvPr id="2" name="Picture 4">
+            <a:extLst>
+              <a:ext uri="{FF2B5EF4-FFF2-40B4-BE49-F238E27FC236}">
+                <a16:creationId xmlns:a16="http://schemas.microsoft.com/office/drawing/2014/main" id="{C6F665E4-16E4-89B7-F29E-C5589A9A5087}"/>
+              </a:ext>
+            </a:extLst>
+          </p:cNvPr>
+          <p:cNvPicPr>
+            <a:picLocks noChangeAspect="1"/>
+          </p:cNvPicPr>
+          <p:nvPr/>
+        </p:nvPicPr>
+        <p:blipFill>
+          <a:blip r:embed="rId2">
+            <a:extLst>
+              <a:ext uri="{28A0092B-C50C-407E-A947-70E740481C1C}">
+                <a14:useLocalDpi xmlns:a14="http://schemas.microsoft.com/office/drawing/2010/main" val="0"/>
+              </a:ext>
+            </a:extLst>
+          </a:blip>
+          <a:stretch>
+            <a:fillRect/>
+          </a:stretch>
+        </p:blipFill>
+        <p:spPr>
+          <a:xfrm>
+            <a:off x="620184" y="3130345"/>
+            <a:ext cx="5818812" cy="2378376"/>
+          </a:xfrm>
+          <a:prstGeom prst="rect">
+            <a:avLst/>
+          </a:prstGeom>
+        </p:spPr>
+      </p:pic>
+      <p:sp>
+        <p:nvSpPr>
+          <p:cNvPr id="3" name="TextBox 2">
+            <a:extLst>
+              <a:ext uri="{FF2B5EF4-FFF2-40B4-BE49-F238E27FC236}">
+                <a16:creationId xmlns:a16="http://schemas.microsoft.com/office/drawing/2014/main" id="{D9B8BF98-CDEA-294F-5A40-BA21B6EEF1E0}"/>
+              </a:ext>
+            </a:extLst>
+          </p:cNvPr>
+          <p:cNvSpPr txBox="1"/>
+          <p:nvPr/>
+        </p:nvSpPr>
+        <p:spPr>
+          <a:xfrm>
+            <a:off x="664119" y="2022364"/>
+            <a:ext cx="4823460" cy="646331"/>
+          </a:xfrm>
+          <a:prstGeom prst="rect">
+            <a:avLst/>
+          </a:prstGeom>
+          <a:noFill/>
+        </p:spPr>
+        <p:txBody>
+          <a:bodyPr wrap="square" rtlCol="0">
+            <a:spAutoFit/>
+          </a:bodyPr>
+          <a:lstStyle/>
+          <a:p>
+            <a:r>
+              <a:rPr lang="en-US" sz="1800" dirty="0">
+                <a:solidFill>
+                  <a:srgbClr val="5E676E"/>
+                </a:solidFill>
+                <a:latin typeface="+mn-lt"/>
+                <a:cs typeface="+mn-cs"/>
+              </a:rPr>
+              <a:t>Presenter:</a:t>
+            </a:r>
+            <a:br>
+              <a:rPr lang="en-US" sz="1800" dirty="0">
+                <a:solidFill>
+                  <a:srgbClr val="5E676E"/>
+                </a:solidFill>
+                <a:latin typeface="+mn-lt"/>
+                <a:cs typeface="+mn-cs"/>
+              </a:rPr>
+            </a:br>
+            <a:r>
+              <a:rPr lang="en-US" sz="1800" dirty="0">
+                <a:solidFill>
+                  <a:srgbClr val="5E676E"/>
+                </a:solidFill>
+                <a:latin typeface="+mn-lt"/>
+                <a:cs typeface="+mn-cs"/>
+              </a:rPr>
+              <a:t>Christian Bertsch, Bosch Research</a:t>
+            </a:r>
+          </a:p>
+        </p:txBody>
+      </p:sp>
+      <p:sp>
+        <p:nvSpPr>
+          <p:cNvPr id="7" name="TextBox 4">
+            <a:extLst>
+              <a:ext uri="{FF2B5EF4-FFF2-40B4-BE49-F238E27FC236}">
+                <a16:creationId xmlns:a16="http://schemas.microsoft.com/office/drawing/2014/main" id="{978ADD06-3B1E-7161-A229-C13B73EE0EAF}"/>
+              </a:ext>
+            </a:extLst>
+          </p:cNvPr>
+          <p:cNvSpPr txBox="1"/>
+          <p:nvPr/>
+        </p:nvSpPr>
+        <p:spPr>
+          <a:xfrm>
+            <a:off x="9619757" y="3586701"/>
+            <a:ext cx="2142256" cy="369332"/>
+          </a:xfrm>
+          <a:prstGeom prst="rect">
+            <a:avLst/>
+          </a:prstGeom>
+          <a:noFill/>
+        </p:spPr>
+        <p:txBody>
+          <a:bodyPr wrap="square" rtlCol="0">
+            <a:spAutoFit/>
+          </a:bodyPr>
+          <a:lstStyle/>
+          <a:p>
+            <a:r>
+              <a:rPr lang="en-US" sz="1800" dirty="0">
+                <a:solidFill>
+                  <a:srgbClr val="5E676E"/>
+                </a:solidFill>
+                <a:latin typeface="+mn-lt"/>
+                <a:cs typeface="+mn-cs"/>
+              </a:rPr>
+              <a:t>Online Materials:</a:t>
+            </a:r>
+          </a:p>
+        </p:txBody>
+      </p:sp>
+      <p:sp>
+        <p:nvSpPr>
+          <p:cNvPr id="10" name="TextBox 6">
+            <a:extLst>
+              <a:ext uri="{FF2B5EF4-FFF2-40B4-BE49-F238E27FC236}">
+                <a16:creationId xmlns:a16="http://schemas.microsoft.com/office/drawing/2014/main" id="{029415F6-21ED-FE69-17BC-A2F9B50AC688}"/>
+              </a:ext>
+            </a:extLst>
+          </p:cNvPr>
+          <p:cNvSpPr txBox="1"/>
+          <p:nvPr/>
+        </p:nvSpPr>
+        <p:spPr>
+          <a:xfrm>
+            <a:off x="9619757" y="5961260"/>
+            <a:ext cx="4823460" cy="738664"/>
+          </a:xfrm>
+          <a:prstGeom prst="rect">
+            <a:avLst/>
+          </a:prstGeom>
+          <a:noFill/>
+        </p:spPr>
+        <p:txBody>
+          <a:bodyPr wrap="square" rtlCol="0">
+            <a:spAutoFit/>
+          </a:bodyPr>
+          <a:lstStyle/>
+          <a:p>
+            <a:r>
+              <a:rPr lang="en-US" sz="1200" dirty="0">
+                <a:solidFill>
+                  <a:srgbClr val="5E676E"/>
+                </a:solidFill>
+                <a:latin typeface="+mn-lt"/>
+                <a:cs typeface="+mn-cs"/>
+                <a:hlinkClick r:id="rId3"/>
+              </a:rPr>
+              <a:t>https://github.com/modelica/</a:t>
+            </a:r>
+            <a:br>
+              <a:rPr lang="en-US" sz="1200" dirty="0">
+                <a:solidFill>
+                  <a:srgbClr val="5E676E"/>
+                </a:solidFill>
+                <a:latin typeface="+mn-lt"/>
+                <a:cs typeface="+mn-cs"/>
+                <a:hlinkClick r:id="rId3"/>
+              </a:rPr>
+            </a:br>
+            <a:r>
+              <a:rPr lang="en-US" sz="1200" dirty="0">
+                <a:solidFill>
+                  <a:srgbClr val="5E676E"/>
+                </a:solidFill>
+                <a:latin typeface="+mn-lt"/>
+                <a:cs typeface="+mn-cs"/>
+                <a:hlinkClick r:id="rId3"/>
+              </a:rPr>
+              <a:t>fmi-beginners-tutorial-2024/tree/main</a:t>
+            </a:r>
+            <a:endParaRPr lang="en-US" sz="1200" dirty="0">
+              <a:solidFill>
+                <a:srgbClr val="5E676E"/>
+              </a:solidFill>
+              <a:latin typeface="+mn-lt"/>
+              <a:cs typeface="+mn-cs"/>
+            </a:endParaRPr>
+          </a:p>
+          <a:p>
+            <a:endParaRPr lang="en-US" sz="1800" dirty="0">
+              <a:solidFill>
+                <a:srgbClr val="5E676E"/>
+              </a:solidFill>
+              <a:latin typeface="+mn-lt"/>
+              <a:cs typeface="+mn-cs"/>
+            </a:endParaRPr>
+          </a:p>
+        </p:txBody>
+      </p:sp>
+      <p:pic>
+        <p:nvPicPr>
+          <p:cNvPr id="11" name="Grafik 10">
+            <a:extLst>
+              <a:ext uri="{FF2B5EF4-FFF2-40B4-BE49-F238E27FC236}">
+                <a16:creationId xmlns:a16="http://schemas.microsoft.com/office/drawing/2014/main" id="{85547DFE-87A6-5D51-B6B2-16817869D8DB}"/>
+              </a:ext>
+            </a:extLst>
+          </p:cNvPr>
+          <p:cNvPicPr>
+            <a:picLocks noChangeAspect="1"/>
+          </p:cNvPicPr>
+          <p:nvPr/>
+        </p:nvPicPr>
+        <p:blipFill>
+          <a:blip r:embed="rId4">
+            <a:extLst>
+              <a:ext uri="{28A0092B-C50C-407E-A947-70E740481C1C}">
+                <a14:useLocalDpi xmlns:a14="http://schemas.microsoft.com/office/drawing/2010/main" val="0"/>
+              </a:ext>
+              <a:ext uri="{96DAC541-7B7A-43D3-8B79-37D633B846F1}">
+                <asvg:svgBlip xmlns:asvg="http://schemas.microsoft.com/office/drawing/2016/SVG/main" r:embed="rId5"/>
+              </a:ext>
+            </a:extLst>
+          </a:blip>
+          <a:stretch>
+            <a:fillRect/>
+          </a:stretch>
+        </p:blipFill>
+        <p:spPr>
+          <a:xfrm>
+            <a:off x="9787923" y="4049318"/>
+            <a:ext cx="1974090" cy="1974090"/>
+          </a:xfrm>
+          <a:prstGeom prst="rect">
+            <a:avLst/>
+          </a:prstGeom>
+        </p:spPr>
+      </p:pic>
+    </p:spTree>
+    <p:extLst>
+      <p:ext uri="{BB962C8B-B14F-4D97-AF65-F5344CB8AC3E}">
+        <p14:creationId xmlns:p14="http://schemas.microsoft.com/office/powerpoint/2010/main" val="3567263522"/>
+      </p:ext>
+    </p:extLst>
+  </p:cSld>
+  <p:clrMapOvr>
+    <a:masterClrMapping/>
+  </p:clrMapOvr>
+  <p:transition/>
+</p:sld>
+</file>
+
+<file path=ppt/slides/slide30.xml><?xml version="1.0" encoding="utf-8"?>
 <p:sld xmlns:a="http://schemas.openxmlformats.org/drawingml/2006/main" xmlns:r="http://schemas.openxmlformats.org/officeDocument/2006/relationships" xmlns:p="http://schemas.openxmlformats.org/presentationml/2006/main">
   <p:cSld>
     <p:spTree>
@@ -14999,7 +15620,7 @@
 </p:sld>
 </file>
 
-<file path=ppt/slides/slide29.xml><?xml version="1.0" encoding="utf-8"?>
+<file path=ppt/slides/slide31.xml><?xml version="1.0" encoding="utf-8"?>
 <p:sld xmlns:a="http://schemas.openxmlformats.org/drawingml/2006/main" xmlns:r="http://schemas.openxmlformats.org/officeDocument/2006/relationships" xmlns:p="http://schemas.openxmlformats.org/presentationml/2006/main">
   <p:cSld>
     <p:spTree>
@@ -16472,350 +17093,7 @@
 </p:sld>
 </file>
 
-<file path=ppt/slides/slide3.xml><?xml version="1.0" encoding="utf-8"?>
-<p:sld xmlns:a="http://schemas.openxmlformats.org/drawingml/2006/main" xmlns:r="http://schemas.openxmlformats.org/officeDocument/2006/relationships" xmlns:p="http://schemas.openxmlformats.org/presentationml/2006/main">
-  <p:cSld>
-    <p:spTree>
-      <p:nvGrpSpPr>
-        <p:cNvPr id="1" name=""/>
-        <p:cNvGrpSpPr/>
-        <p:nvPr/>
-      </p:nvGrpSpPr>
-      <p:grpSpPr>
-        <a:xfrm>
-          <a:off x="0" y="0"/>
-          <a:ext cx="0" cy="0"/>
-          <a:chOff x="0" y="0"/>
-          <a:chExt cx="0" cy="0"/>
-        </a:xfrm>
-      </p:grpSpPr>
-      <p:sp>
-        <p:nvSpPr>
-          <p:cNvPr id="5" name="Inhaltsplatzhalter 4">
-            <a:extLst>
-              <a:ext uri="{FF2B5EF4-FFF2-40B4-BE49-F238E27FC236}">
-                <a16:creationId xmlns:a16="http://schemas.microsoft.com/office/drawing/2014/main" id="{67430165-842A-5F14-A591-01F55A119BD9}"/>
-              </a:ext>
-            </a:extLst>
-          </p:cNvPr>
-          <p:cNvSpPr>
-            <a:spLocks noGrp="1"/>
-          </p:cNvSpPr>
-          <p:nvPr>
-            <p:ph idx="1"/>
-          </p:nvPr>
-        </p:nvSpPr>
-        <p:spPr/>
-        <p:txBody>
-          <a:bodyPr/>
-          <a:lstStyle/>
-          <a:p>
-            <a:r>
-              <a:rPr lang="en-US" sz="4000" b="1" dirty="0"/>
-              <a:t>Introduction to FMI</a:t>
-            </a:r>
-            <a:endParaRPr lang="en-US" dirty="0"/>
-          </a:p>
-        </p:txBody>
-      </p:sp>
-      <p:sp>
-        <p:nvSpPr>
-          <p:cNvPr id="4" name="Titel 3">
-            <a:extLst>
-              <a:ext uri="{FF2B5EF4-FFF2-40B4-BE49-F238E27FC236}">
-                <a16:creationId xmlns:a16="http://schemas.microsoft.com/office/drawing/2014/main" id="{B1C8FE56-2E01-097C-45C4-D3BC2A5ADD27}"/>
-              </a:ext>
-            </a:extLst>
-          </p:cNvPr>
-          <p:cNvSpPr>
-            <a:spLocks noGrp="1"/>
-          </p:cNvSpPr>
-          <p:nvPr>
-            <p:ph type="title"/>
-          </p:nvPr>
-        </p:nvSpPr>
-        <p:spPr/>
-        <p:txBody>
-          <a:bodyPr/>
-          <a:lstStyle/>
-          <a:p>
-            <a:r>
-              <a:rPr lang="en-US" dirty="0"/>
-              <a:t> </a:t>
-            </a:r>
-          </a:p>
-        </p:txBody>
-      </p:sp>
-      <p:pic>
-        <p:nvPicPr>
-          <p:cNvPr id="2" name="Picture 4">
-            <a:extLst>
-              <a:ext uri="{FF2B5EF4-FFF2-40B4-BE49-F238E27FC236}">
-                <a16:creationId xmlns:a16="http://schemas.microsoft.com/office/drawing/2014/main" id="{C6F665E4-16E4-89B7-F29E-C5589A9A5087}"/>
-              </a:ext>
-            </a:extLst>
-          </p:cNvPr>
-          <p:cNvPicPr>
-            <a:picLocks noChangeAspect="1"/>
-          </p:cNvPicPr>
-          <p:nvPr/>
-        </p:nvPicPr>
-        <p:blipFill>
-          <a:blip r:embed="rId2">
-            <a:extLst>
-              <a:ext uri="{28A0092B-C50C-407E-A947-70E740481C1C}">
-                <a14:useLocalDpi xmlns:a14="http://schemas.microsoft.com/office/drawing/2010/main" val="0"/>
-              </a:ext>
-            </a:extLst>
-          </a:blip>
-          <a:stretch>
-            <a:fillRect/>
-          </a:stretch>
-        </p:blipFill>
-        <p:spPr>
-          <a:xfrm>
-            <a:off x="620184" y="3130345"/>
-            <a:ext cx="5818812" cy="2378376"/>
-          </a:xfrm>
-          <a:prstGeom prst="rect">
-            <a:avLst/>
-          </a:prstGeom>
-        </p:spPr>
-      </p:pic>
-      <p:sp>
-        <p:nvSpPr>
-          <p:cNvPr id="3" name="TextBox 2">
-            <a:extLst>
-              <a:ext uri="{FF2B5EF4-FFF2-40B4-BE49-F238E27FC236}">
-                <a16:creationId xmlns:a16="http://schemas.microsoft.com/office/drawing/2014/main" id="{D9B8BF98-CDEA-294F-5A40-BA21B6EEF1E0}"/>
-              </a:ext>
-            </a:extLst>
-          </p:cNvPr>
-          <p:cNvSpPr txBox="1"/>
-          <p:nvPr/>
-        </p:nvSpPr>
-        <p:spPr>
-          <a:xfrm>
-            <a:off x="664119" y="2022364"/>
-            <a:ext cx="4823460" cy="646331"/>
-          </a:xfrm>
-          <a:prstGeom prst="rect">
-            <a:avLst/>
-          </a:prstGeom>
-          <a:noFill/>
-        </p:spPr>
-        <p:txBody>
-          <a:bodyPr wrap="square" rtlCol="0">
-            <a:spAutoFit/>
-          </a:bodyPr>
-          <a:lstStyle/>
-          <a:p>
-            <a:r>
-              <a:rPr lang="en-US" sz="1800" dirty="0">
-                <a:solidFill>
-                  <a:srgbClr val="5E676E"/>
-                </a:solidFill>
-                <a:latin typeface="+mn-lt"/>
-                <a:cs typeface="+mn-cs"/>
-              </a:rPr>
-              <a:t>Presenter:</a:t>
-            </a:r>
-            <a:br>
-              <a:rPr lang="en-US" sz="1800" dirty="0">
-                <a:solidFill>
-                  <a:srgbClr val="5E676E"/>
-                </a:solidFill>
-                <a:latin typeface="+mn-lt"/>
-                <a:cs typeface="+mn-cs"/>
-              </a:rPr>
-            </a:br>
-            <a:r>
-              <a:rPr lang="en-US" sz="1800" dirty="0">
-                <a:solidFill>
-                  <a:srgbClr val="5E676E"/>
-                </a:solidFill>
-                <a:latin typeface="+mn-lt"/>
-                <a:cs typeface="+mn-cs"/>
-              </a:rPr>
-              <a:t>Christian Bertsch, Bosch Research</a:t>
-            </a:r>
-          </a:p>
-        </p:txBody>
-      </p:sp>
-      <p:sp>
-        <p:nvSpPr>
-          <p:cNvPr id="7" name="TextBox 4">
-            <a:extLst>
-              <a:ext uri="{FF2B5EF4-FFF2-40B4-BE49-F238E27FC236}">
-                <a16:creationId xmlns:a16="http://schemas.microsoft.com/office/drawing/2014/main" id="{978ADD06-3B1E-7161-A229-C13B73EE0EAF}"/>
-              </a:ext>
-            </a:extLst>
-          </p:cNvPr>
-          <p:cNvSpPr txBox="1"/>
-          <p:nvPr/>
-        </p:nvSpPr>
-        <p:spPr>
-          <a:xfrm>
-            <a:off x="9619757" y="3586701"/>
-            <a:ext cx="2142256" cy="369332"/>
-          </a:xfrm>
-          <a:prstGeom prst="rect">
-            <a:avLst/>
-          </a:prstGeom>
-          <a:noFill/>
-        </p:spPr>
-        <p:txBody>
-          <a:bodyPr wrap="square" rtlCol="0">
-            <a:spAutoFit/>
-          </a:bodyPr>
-          <a:lstStyle/>
-          <a:p>
-            <a:r>
-              <a:rPr lang="en-US" sz="1800" dirty="0">
-                <a:solidFill>
-                  <a:srgbClr val="5E676E"/>
-                </a:solidFill>
-                <a:latin typeface="+mn-lt"/>
-                <a:cs typeface="+mn-cs"/>
-              </a:rPr>
-              <a:t>Online Materials:</a:t>
-            </a:r>
-          </a:p>
-        </p:txBody>
-      </p:sp>
-      <p:sp>
-        <p:nvSpPr>
-          <p:cNvPr id="10" name="TextBox 6">
-            <a:extLst>
-              <a:ext uri="{FF2B5EF4-FFF2-40B4-BE49-F238E27FC236}">
-                <a16:creationId xmlns:a16="http://schemas.microsoft.com/office/drawing/2014/main" id="{029415F6-21ED-FE69-17BC-A2F9B50AC688}"/>
-              </a:ext>
-            </a:extLst>
-          </p:cNvPr>
-          <p:cNvSpPr txBox="1"/>
-          <p:nvPr/>
-        </p:nvSpPr>
-        <p:spPr>
-          <a:xfrm>
-            <a:off x="9619757" y="5961260"/>
-            <a:ext cx="4823460" cy="738664"/>
-          </a:xfrm>
-          <a:prstGeom prst="rect">
-            <a:avLst/>
-          </a:prstGeom>
-          <a:noFill/>
-        </p:spPr>
-        <p:txBody>
-          <a:bodyPr wrap="square" rtlCol="0">
-            <a:spAutoFit/>
-          </a:bodyPr>
-          <a:lstStyle/>
-          <a:p>
-            <a:r>
-              <a:rPr lang="en-US" sz="1200" dirty="0">
-                <a:solidFill>
-                  <a:srgbClr val="5E676E"/>
-                </a:solidFill>
-                <a:latin typeface="+mn-lt"/>
-                <a:cs typeface="+mn-cs"/>
-                <a:hlinkClick r:id="rId3"/>
-              </a:rPr>
-              <a:t>https://github.com/modelica/</a:t>
-            </a:r>
-            <a:br>
-              <a:rPr lang="en-US" sz="1200" dirty="0">
-                <a:solidFill>
-                  <a:srgbClr val="5E676E"/>
-                </a:solidFill>
-                <a:latin typeface="+mn-lt"/>
-                <a:cs typeface="+mn-cs"/>
-                <a:hlinkClick r:id="rId3"/>
-              </a:rPr>
-            </a:br>
-            <a:r>
-              <a:rPr lang="en-US" sz="1200" dirty="0">
-                <a:solidFill>
-                  <a:srgbClr val="5E676E"/>
-                </a:solidFill>
-                <a:latin typeface="+mn-lt"/>
-                <a:cs typeface="+mn-cs"/>
-                <a:hlinkClick r:id="rId3"/>
-              </a:rPr>
-              <a:t>fmi-beginners-tutorial-2024/tree/main</a:t>
-            </a:r>
-            <a:endParaRPr lang="en-US" sz="1200" dirty="0">
-              <a:solidFill>
-                <a:srgbClr val="5E676E"/>
-              </a:solidFill>
-              <a:latin typeface="+mn-lt"/>
-              <a:cs typeface="+mn-cs"/>
-            </a:endParaRPr>
-          </a:p>
-          <a:p>
-            <a:endParaRPr lang="en-US" sz="1800" dirty="0">
-              <a:solidFill>
-                <a:srgbClr val="5E676E"/>
-              </a:solidFill>
-              <a:latin typeface="+mn-lt"/>
-              <a:cs typeface="+mn-cs"/>
-            </a:endParaRPr>
-          </a:p>
-        </p:txBody>
-      </p:sp>
-      <p:pic>
-        <p:nvPicPr>
-          <p:cNvPr id="11" name="Grafik 10">
-            <a:extLst>
-              <a:ext uri="{FF2B5EF4-FFF2-40B4-BE49-F238E27FC236}">
-                <a16:creationId xmlns:a16="http://schemas.microsoft.com/office/drawing/2014/main" id="{85547DFE-87A6-5D51-B6B2-16817869D8DB}"/>
-              </a:ext>
-            </a:extLst>
-          </p:cNvPr>
-          <p:cNvPicPr>
-            <a:picLocks noChangeAspect="1"/>
-          </p:cNvPicPr>
-          <p:nvPr/>
-        </p:nvPicPr>
-        <p:blipFill>
-          <a:blip r:embed="rId4">
-            <a:extLst>
-              <a:ext uri="{28A0092B-C50C-407E-A947-70E740481C1C}">
-                <a14:useLocalDpi xmlns:a14="http://schemas.microsoft.com/office/drawing/2010/main" val="0"/>
-              </a:ext>
-              <a:ext uri="{96DAC541-7B7A-43D3-8B79-37D633B846F1}">
-                <asvg:svgBlip xmlns:asvg="http://schemas.microsoft.com/office/drawing/2016/SVG/main" r:embed="rId5"/>
-              </a:ext>
-            </a:extLst>
-          </a:blip>
-          <a:stretch>
-            <a:fillRect/>
-          </a:stretch>
-        </p:blipFill>
-        <p:spPr>
-          <a:xfrm>
-            <a:off x="9787923" y="4049318"/>
-            <a:ext cx="1974090" cy="1974090"/>
-          </a:xfrm>
-          <a:prstGeom prst="rect">
-            <a:avLst/>
-          </a:prstGeom>
-        </p:spPr>
-      </p:pic>
-    </p:spTree>
-    <p:extLst>
-      <p:ext uri="{BB962C8B-B14F-4D97-AF65-F5344CB8AC3E}">
-        <p14:creationId xmlns:p14="http://schemas.microsoft.com/office/powerpoint/2010/main" val="3567263522"/>
-      </p:ext>
-    </p:extLst>
-  </p:cSld>
-  <p:clrMapOvr>
-    <a:masterClrMapping/>
-  </p:clrMapOvr>
-  <p:transition/>
-</p:sld>
-</file>
-
-<file path=ppt/slides/slide30.xml><?xml version="1.0" encoding="utf-8"?>
+<file path=ppt/slides/slide32.xml><?xml version="1.0" encoding="utf-8"?>
 <p:sld xmlns:a="http://schemas.openxmlformats.org/drawingml/2006/main" xmlns:r="http://schemas.openxmlformats.org/officeDocument/2006/relationships" xmlns:p="http://schemas.openxmlformats.org/presentationml/2006/main">
   <p:cSld>
     <p:spTree>
@@ -17053,7 +17331,7 @@
 </p:sld>
 </file>
 
-<file path=ppt/slides/slide31.xml><?xml version="1.0" encoding="utf-8"?>
+<file path=ppt/slides/slide33.xml><?xml version="1.0" encoding="utf-8"?>
 <p:sld xmlns:a="http://schemas.openxmlformats.org/drawingml/2006/main" xmlns:r="http://schemas.openxmlformats.org/officeDocument/2006/relationships" xmlns:p="http://schemas.openxmlformats.org/presentationml/2006/main">
   <p:cSld>
     <p:spTree>
@@ -17153,83 +17431,7 @@
             </a:pPr>
             <a:r>
               <a:rPr lang="en-US" dirty="0"/>
-              <a:t>FMI-Kit by Dassault </a:t>
-            </a:r>
-            <a:r>
-              <a:rPr lang="en-US" dirty="0" err="1"/>
-              <a:t>Systèms</a:t>
-            </a:r>
-            <a:r>
-              <a:rPr lang="en-US" dirty="0"/>
-              <a:t> </a:t>
-            </a:r>
-            <a:br>
-              <a:rPr lang="en-US" dirty="0"/>
-            </a:br>
-            <a:r>
-              <a:rPr lang="en-US" dirty="0"/>
-              <a:t>(</a:t>
-            </a:r>
-            <a:r>
-              <a:rPr lang="en-US" dirty="0">
-                <a:hlinkClick r:id="rId2"/>
-              </a:rPr>
-              <a:t>available on </a:t>
-            </a:r>
-            <a:r>
-              <a:rPr lang="en-US" dirty="0" err="1">
-                <a:hlinkClick r:id="rId2"/>
-              </a:rPr>
-              <a:t>Github</a:t>
-            </a:r>
-            <a:r>
-              <a:rPr lang="en-US" dirty="0"/>
-              <a:t>) </a:t>
-            </a:r>
-            <a:br>
-              <a:rPr lang="en-US" dirty="0"/>
-            </a:br>
-            <a:r>
-              <a:rPr lang="en-US" dirty="0"/>
-              <a:t>for older ML/SL version</a:t>
-            </a:r>
-          </a:p>
-          <a:p>
-            <a:pPr>
-              <a:buFont typeface="Wingdings" panose="05000000000000000000" pitchFamily="2" charset="2"/>
-              <a:buChar char="§"/>
-            </a:pPr>
-            <a:endParaRPr lang="en-US" dirty="0"/>
-          </a:p>
-          <a:p>
-            <a:pPr>
-              <a:buFont typeface="Wingdings" panose="05000000000000000000" pitchFamily="2" charset="2"/>
-              <a:buChar char="§"/>
-            </a:pPr>
-            <a:endParaRPr lang="en-US" dirty="0"/>
-          </a:p>
-          <a:p>
-            <a:pPr>
-              <a:buFont typeface="Wingdings" panose="05000000000000000000" pitchFamily="2" charset="2"/>
-              <a:buChar char="§"/>
-            </a:pPr>
-            <a:endParaRPr lang="en-US" dirty="0"/>
-          </a:p>
-          <a:p>
-            <a:pPr>
-              <a:buFont typeface="Wingdings" panose="05000000000000000000" pitchFamily="2" charset="2"/>
-              <a:buChar char="§"/>
-            </a:pPr>
-            <a:endParaRPr lang="en-US" dirty="0"/>
-          </a:p>
-          <a:p>
-            <a:pPr>
-              <a:buFont typeface="Wingdings" panose="05000000000000000000" pitchFamily="2" charset="2"/>
-              <a:buChar char="§"/>
-            </a:pPr>
-            <a:r>
-              <a:rPr lang="en-US" dirty="0"/>
-              <a:t>Native FMI import by Mathworks</a:t>
+              <a:t>FMI import by Mathworks</a:t>
             </a:r>
             <a:br>
               <a:rPr lang="en-US" dirty="0"/>
@@ -17256,15 +17458,15 @@
           <p:nvPr/>
         </p:nvPicPr>
         <p:blipFill>
-          <a:blip r:embed="rId3"/>
+          <a:blip r:embed="rId2"/>
           <a:stretch>
             <a:fillRect/>
           </a:stretch>
         </p:blipFill>
         <p:spPr>
           <a:xfrm>
-            <a:off x="8548099" y="3999913"/>
-            <a:ext cx="3110134" cy="2127356"/>
+            <a:off x="5276997" y="2470804"/>
+            <a:ext cx="4489171" cy="3070628"/>
           </a:xfrm>
           <a:prstGeom prst="rect">
             <a:avLst/>
@@ -17286,14 +17488,14 @@
           <p:nvPr/>
         </p:nvPicPr>
         <p:blipFill>
-          <a:blip r:embed="rId4"/>
+          <a:blip r:embed="rId3"/>
           <a:stretch>
             <a:fillRect/>
           </a:stretch>
         </p:blipFill>
         <p:spPr>
           <a:xfrm>
-            <a:off x="5926870" y="4026226"/>
+            <a:off x="2080734" y="2470804"/>
             <a:ext cx="2051155" cy="1714588"/>
           </a:xfrm>
           <a:prstGeom prst="rect">
@@ -17304,96 +17506,6 @@
               <a:schemeClr val="tx1"/>
             </a:solidFill>
           </a:ln>
-        </p:spPr>
-      </p:pic>
-      <p:pic>
-        <p:nvPicPr>
-          <p:cNvPr id="7" name="Grafik 7">
-            <a:extLst>
-              <a:ext uri="{FF2B5EF4-FFF2-40B4-BE49-F238E27FC236}">
-                <a16:creationId xmlns:a16="http://schemas.microsoft.com/office/drawing/2014/main" id="{7A00875A-75C9-3B0F-FB96-540C756A26AF}"/>
-              </a:ext>
-            </a:extLst>
-          </p:cNvPr>
-          <p:cNvPicPr>
-            <a:picLocks noChangeAspect="1"/>
-          </p:cNvPicPr>
-          <p:nvPr/>
-        </p:nvPicPr>
-        <p:blipFill>
-          <a:blip r:embed="rId5"/>
-          <a:stretch>
-            <a:fillRect/>
-          </a:stretch>
-        </p:blipFill>
-        <p:spPr>
-          <a:xfrm>
-            <a:off x="7978025" y="1519191"/>
-            <a:ext cx="1937640" cy="1567017"/>
-          </a:xfrm>
-          <a:prstGeom prst="rect">
-            <a:avLst/>
-          </a:prstGeom>
-        </p:spPr>
-      </p:pic>
-      <p:pic>
-        <p:nvPicPr>
-          <p:cNvPr id="8" name="Grafik 8">
-            <a:extLst>
-              <a:ext uri="{FF2B5EF4-FFF2-40B4-BE49-F238E27FC236}">
-                <a16:creationId xmlns:a16="http://schemas.microsoft.com/office/drawing/2014/main" id="{7830128B-820C-EB44-4EA5-25F584D5A997}"/>
-              </a:ext>
-            </a:extLst>
-          </p:cNvPr>
-          <p:cNvPicPr>
-            <a:picLocks noChangeAspect="1"/>
-          </p:cNvPicPr>
-          <p:nvPr/>
-        </p:nvPicPr>
-        <p:blipFill>
-          <a:blip r:embed="rId6"/>
-          <a:stretch>
-            <a:fillRect/>
-          </a:stretch>
-        </p:blipFill>
-        <p:spPr>
-          <a:xfrm>
-            <a:off x="5626462" y="1519191"/>
-            <a:ext cx="1984910" cy="1310731"/>
-          </a:xfrm>
-          <a:prstGeom prst="rect">
-            <a:avLst/>
-          </a:prstGeom>
-        </p:spPr>
-      </p:pic>
-      <p:pic>
-        <p:nvPicPr>
-          <p:cNvPr id="9" name="Grafik 8">
-            <a:extLst>
-              <a:ext uri="{FF2B5EF4-FFF2-40B4-BE49-F238E27FC236}">
-                <a16:creationId xmlns:a16="http://schemas.microsoft.com/office/drawing/2014/main" id="{4A4A5A1D-003C-1A8C-6FEA-445F04A9B857}"/>
-              </a:ext>
-            </a:extLst>
-          </p:cNvPr>
-          <p:cNvPicPr>
-            <a:picLocks noChangeAspect="1"/>
-          </p:cNvPicPr>
-          <p:nvPr/>
-        </p:nvPicPr>
-        <p:blipFill>
-          <a:blip r:embed="rId7"/>
-          <a:stretch>
-            <a:fillRect/>
-          </a:stretch>
-        </p:blipFill>
-        <p:spPr>
-          <a:xfrm>
-            <a:off x="10282318" y="1519191"/>
-            <a:ext cx="1497451" cy="1338897"/>
-          </a:xfrm>
-          <a:prstGeom prst="rect">
-            <a:avLst/>
-          </a:prstGeom>
         </p:spPr>
       </p:pic>
     </p:spTree>
@@ -17859,7 +17971,7 @@
             </a:pPr>
             <a:r>
               <a:rPr lang="en-US" dirty="0"/>
-              <a:t>2021: Release of FMI 3.0 </a:t>
+              <a:t>2022: Release of FMI 3.0 </a:t>
             </a:r>
           </a:p>
           <a:p>
@@ -19926,27 +20038,14 @@
 
 <file path=ppt/tags/tag1.xml><?xml version="1.0" encoding="utf-8"?>
 <p:tagLst xmlns:a="http://schemas.openxmlformats.org/drawingml/2006/main" xmlns:r="http://schemas.openxmlformats.org/officeDocument/2006/relationships" xmlns:p="http://schemas.openxmlformats.org/presentationml/2006/main">
-  <p:tag name="COLORSETGROUPCLASSNAME" val="ColorSetGroup4"/>
-  <p:tag name="COLORSETCLASSNAME" val="ColorSet2"/>
-  <p:tag name="AGTX" val="Example model: Controlled Motor Drive"/>
-  <p:tag name="SAXCONVERTED" val="2"/>
+  <p:tag name="EMPOWERCHARTSPROPERTIES_A_0" val="AAAAAAH//////////wEAAAAAAAAAAAAAACoqIFRoaXMgaXMgYSBMaXRlREIgZmlsZSAqKgcEAP////8FAAAAAQAAAAAAAAAAAAAAAAAAAAAAAAAAAAAAAAAAAAAAAAAAAAAAAAABEQAAAFByb3BlcnR5RG9jdW1lbnRzAgAAAAAAAAAAAAAAAAAAAAAAAAAAAAAAAAAAAAAAAAAAAAAAAAAAAAAAAAAAAAAAAAAAAAAAAAAAAAAAAAAAAAAAAAAAAAAAAAAAAAAAAAAAAAAAAAAAAAAAAAAAAAAAAAAAAAAAAAAAAAAAAAAAAAAAAAAAAAAAAAAAAAAAAAAAAAAAAAAAAAAAAAAAAAAAAAAAAAAAAAAAAAAAAAAAAAAAAAAAAAAAAAAAAAAAAAAAAAAAAAAAAAAAAAAAAAAAAAAAAAAAAAAAAAAAAAAAAAAAAAAAAAAAAAAAAAAAAAAAAAAAAAAAAAAAAAAAAAAAAAAAAAAAAAAAAAAAAAAAAAAAAAAAAAAAAAAAAAAAAAAAAAAAAAAAAAAAAAAAAAAAAAAAAAAAAAAAAAAAAAAAAAAAAAAAAAAAAAAAAAAAAAAAAAAAAAAAAAAAAAAAAAAAAAAAAAAAAAAAAAAAAAAAAAAAAAAAAAAAAAAAAAAAAAAAAAAAAAAAAAAAAAAAAAAAAAAAAAAAAAAAAAAAAAAAAAAAAAAAAAAAAAAAAAAAAAAAAAAAAAAAAAAAAAAAAAAAAAAAAAAAAAAAAAAAAAAAAAAAAAAAAAAAAAAAAAAAAAAAAAAAAAAAAAAAAAAAAAAAAAAAAAAAAAAAAAAAAAAAAAAAAAAAAAAAAAAAAAAAAAAAAAAAAAAAAAAAAAAAAAAAAAAAAAAAAAAAAAAAAAAAAAAAAAAAAAAAAAAAAAAAAAAAAAAAAAAAAAAAAAAAAAAAAAAAAAAAAAAAAAAAAAAAAAAAAAAAAAAAAAAAAAAAAAAAAAAAAAAAAAAAAAAAAAAAAAAAAAAAAAAAAAAAAAAAAAAAAAAAAAAAAAAAAAAAAAAAAAAAAAAAAAAAAAAAAAAAAAAAAAAAAAAAAAAAAAAAAAAAAAAAAAAAAAAAAAAAAAAAAAAAAAAAAAAAAAAAAAAAAAAAAAAAAAAAAAAAAAAAAAAAAAAAAAAAAAAAAAAAAAAAAAAAAAAAAAAAAAAAAAAAAAAAAAAAAAAAAAAAAAAAAAAAAAAAAAAAAAAAAAAAAAAAAAAAAAAAAAAAAAAAAAAAAAAAAAAAAAAAAAAAAAAAAAAAAAAAAAAAAAAAAAAAAAAAAAAAAAAAAAAAAAAAAAAAAAAAAAAAAAAAAAAAAAAAAAAAAAAAAAAAAAAAAAAAAAAAAAAAAAAAAAAAAAAAAAAAAAAAAAAAAAAAAAAAAAAAAAAAAAAAAAAAAAAAAAAAAAAAAAAAAAAAAAAAAAAAAAAAAAAAAAAAAAAAAAAAAAAAAAAAAAAAAAAAAAAAAAAAAAAAAAAAAAAAAAAAAAAAAAAAAAAAAAAAAAAAAAAAAAAAAAAAAAAAAAAAAAAAAAAAAAAAAAAAAAAAAAAAAAAAAAAAAAAAAAAAAAAAAAAAAAAAAAAAAAAAAAAAAAAAAAAAAAAAAAAAAAAAAAAAAAAAAAAAAAAAAAAAAAAAAAAAAAAAAAAAAAAAAAAAAAAAAAAAAAAAAAAAAAAAAAAAAAAAAAAAAAAAAAAAAAAAAAAAAAAAAAAAAAAAAAAAAAAAAAAAAAAAAAAAAAAAAAAAAAAAAAAAAAAAAAAAAAAAAAAAAAAAAAAAAAAAAAAAAAAAAAAAAAAAAAAAAAAAAAAAAAAAAAAAAAAAAAAAAAAAAAAAAAAAAAAAAAAAAAAAAAAAAAAAAAAAAAAAAAAAAAAAAAAAAAAAAAAAAAAAAAAAAAAAAAAAAAAAAAAAAAAAAAAAAAAAAAAAAAAAAAAAAAAAAAAAAAAAAAAAAAAAAAAAAAAAAAAAAAAAAAAAAAAAAAAAAAAAAAAAAAAAAAAAAAAAAAAAAAAAAAAAAAAAAAAAAAAAAAAAAAAAAAAAAAAAAAAAAAAAAAAAAAAAAAAAAAAAAAAAAAAAAAAAAAAAAAAAAAAAAAAAAAAAAAAAAAAAAAAAAAAAAAAAAAAAAAAAAAAAAAAAAAAAAAAAAAAAAAAAAAAAAAAAAAAAAAAAAAAAAAAAAAAAAAAAAAAAAAAAAAAAAAAAAAAAAAAAAAAAAAAAAAAAAAAAAAAAAAAAAAAAAAAAAAAAAAAAAAAAAAAAAAAAAAAAAAAAAAAAAAAAAAAAAAAAAAAAAAAAAAAAAAAAAAAAAAAAAAAAAAAAAAAAAAAAAAAAAAAAAAAAAAAAAAAAAAAAAAAAAAAAAAAAAAAAAAAAAAAAAAAAAAAAAAAAAAAAAAAAAAAAAAAAAAAAAAAAAAAAAAAAAAAAAAAAAAAAAAAAAAAAAAAAAAAAAAAAAAAAAAAAAAAAAAAAAAAAAAAAAAAAAAAAAAAAAAAAAAAAAAAAAAAAAAAAAAAAAAAAAAAAAAAAAAAAAAAAAAAAAAAAAAAAAAAAAAAAAAAAAAAAAAAAAAAAAAAAAAAAAAAAAAAAAAAAAAAAAAAAAAAAAAAAAAAAAAAAAAAAAAAAAAAAAAAAAAAAAAAAAAAAAAAAAAAAAAAAAAAAAAAAAAAAAAAAAAAAAAAAAAAAAAAAAAAAAAAAAAAAAAAAAAAAAAAAAAAAAAAAAAAAAAAAAAAAAAAAAAAAAAAAAAAAAAAAAAAAAAAAAAAAAAAAAAAAAAAAAAAAAAAAAAAAAAAAAAAAAAAAAAAAAAAAAAAAAAAAAAAAAAAAAAAAAAAAAAAAAAAAAAAAAAAAAAAAAAAAAAAAAAAAAAAAAAAAAAAAAAAAAAAAAAAAAAAAAAAAAAAAAAAAAAAAAAAAAAAAAAAAAAAAAAAAAAAAAAAAAAAAAAAAAAAAAAAAAAAAAAAAAAAAAAAAAAAAAAAAAAAAAAAAAAAAAAAAAAAAAAAAAAAAAAAAAAAAAAAAAAAAAAAAAAAAAAAAAAAAAAAAAAAAAAAAAAAAAAAAAAAAAAAAAAAAAAAAAAAAAAAAAAAAAAAAAAAAAAAAAAAAAAAAAAAAAAAAAAAAAAAAAAAAAAAAAAAAAAAAAAAAAAAAAAAAAAAAAAAAAAAAAAAAAAAAAAAAAAAAAAAAAAAAAAAAAAAAAAAAAAAAAAAAAAAAAAAAAAAAAAAAAAAAAAAAAAAAAAAAAAAAAAAAAAAAAAAAAAAAAAAAAAAAAAAAAAAAAAAAAAAAAAAAAAAAAAAAAAAAAAAAAAAAAAAAAAAAAAAAAAAAAAAAAAAAAAAAAAAAAAAAAAAAAAAAAAAAAAAAAAAAAAAAAAAAAAAAAAAAAAAAAAAAAAAAAAAAAAAAAAAAAAAAAAAAAAAAAAAAAAAAAAAAAAAAAAAAAAAAAAAAAAAAAAAAAAAAAAAAAAAAAAAAAAAAAAAAAAAAAAAAAAAAAAAAAAAAAAAAAAAAAAAAAAAAAAAAAAAAAAAAAAAAAAAAAAAAAAAAAAAAAAAAAAAAAAAAAAAAAAAAAAAAAAAAAAAAAAAAAAAAAAAAAAAAAAAAAAAAAAAAAAAAAAAAAAAAAAAAAAAAAAAAAAAAAAAAAAAAAAAAAAAAAAAAAAAAAAAAAAAAAAAAAAAAAAAAAAAAAAAAAAAAAAAAAAAAAAAAAAAAAAAAAAAAAAAAAAAAAAAAAAAAAAAAAAAAAAAAAAAAAAAAAAAAAAAAAAAAAAAAAAAAAAAAAAAAAAAAAAAAAAAAAAAAAAAAAAAAAAAAAAAAAAAAAAAAAAAAAAAAAAAAAAAAAAAAAAAAAAAAAAAAAAAAAAAAAAAAAAAAAAAAAAAAAAAAAAAAAAAAAAAAAAAAAAAAAAAAAAAAAAAAAAAAAAAAAAAAAAAAAAAAAAAAAAAAAAAAAAAAAAAAAAAAAAAAAAAAAAAAAAAAAAAAAAAAAAAAAAAAAAAAAAAAAAAAAAAAAAAAAAAAAAAAAAAAAAAAAAAAAAAAAAAAAAAAAAAAAAAAAAAAAAAAAAAAAAAAAAAAAAAAAAAAAAAAAAAAAAAAAAAAAAAAAAAAAAAAAAAAAAAAAAAAAAAAAAAAAAAAAAAAAAAAAAAAAAAAAAAAAAAAAAAAAAAAAAAAAAAAAAAAAAAAAAAAAAAAAAAAAAAAAAAAAAAAAAAAAAAAAAAAAAAAAAAAAAAAAAAAAAAAAAAAAAAAAAAAAAAAAAAAAAAAAAAAAAAAAAAAAAAAAAAAAAAAAAAAAAAAAAAAAAAAAAAAAAAAAAAAAAAAAAAAAAAAAAAAAAAAAAAAAAAAAAAAAAAAAAAAAAAAAAAAAAAAAAAAAAAAAAAAAAAAAAAAAAAAAAAAAAAAAAAAAAAAAAAAAAAAAAAAAAAAAAAAAAAAAAAAAAAAAAAAAAAAAAAAAAAAAAAAAAAAAAAAAAAAAAAAAAAAAAAAAAAAAAAAAAAAAAAAAAAAAAAAAAAAAAAAAAAAAAAAAAAAAAAAAAAAAAAAAAAAAAAAAAAAAAAAAAAAAAAAAAAAAAAAAAAAAAAAAAAAAAAAAAAAAAAAAAAAAAAAAAAAAAAAAAAAAAAAAAAAAAAAAAAAAAAAAAAAAAAAAAAAAAAAAAAAAAAAAAAAAAAAAAAAAAAAAAAAAAAAAAAAAAAAAAAAAAAAAAAAAAAAAAAAAAAAAAAAAAAAAAAAAAAAAAAAAAAAAAAAAAAAAAAAAAAAAAAAAAAAAAAAAAAAAAAAAAAAAAAAAAAAAAAAAAAAAAAAAAAAAAAAAAAAAAAAAAAAAAAAAAAAAAAAAAAAAAAAAAAAAAAAAAAAAAAAAAAAAAAAAAAAAAAAAAAAAAAAAAAAAAAAAAAAAAAAAAAAAAAAAAAAAAAAAAAAAAAAAAAAAAAAAAAAAAAAAAAAAAAAAAAAAAAAAAAAAAAAAAAAAAAAAAAAAAAAAAAAAAAAAAAAAAAAAAAAAAAAAAAAAAAAAAAAAAAAAAAAAAAAAAAAAAAAAAAAAAAAAAAAAAAAAAAAAAAAAAAAAAAAAAAAAAAAAAAAAAAAAAAAAAAAAAAAAAAAAAAAAAAAAAAAAAAAAAAAAAAAAAAAAAAAAAAAAAAAAAAAAAAAAAAAAAAAAAAAAAAAAAAAAAAAAAAAAAAAAAAAAAAAAAAAAAAAAAAAAAAAAAAAAAAAAAAAAAAAAAAAAAAAAAAAAAAAAAAAAAAAAAAAAAAAAAAAAAAAAAAAAAAAAAAAAAAAAAAAAAAAAAAAAAAAAAAAAAAAAAAAAAAAAAAAAAAAAAAAAAAAAAAAAAAAAAAAAAAAAAAAAAAAAAAAAAAAAAAAAAAAAAAAAAAAAAAAAAAAAAAAAAAAAAAAAAAAAAAAAAAAAAAAAAAAAAAAAAAAAAAAAAAAAAAAAAAAAAAAAAAAAAAAAAAAAAAAAAAAAAAAAAAAAAAAAAAAAAAAAAAAAAAAAAAAAAAAAAAAAAAAAAAAAAAAAAAAAAAAAAAAAAAAAAAAAAAAAAAAAAAAAAAAAAAAAAAAAAAAAAAAAAAAAAAAAAAAAAAAAAAAAAAAAAAAAAAAAAAAAAAAAAAAAAAAAAAAAAAAAAAAAAAAAAAAAAAAAAAAAAAAAAAAAAAAAAAAAAAAAAAAAAAAAAAAAAAAAAAAAAAAAAAAAAAAAAAAAAAAAAAAAAAAAAAAAAAAAAAAAAAAAAAAAAAAAAAAAAAAAAAAAAAAAAAAAAAAAAAAAAAAAAAAAAAAAAAAAAAAAAAAAAAAAAAAAAAAAAAAAAAAAAAAAAAAAAAAAAAAAAAAAAAAAAAAAAAAAAAAAAAAAAAAAAAAAAAAAAAAAAAAAAAAAAAAAAAAAAAAAAAAAAAAAAAAAAAAAAAAAAAAAAAAAAAAAAAAAAAAAAAAAAAAAAAAAAAAAAAAAAAAAAAAAAAAAAAAAAAAAAAAAAAAAAAAAAAAAAAAAAAAAAAAAAAAAAAAAAAAAAAAAAAAAAAAAAAAAAAAAAAAAAAAAAAAAAAAAAAAAAAAAAAAAAAAAAAAAAAAAAAAAAAAAAAAAAAAAAAAAAAAAAAAAAAAAAAAAAAAAAAAAAAAAAAAAAAAAAAAAAAAAAAAAAAAAAAAAAAAAAAAAAAAAAAAAAAAAAAAAAAAAAAAAAAAAAAAAAAAAAAAAAAAAAAAAAAAAAAAAAAAAAAAAAAAAAAAAAAAAAAAAAAAAAAAAAAAAAAAAAAAAAAAAAAAAAAAAAAAAAAAAAAAAAAAAAAAAAAAAAAAAAAAAAAAAAAAAAAAAAAAAAAAAAAAAAAAAAAAAAAAAAAAAAAAAAAAAAAAAAAAAAAAAAAAAAAAAAAAAAAAAAAAAAAAAAAAAAAAAAAAAAAAAAAAAAAAAAAAAAAAAAAAAAAAAAAAAAAAAAAAAAAAAAAAAAAAAAAAAAAAAAAAAAAAAAAAAAAAAAAAAAAAAAAAAAAAAAAAAAAAAAAAAAAAAAAAAAAAAAAAAAAAAAAAAAAAAAAAAAAAAAAAAAAAAAAAAAAAAAAAAAAAAAAAAAAAAAAAAAAAAAAAAAAAAAAAAAAAAAAAAAAAAAAAAAAAAAAAAAAAAAAAAAAAAAAAAAAAAAAAAAAAAAAAAAAAAAAAAAAAAAAAAAAAAAAAAAAAAAAAAAAAAAAAAAAAAAAAAAAAAAAAAAAAAAAAAAAAAAAAAAAAAAAAAAAAAAAAAAAAAAAAAAAAAAAAAAAAAAAAAAAAAAAAAAAAAAAAAAAAAAAAAAAAAAAAAAAAAAAAAAAAAAAAAAAAAAAAAAAAAAAAAAAAAAAAAAAAAAAAAAAAAAAAAAAAAAAAAAAAAAAAAAAAAAAAAAAAAAAAAAAAAAAAAAAAAAAAAAAAAAAAAAAAAAAAAAAAAAAAAAAAAAAAAAAAAAAAAAAAAAAAAAAAAAAAAAAAAAAAAAAAAAAAAAAAAAAAAAAAAAAAAAAAAAAAAAAAAAAAAAAAAAAAAAAAAAAAAAAAAAAAAAAAAAAAAAAAAAAAAAAAAAAAAAAAAAAAAAAAAAAAAAAAAAAAAAAAAAAAAAAAAAAAAAAAAAAAAAAAAAAAAAAAAAAAAAAAAAAAAAAAAAAAAAAAAAAAAAAAAAAAAAAAAAAAAAAAAAAAAAAAAAAAAAAAAAAAAAAAAAAAAAAAAAAAAAAAAAAAAAAAAAAAAAAAAAAAAAAAAAAAAAAAAAAAAAAAAAAAAAAAAAAAAAAAAAAAAAAAAAAAAAAAAAAAAAAAAAAAAAAAAAAAAAAAAAAAAAAAAAAAAAAAAAAAAAAAAAAAAAAAAAAAAAAAAAAAAAAAAAAAAAAAAAAAAAAAAAAAAAAAAAAAAAAAAAAAAAAAAAAAAAAAAAAAAAAAAAAAAAAAAAAAAAAAAAAAAAAAAAAAAAAAAAAAAAAAAAAAAAAAAAAAAAAAAAAAAAAAAAAAAAAAAAAAAAAAAAAAAAAAAAAAAAAAAAAAAAAAAAAAAAAAAAAAAAAAAAAAAAAAAAAAAAAAAAAAAAAAAAAAAAAAAAAAAAAAAAAAAAAAAAAAAAAAAAAAAAAAAAAAAAAAAAAAAAAAAAAAAAAAAAAAAAAAAAAAAAAAAAAAAAAAAAAAAAAAAAAAAAAAAAAAAAAAAAAAAAAAAAAAAAAAAAAAAAAAAAAAAAAAAAAAAAAAAAAAAAAAAAAAAAAAAAAAAAAAAAAAAAAAAAAAAAAAAAAAAAAAAAAAAAAAAAAAAAAAAAAAAAAAAAAAAAAAAAAAAAAAAAAAAAAAAAAAAAAAAAAAAAAAAAAAAAAAAAAAAAAAAAAAAAAAAAAAAAAAAAAAAAAAAAAAAAAAAAAAAAAAAAAAAAAAAAAAAAAAAAAAAAAAAAAAAAAAAAAAAAAAAAAAAAAAAAAAAAAAAAAAAAAAAAAAAAAAAAAAAAAAAAAAAAAAAAAAAAAAAAAAAAAAAAAAAAAAAAAAAAAAAAAAAAAAAAAAAAAAAAAAAAAAAAAAAAAAAAAAAAAAAAAAAAAAAAAAAAAAAAAAAAAAAAAAAAAAAAAAAAAAAAAAAAAAAAAAAAAAAAAAAAAAAAAAAAAAAAAAAAAAAAAAAAAAAAAAAAAAAAAAAAAAAAAAAAAAAAAAAAAAAAAAAAAAAAAAAAAAAAAAAAAAAAAAAAAAAAAAAAAAAAAAAAAAAAAAAAAAAAAAAAAAAAAAAAAAAAAAAAAAAAAAAAAAAAAAAAAAAAAAAAAAAAAAAAAAAAAAAAAAAAAAAAAAAAAAAAAAAAAAAAAAAAAAAAAAAAAAAAAAAAAAAAAAAAAAAAAAAAAAAAAAAAAAAAAAAAAAAAAAAAAAAAAAAAAAAAAAAAAAAAAAAAAAAAAAAAAAAAAAAAAAAAAAAAAAAAAAAAAAAAAAAAAAAAAAAAAAAAAAAAAAAAAAAAAAAAAAAAAAAAAAAAAAAAAAAAAAAAAAAAAAAAAAAAAAAAAAAAAAAAAAAAAAAAAAAAAAAAAAAAAAAAAAAAAAAAAAAAAAAAAAAAAAAAAAAAAAAAAAAAAAAAAAAAAAAAAAAAAAAAAAAAAAAAAAAAAAAAAAAAAAAAAAAAAAAAAAAAAAAAAAAAAAAAAAAAAAAAAAAAAAAAAAAAAAAAAAAAAAAAAAAAAAAAAAAAAAAAAAAAAAAAAAAAAAAAAAAAAAAAAAAAAAAAAAAAAAAAAAAAAAAAAAAAAAAAAAAAAAAAAAAAAAAAAAAAAAAAAAAAAAAAAAAAAAAAAAAAAAAAAAAAAAAAAAAAAAAAAAAAAAAAAAAAAAAAAAAAAAAAAAAAAAAAAAAAAAAAAAAAAAAAAAAAAAAAAAAAAAAAAAAAAAAAAAAAAAAAAAAAAAAAAAAAAAAAAAAAAAAAAAAAAAAAAAAAAAAAAAAAAAAAAAAAAAAAAAAAAAAAAAAAAAAAAAAAAAAAAAAAAAAAAAAAAAAAAAAAAAAAAAAAAAAAAAAAAAAAAAAAAAAAAAAAAAAAAAAAAAAAAAAAAAAAAAAAAAAAAAAAAAAAAAAAAAAAAAAAAAAAAAAAAAAAAAAAAAAAAAAAAAAAAAAAAAAAAAAAAAAAAAAAAAAAAAAAAAAAAAAAAAAAAAAAAAAAAAAAAAAAAAAAAAAAAAAAAAAAAAAAAAAAAAAAAAAAAAAAAAAAAAAAAAAAAAAAAAAAAAAAAAAAAAAAAAAAAAAAAAAAAAAAAAAAAAAAAAAAAAAAAAAAAAAAAAAAAAAAAAAAAAAAAAAAAAAAAAAAAAAAAAAAAAAAAAAAAAAAAAAAAAAAAAAAAAAAAAAAAAAAAAAAAAAAAAAAAAAAAAAAAAAAAAAAAAAAAAAAAAAAAAAAAAAAAAAAAAAAAAAAAAAAAAAAAAAAAAAAAAAAAAAAAAAAAAAAAAAAAAAAAAAAAAAAAAAAAAAAAAAAAAAAAAAAAAAAAAAAAAAAAAAAAAAAAAAAAAAAAAAAAAAAAAAAAAAAAAAAAAAAAAAAAAAAAAAAAAAAAAAAAAAAAAAAAAAAAAAAAAAAAAAAAAAAAAAAAAAAAAAAAAAAAAAAAAAAAAAAAAAAAAAAAAAAAAAAAAAAAAAAAAAAAAAAAAAAAAAAAAAAAAAAAAAAAAAAAAAAAAAAAAAAAAAAAAAAAAAAAAAAAAAAAAAAAAAAAAAAAAAAAAAAAAAAAAAAAAAAAAAAAAAAAAAAAAAAAAAAAAAAAAAAAAAAAAAAAAAAAAAAAAAAAAAAAAAAAAAAAAAAAAAAAAAAAAAAAAAAAAAAAAAAAAAAAAAAAAAAAAAAAAAAAAAAAAAAAAAAAAAAAAAAAAAAAAAAAAAAAAAAAAAAAAAAAAAAAAAAAAAAAAAAAAAAAAAAAAAAAAAAAAAAAAAAAAAAAAAAAAAAAAAAAAAAAAAAAAAAAAAAAAAAAAAAAAAAAAAAAAAAAAAAAAAAAAAAAAAAAAAAAAAAAAAAAAAAAAAAAAAAAAAAAAAAAAAAAAAAAAAAAAAAAAAAAAAAAAAAAAAAAAAAAAAAAAAAAAAAAAAAAAAAAAAAAAAAAAAAAAAAAAAAAAAAAAAAAAAAAAAAAAAAAAAAAAAAAAAAAAAAAAAAAAAAAAAAAAAAAAAAAAAAAAAAAAAAAAAAAAAAAAAAAAAAAAAAAAAAAAAAAAAAAAAAAAAAAAAAAAAAAAAAAAAAAAAAAAAAAAAAAAAAAAAAAAAAAAAAAAAAAAAAAAAAAAAAAAAAAAAAAAAAAAAAAAAAAAAAAAAAAAAAAAAAAAAAAAAAAAAAAAAAAAAAAAAAAAAAAAAAAAAAAAAAAAAAAAAAAAAAAAAAAAAAAAAAAAAAAAAAAAAAAAAAAAAAAAAAAAAAAAAAAAAAAAAAAAAAAAAAAAAAAAAAAAAAAAAAAAAAAAAAAAAAAAAAAAAAAAAAAAAAAAAAAAAAAAAAAAAAAAAAAAAAAAAAAAAAAAAAAAAAAAAAAAAAAAAAAAAAAAAAAAAAAAAAAAAAAAAAAAAAAAAAAAAAAAAAAAAAAAAAAAAAAAAAAAAAAAAAAAAAAAAAAAAAAAAAAAAAAAAAAAAAAAAAAAAAAAAAAAAAAAAAAAAAAAAAAAAAAAAAAAAAAAAAAAAAAAAAAAAAAAAAAAAAAAAAAAAAAAAAAAAAAAAAAAAAAAAAAAAAAAAAAAAAAAAAAAAAAAAAAAAAAAAAAAAAAAAAAAAAAAAAAAAAAAAAAAAAAAAAAAAAAAAAAAAAAAAAAAAAAAAAAAAAAAAAAAAAAAAAAAAAAAAAAAAAAAAAAAAAAAAAAAAAAAAAAAAAAAAAAAAAAAAAAAAAAAAAAAAAAAAAAAAAAAAAAAAAAAAAAAAAAAAAAAAAAAAAAAAAAAAAAAAAAAAAAAAAAAAAAAAAAAAAAAAAAAAAAAAAAAAAAAAAAAAAAAAAAAAAAAAAAAAAAAAAAAAAAAAAAAAAAAAAAAAAAAAAAAAAAAAAAAAAAAAAACAAAAAv//////////AQAAAAAAAAAAAAAAEQAAAFByb3BlcnR5RG9jdW1lbnRzAgAAAAAAAAAEAAAACQAAAF9pZD0kLl9pZAEDAAAAAAADAAAAAQADAAAAIwAAAENvbWJpSW5kZXg9JC5OYW1lICsgJ18nICsgJC5WZXJzaW9uAQUAAAAAAAUAAAABAAUAAAAAAAAAAP///////wAAAAAAAP////8AAAAAAP///////wAAAAAAAP////8AAAAAAP///////wAAAAAAAP////8AAAAAAP///////wAAAAAAAP////8AAAAAAP///////wAAAAAAAP////8AAAAAAP///////wAAAAAAAP////8AAAAAAP///////wAAAAAAAP////8AAAAAAP///////wAAAAAAAP////8AAAAAAP///////wAAAAAAAP////8AAAAAAP///////wAAAAAAAP////8AAAAAAP///////wAAAAAAAP////8AAAAAAP///////wAAAAAAAP////8AAAAAAP///////wAAAAAAAP////8AAAAAAP///////wAAAAAAAP////8AAAAAAAAAAAAAAAAAAAAAAAAAAAAAAAAAAAAAAAAAAAAAAAAAAAAAAAAAAAAAAAAAAAAAAAAAAAAAAAAAAAAAAAAAAAAAAAAAAAAAAAAAAAAAAAAAAAAAAAAAAAAAAAAAAAAAAAAAAAAAAAAAAAAAAAAAAAAAAAAAAAAAAAAAAAAAAAAAAAAAAAAAAAAAAAAAAAAAAAAAAAAAAAAAAAAAAAAAAAAAAAAAAAAAAAAAAAAAAAAAAAAAAAAAAAAAAAAAAAAAAAAAAAAAAAAAAAAAAAAAAAAAAAAAAAAAAAAAAAAAAAAAAAAAAAAAAAAAAAAAAAAAAAAAAAAAAAAAAAAAAAAAAAAAAAAAAAAAAAAAAAAAAAAAAAAAAAAAAAAAAAAAAAAAAAAAAAAAAAAAAAAAAAAAAAAAAAAAAAAAAAAAAAAAAAAAAAAAAAAAAAAAAAAAAAAAAAAAAAAAAAAAAAAAAAAAAAAAAAAAAAAAAAAAAAAAAAAAAAAAAAAAAAAAAAAAAAAAAAAAAAAAAAAAAAAAAAAAAAAAAAAAAAAAAAAAAAAAAAAAAAAAAAAAAAAAAAAAAAAAAAAAAAAAAAAAAAAAAAAAAAAAAAAAAAAAAAAAAAAAAAAAAAAAAAAAAAAAAAAAAAAAAAAAAAAAAAAAAAAAAAAAAAAAAAAAAAAAAAAAAAAAAAAAAAAAAAAAAAAAAAAAAAAAAAAAAAAAAAAAAAAAAAAAAAAAAAAAAAAAAAAAAAAAAAAAAAAAAAAAAAAAAAAAAAAAAAAAAAAAAAAAAAAAAAAAAAAAAAAAAAAAAAAAAAAAAAAAAAAAAAAAAAAAAAAAAAAAAAAAAAAAAAAAAAAAAAAAAAAAAAAAAAAAAAAAAAAAAAAAAAAAAAAAAAAAAAAAAAAAAAAAAAAAAAAAAAAAAAAAAAAAAAAAAAAAAAAAAAAAAAAAAAAAAAAAAAAAAAAAAAAAAAAAAAAAAAAAAAAAAAAAAAAAAAAAAAAAAAAAAAAAAAAAAAAAAAAAAAAAAAAAAAAAAAAAAAAAAAAAAAAAAAAAAAAAAAAAAAAAAAAAAAAAAAAAAAAAAAAAAAAAAAAAAAAAAAAAAAAAAAAAAAAAAAAAAAAAAAAAAAAAAAAAAAAAAAAAAAAAAAAAAAAAAAAAAAAAAAAAAAAAAAAAAAAAAAAAAAAAAAAAAAAAAAAAAAAAAAAAAAAAAAAAAAAAAAAAAAAAAAAAAAAAAAAAAAAAAAAAAAAAAAAAAAAAAAAAAAAAAAAAAAAAAAAAAAAAAAAAAAAAAAAAAAAAAAAAAAAAAAAAAAAAAAAAAAAAAAAAAAAAAAAAAAAAAAAAAAAAAAAAAAAAAAAAAAAAAAAAAAAAAAAAAAAAAAAAAAAAAAAAAAAAAAAAAAAAAAAAAAAAAAAAAAAAAAAAAAAAAAAAAAAAAAAAAAAAAAAAAAAAAAAAAAAAAAAAAAAAAAAAAAAAAAAAAAAAAAAAAAAAAAAAAAAAAAAAAAAAAAAAAAAAAAAAAAAAAAAAAAAAAAAAAAAAAAAAAAAAAAAAAAAAAAAAAAAAAAAAAAAAAAAAAAAAAAAAAAAAAAAAAAAAAAAAAAAAAAAAAAAAAAAAAAAAAAAAAAAAAAAAAAAAAAAAAAAAAAAAAAAAAAAAAAAAAAAAAAAAAAAAAAAAAAAAAAAAAAAAAAAAAAAAAAAAAAAAAAAAAAAAAAAAAAAAAAAAAAAAAAAAAAAAAAAAAAAAAAAAAAAAAAAAAAAAAAAAAAAAAAAAAAAAAAAAAAAAAAAAAAAAAAAAAAAAAAAAAAAAAAAAAAAAAAAAAAAAAAAAAAAAAAAAAAAAAAAAAAAAAAAAAAAAAAAAAAAAAAAAAAAAAAAAAAAAAAAAAAAAAAAAAAAAAAAAAAAAAAAAAAAAAAAAAAAAAAAAAAAAAAAAAAAAAAAAAAAAAAAAAAAAAAAAAAAAAAAAAAAAAAAAAAAAAAAAAAAAAAAAAAAAAAAAAAAAAAAAAAAAAAAAAAAAAAAAAAAAAAAAAAAAAAAAAAAAAAAAAAAAAAAAAAAAAAAAAAAAAAAAAAAAAAAAAAAAAAAAAAAAAAAAAAAAAAAAAAAAAAAAAAAAAAAAAAAAAAAAAAAAAAAAAAAAAAAAAAAAAAAAAAAAAAAAAAAAAAAAAAAAAAAAAAAAAAAAAAAAAAAAAAAAAAAAAAAAAAAAAAAAAAAAAAAAAAAAAAAAAAAAAAAAAAAAAAAAAAAAAAAAAAAAAAAAAAAAAAAAAAAAAAAAAAAAAAAAAAAAAAAAAAAAAAAAAAAAAAAAAAAAAAAAAAAAAAAAAAAAAAAAAAAAAAAAAAAAAAAAAAAAAAAAAAAAAAAAAAAAAAAAAAAAAAAAAAAAAAAAAAAAAAAAAAAAAAAAAAAAAAAAAAAAAAAAAAAAAAAAAAAAAAAAAAAAAAAAAAAAAAAAAAAAAAAAAAAAAAAAAAAAAAAAAAAAAAAAAAAAAAAAAAAAAAAAAAAAAAAAAAAAAAAAAAAAAAAAAAAAAAAAAAAAAAAAAAAAAAAAAAAAAAAAAAAAAAAAAAAAAAAAAAAAAAAAAAAAAAAAAAAAAAAAAAAAAAAAAAAAAAAAAAAAAAAAAAAAAAAAAAAAAAAAAAAAAAAAAAAAAAAAAAAAAAAAAAAAAAAAAAAAAAAAAAAAAAAAAAAAAAAAAAAAAAAAAAAAAAAAAAAAAAAAAAAAAAAAAAAAAAAAAAAAAAAAAAAAAAAAAAAAAAAAAAAAAAAAAAAAAAAAAAAAAAAAAAAAAAAAAAAAAAAAAAAAAAAAAAAAAAAAAAAAAAAAAAAAAAAAAAAAAAAAAAAAAAAAAAAAAAAAAAAAAAAAAAAAAAAAAAAAAAAAAAAAAAAAAAAAAAAAAAAAAAAAAAAAAAAAAAAAAAAAAAAAAAAAAAAAAAAAAAAAAAAAAAAAAAAAAAAAAAAAAAAAAAAAAAAAAAAAAAAAAAAAAAAAAAAAAAAAAAAAAAAAAAAAAAAAAAAAAAAAAAAAAAAAAAAAAAAAAAAAAAAAAAAAAAAAAAAAAAAAAAAAAAAAAAAAAAAAAAAAAAAAAAAAAAAAAAAAAAAAAAAAAAAAAAAAAAAAAAAAAAAAAAAAAAAAAAAAAAAAAAAAAAAAAAAAAAAAAAAAAAAAAAAAAAAAAAAAAAAAAAAAAAAAAAAAAAAAAAAAAAAAAAAAAAAAAAAAAAAAAAAAAAAAAAAAAAAAAAAAAAAAAAAAAAAAAAAAAAAAAAAAAAAAAAAAAAAAAAAAAAAAAAAAAAAAAAAAAAAAAAAAAAAAAAAAAAAAAAAAAAAAAAAAAAAAAAAAAAAAAAAAAAAAAAAAAAAAAAAAAAAAAAAAAAAAAAAAAAAAAAAAAAAAAAAAAAAAAAAAAAAAAAAAAAAAAAAAAAAAAAAAAAAAAAAAAAAAAAAAAAAAAAAAAAAAAAAAAAAAAAAAAAAAAAAAAAAAAAAAAAAAAAAAAAAAAAAAAAAAAAAAAAAAAAAAAAAAAAAAAAAAAAAAAAAAAAAAAAAAAAAAAAAAAAAAAAAAAAAAAAAAAAAAAAAAAAAAAAAAAAAAAAAAAAAAAAAAAAAAAAAAAAAAAAAAAAAAAAAAAAAAAAAAAAAAAAAAAAAAAAAAAAAAAAAAAAAAAAAAAAAAAAAAAAAAAAAAAAAAAAAAAAAAAAAAAAAAAAAAAAAAAAAAAAAAAAAAAAAAAAAAAAAAAAAAAAAAAAAAAAAAAAAAAAAAAAAAAAAAAAAAAAAAAAAAAAAAAAAAAAAAAAAAAAAAAAAAAAAAAAAAAAAAAAAAAAAAAAAAAAAAAAAAAAAAAAAAAAAAAAAAAAAAAAAAAAAAAAAAAAAAAAAAAAAAAAAAAAAAAAAAAAAAAAAAAAAAAAAAAAAAAAAAAAAAAAAAAAAAAAAAAAAAAAAAAAAAAAAAAAAAAAAAAAAAAAAAAAAAAAAAAAAAAAAAAAAAAAAAAAAAAAAAAAAAAAAAAAAAAAAAAAAAAAAAAAAAAAAAAAAAAAAAAAAAAAAAAAAAAAAAAAAAAAAAAAAAAAAAAAAAAAAAAAAAAAAAAAAAAAAAAAAAAAAAAAAAAAAAAAAAAAAAAAAAAAAAAAAAAAAAAAAAAAAAAAAAAAAAAAAAAAAAAAAAAAAAAAAAAAAAAAAAAAAAAAAAAAAAAAAAAAAAAAAAAAAAAAAAAAAAAAAAAAAAAAAAAAAAAAAAAAAAAAAAAAAAAAAAAAAAAAAAAAAAAAAAAAAAAAAAAAAAAAAAAAAAAAAAAAAAAAAAAAAAAAAAAAAAAAAAAAAAAAAAAAAAAAAAAAAAAAAAAAAAAAAAAAAAAAAAAAAAAAAAAAAAAAAAAAAAAAAAAAAAAAAAAAAAAAAAAAAAAAAAAAAAAAAAAAAAAAAAAAAAAAAAAAAAAAAAAAAAAAAAAAAAAAAAAAAAAAAAAAAAAAAAAAAAAAAAAAAAAAAAAAAAAAAAAAAAAAAAAAAAAAAAAAAAAAAAAAAAAAAAAAAAAAAAAAAAAAAAAAAAAAAAAAAAAAAAAAAAAAAAAAAAAAAAAAAAAAAAAAAAAAAAAAAAAAAAAAAAAAAAAAAAAAAAAAAAAAAAAAAAAAAAAAAAAAAAAAAAAAAAAAAAAAAAAAAAAAAAAAAAAAAAAAAAAAAAAAAAAAAAAAAAAAAAAAAAAAAAAAAAAAAAAAAAAAAAAAAAAAAAAAAAAAAAAAAAAAAAAAAAAAAAAAAAAAAAAAAAAAAAAAAAAAAAAAAAAAAAAAAAAAAAAAAAAAAAAAAAAAAAAAAAAAAAAAAAAAAAAAAAAAAAAAAAAAAAAAAAAAAAAAAAAAAAAAAAAAAAAAAAAAAAAAAAAwQBAQEBAQEBAQEBAQEBAQMAAAAAAAAAAwAAAAMAAAAA/////wQAMwwAAAAAAAAAAAAAIAD///////////////8AAAD///////////////8DAAAAAgD///////8DAAAAAwD///////8DAAAAAwD///////////////////////////////////////////////////////////////////////////////////////////////////////////////////////////////////////////////////////////////////////////////////////////////////////////////////////////////////////////////////////////////////////////////////////////////////////////////////////////////////////////////////////////////////////////////////////////////////////////////////////////////////////////////////////////////////////////////8BACAA////////////////AAAO////////AwAAAAMA////////////////////////////////////////////////////////////////////////////////////////////////////////////////////////////////////////////////////////////////////////////////////////////////////////////////////////////////////////////////////////////////////////////////////////////////////////////////////////////////////////////////////////////////////////////////////////////////////////////////////////////////////////////////////////////////////////////////////////////////////////////////////////AgABAP///////wUAAAACABAACz+fPFbJ6jVPug79w+HzFAoEAAAAAAADAAAAAAADAAAAAwADAAMA////////BQAAAAMAEAALZUzI07EzFUeX7pk3xcjAVAQAAAABAAMAAAACAAMAAAABAAMAAAAAAP///////wMAAAAAAP///////wAAAAAAAAAAAAAAAAAAAAAAAAAAAAAAAAAAAAAAAAAAAAAAAAAAAAAAAAAAAAAAAAAAAAAAAAAAAAAAAAAAAAAAAAAAAAAAAAAAAAAAAAAAAAAAAAAAAAAAAAAAAAAAAAAAAAAAAAAAAAAAAAAAAAAAAAAAAAAAAAAAAAAAAAAAAAAAAAAAAAAAAAAAAAAAAAAAAAAAAAAAAAAAAAAAAAAAAAAAAAAAAAAAAAAAAAAAAAAAAAAAAAAAAAAAAAAAAAAAAAAAAAAAAAAAAAAAAAAAAAAAAAAAAAAAAAAAAAAAAAAAAAAAAAAAAAAAAAAAAAAAAAAAAAAAAAAAAAAAAAAAAAAAAAAAAAAAAAAAAAAAAAAAAAAAAAAAAAAAAAAAAAAAAAAAAAAAAAAAAAAAAAAAAAAAAAAAAAAAAAAAAAAAAAAAAAAAAAAAAAAAAAAAAAAAAAAAAAAAAAAAAAAAAAAAAAAAAAAAAAAAAAAAAAAAAAAAAAAAAAAAAAAAAAAAAAAAAAAAAAAAAAAAAAAAAAAAAAAAAAAAAAAAAAAAAAAAAAAAAAAAAAAAAAAAAAAAAAAAAAAAAAAAAAAAAAAAAAAAAAAAAAAAAAAAAAAAAAAAAAAAAAAAAAAAAAAAAAAAAAAAAAAAAAAAAAAAAAAAAAAAAAAAAAAAAAAAAAAAAAAAAAAAAAAAAAAAAAAAAAAAAAAAAAAAAAAAAAAAAAAAAAAAAAAAAAAAAAAAAAAAAAAAAAAAAAAAAAAAAAAAAAAAAAAAAAAAAAAAAAAAAAAAAAAAAAAAAAAAAAAAAAAAAAAAAAAAAAAAAAAAAAAAAAAAAAAAAAAAAAAAAAAAAAAAAAAAAAAAAAAAAAAAAAAAAAAAAAAAAAAAAAAAAAAAAAAAAAAAAAAAAAAAAAAAAAAAAAAAAAAAAAAAAAAAAAAAAAAAAAAAAAAAAAAAAAAAAAAAAAAAAAAAAAAAAAAAAAAAAAAAAAAAAAAAAAAAAAAAAAAAAAAAAAAAAAAAAAAAAAAAAAAAAAAAAAAAAAAAAAAAAAAAAAAAAAAAAAAAAAAAAAAAAAAAAAAAAAAAAAAAAAAAAAAAAAAAAAAAAAAAAAAAAAAAAAAAAAAAAAAAAAAAAAAAAAAAAAAAAAAAAAAAAAAAAAAAAAAAAAAAAAAAAAAAAAAAAAAAAAAAAAAAAAAAAAAAAAAAAAAAAAAAAAAAAAAAAAAAAAAAAAAAAAAAAAAAAAAAAAAAAAAAAAAAAAAAAAAAAAAAAAAAAAAAAAAAAAAAAAAAAAAAAAAAAAAAAAAAAAAAAAAAAAAAAAAAAAAAAAAAAAAAAAAAAAAAAAAAAAAAAAAAAAAAAAAAAAAAAAAAAAAAAAAAAAAAAAAAAAAAAAAAAAAAAAAAAAAAAAAAAAAAAAAAAAAAAAAAAAAAAAAAAAAAAAAAAAAAAAAAAAAAAAAAAAAAAAAAAAAAAAAAAAAAAAAAAAAAAAAAAAAAAAAAAAAAAAAAAAAAAAAAAAAAAAAAAAAAAAAAAAAAAAAAAAAAAAAAAAAAAAAAAAAAAAAAAAAAAAAAAAAAAAAAAAAAAAAAAAAAAAAAAAAAAAAAAAAAAAAAAAAAAAAAAAAAAAAAAAAAAAAAAAAAAAAAAAAAAAAAAAAAAAAAAAAAAAAAAAAAAAAAAAAAAAAAAAAAAAAAAAAAAAAAAAAAAAAAAAAAAAAAAAAAAAAAAAAAAAAAAAAAAAAAAAAAAAAAAAAAAAAAAAAAAAAAAAAAAAAAAAAAAAAAAAAAAAAAAAAAAAAAAAAAAAAAAAAAAAAAAAAAAAAAAAAAAAAAAAAAAAAAAAAAAAAAAAAAAAAAAAAAAAAAAAAAAAAAAAAAAAAAAAAAAAAAAAAAAAAAAAAAAAAAAAAAAAAAAAAAAAAAAAAAAAAAAAAAAAAAAAAAAAAAAAAAAAAAAAAAAAAAAAAAAAAAAAAAAAAAAAAAAAAAAAAAAAAAAAAAAAAAAAAAAAAAAAAAAAAAAAAAAAAAAAAAAAAAAAAAAAAAAAAAAAAAAAAAAAAAAAAAAAAAAAAAAAAAAAAAAAAAAAAAAAAAAAAAAAAAAAAAAAAAAAAAAAAAAAAAAAAAAAAAAAAAAAAAAAAAAAAAAAAAAAAAAAAAAAAAAAAAAAAAAAAAAAAAAAAAAAAAAAAAAAAAAAAAAAAAAAAAAAAAAAAAAAAAAAAAAAAAAAAAAAAAAAAAAAAAAAAAAAAAAAAAAAAAAAAAAAAAAAAAAAAAAAAAAAAAAAAAAAAAAAAAAAAAAAAAAAAAAAAAAAAAAAAAAAAAAAAAAAAAAAAAAAAAAAAAAAAAAAAAAAAAAAAAAAAAAAAAAAAAAAAAAAAAAAAAAAAAAAAAAAAAAAAAAAAAAAAAAAAAAAAAAAAAAAAAAAAAAAAAAAAAAAAAAAAAAAAAAAAAAAAAAAAAAAAAAAAAAAAAAAAAAAAAAAAAAAAAAAAAAAAAAAAAAAAAAAAAAAAAAAAAAAAAAAAAAAAAAAAAAAAAAAAAAAAAAAAAAAAAAAAAAAAAAAAAAAAAAAAAAAAAAAAAAAAAAAAAAAAAAAAAAAAAAAAAAAAAAAAAAAAAAAAAAAAAAAAAAAAAAAAAAAAAAAAAAAAAAAAAAAAAAAAAAAAAAAAAAAAAAAAAAAAAAAAAAAAAAAAAAAAAAAAAAAAAAAAAAAAAAAAAAAAAAAAAAAAAAAAAAAAAAAAAAAAAAAAAAAAAAAAAAAAAAAAAAAAAAAAAAAAAAAAAAAAAAAAAAAAAAAAAAAAAAAAAAAAAAAAAAAAAAAAAAAAAAAAAAAAAAAAAAAAAAAAAAAAAAAAAAAAAAAAAAAAAAAAAAAAAAAAAAAAAAAAAAAAAAAAAAAAAAAAAAAAAAAAAAAAAAAAAAAAAAAAAAAAAAAAAAAAAAAAAAAAAAAAAAAAAAAAAAAAAAAAAAAAAAAAAAAAAAAAAAAAAAAAAAAAAAAAAAAAAAAAAAAAAAAAAAAAAAAAAAAAAAAAAAAAAAAAAAAAAAAAAAAAAAAAAAAAAAAAAAAAAAAAAAAAAAAAAAAAAAAAAAAAAAAAAAAAAAAAAAAAAAAAAAAAAAAAAAAAAAAAAAAAAAAAAAAAAAAAAAAAAAAAAAAAAAAAAAAAAAAAAAAAAAAAAAAAAAAAAAAAAAAAAAAAAAAAAAAAAAAAAAAAAAAAAAAAAAAAAAAAAAAAAAAAAAAAAAAAAAAAAAAAAAAAAAAAAAAAAAAAAAAAAAAAAAAAAAAAAAAAAAAAAAAAAAAAAAAAAAAAAAAAAAAAAAAAAAAAAAAAAAAAAAAAAAAAAAAAAAAAAAAAAAAAAAAAAAAAAAAAAAAAAAAAAAAAAAAAAAAAAAAAAAAAAAAAAAAAAAAAAAAAAAAAAAAAAAAAAAAAAAAAAAAAAAAAAAAAAAAAAAAAAAAAAAAAAAAAAAAAAAAAAAAAAAAAAAAAAAAAAAAAAAAAAAAAAAAAAAAAAAAAAAAAAAAAAAAAAAAAAAAAAAAAAAAAAAAAAAAAAAAAAAAAAAAAAAAAAAAAAAAAAAAAAAAAAAAAAAAAAAAAAAAAAAAAAAAAAAAAAAAAAAAAAAAAAAAAAAAAAAAAAAAAAAAAAAAAAAAAAAAAAAAAAAAAAAAAAAAAAAAAAAAAAAAAAAAAAAAAAAAAAAAAAAAAAAAAAAAAAAAAAAAAAAAAAAAAAAAAAAAAAAAAAAAAAAAAAAAAAAAAAAAAAAAAAAAAAAAAAAAAAAAAAAAAAAAAAAAAAAAAAAAAAAAAAAAAAAAAAAAAAAAAAAAAAAAAAAAAAAAAAAAAAAAAAAAAAAAAAAAAAAAAAAAAAAAAAAAAAAAAAAAAAAAAAAAAAAAAAAAAAAAAAAAAAAAAAAAAAAAAAAAAAAAAAAAAAAAAAAAAAAAAAAAAAAAAAAAAAAAAAAAAAAAAAAAAAAAAAAAAAAAAAAAAAAAAAAAAAAAAAAAAAAAAAAAAAAAAAAAAAAAAAAAAAAAAAAAAAAAAAAAAAAAAAAAAAAAAAAAAAAAAAAAAAAAAAAAAAAAAAAAAAAAAAAAAAAAAAAAAAAAAAAAAAAAAAAAAAAAAAAAAAAAAAAAAAAAAAAAAAAAAAAAAAAAAAAAAAAAAAAAAAAAAAAAAAAAAAAAAAAAAAAAAAAAAAAAAAAAQAAAAEAAAAAP////8CAI4OAAAAAAAAAAAAAP/////GAMYAAAAFX2lkABAAAAAEP588VsnqNU+6Dv3D4fMUCgNEYXRhAFMAAAAIUHJlc2VudGF0aW9uU2Nhbm5lZEZvckxpbmtlZFNoYXBlcwAAAk51bWJlckZvcm1hdFNlcGFyYXRvck1vZGUACgAAAEF1dG9tYXRpYwAAAk5hbWUAJAAAAExpbmtlZFNoYXBlUHJlc2VudGF0aW9uU2V0dGluZ3NEYXRhABBWZXJzaW9uAAAAAAAJTGFzdFdyaXRlAPcbljiYAQAAAAEA/////4MAgwAAAAVfaWQAEAAAAARlTMjTsTMVR5fumTfFyMBUA0RhdGEAGwAAAARMaW5rZWRTaGFwZURhdGEABQAAAAAAAk5hbWUAGQAAAExpbmtlZFNoYXBlc0RhdGFQcm9wZXJ0eQAQVmVyc2lvbgABAAAACUxhc3RXcml0ZQDjG5Y4mAEAAAAAAAAAAAAAAAAAAAAAAAAAAAAAAAAAAAAAAAAAAAAAAAAAAAAAAAAAAAAAAAAAAAAAAAAAAAAAAAAAAAAAAAAAAAAAAAAAAAAAAAAAAAAAAAAAAAAAAAAAAAAAAAAAAAAAAAAAAAAAAAAAAAAAAAAAAAAAAAAAAAAAAAAAAAAAAAAAAAAAAAAAAAAAAAAAAAAAAAAAAAAAAAAAAAAAAAAAAAAAAAAAAAAAAAAAAAAAAAAAAAAAAAAAAAAAAAAAAAAAAAAAAAAAAAAAAAAAAAAAAAAAAAAAAAAAAAAAAAAAAAAAAAAAAAAAAAAAAAAAAAAAAAAAAAAAAAAAAAAAAAAAAAAAAAAAAAAAAAAAAAAAAAAAAAAAAAAAAAAAAAAAAAAAAAAAAAAAAAAAAAAAAAAAAAAAAAAAAAAAAAAAAAAAAAAAAAAAAAAAAAAAAAAAAAAAAAAAAAAAAAAAAAAAAAAAAAAAAAAAAAAAAAAAAAAAAAAAAAAAAAAAAAAAAAAAAAAAAAAAAAAAAAAAAAAAAAAAAAAAAAAAAAAAAAAAAAAAAAAAAAAAAAAAAAAAAAAAAAAAAAAAAAAAAAAAAAAAAAAAAAAAAAAAAAAAAAAAAAAAAAAAAAAAAAAAAAAAAAAAAAAAAAAAAAAAAAAAAAAAAAAAAAAAAAAAAAAAAAAAAAAAAAAAAAAAAAAAAAAAAAAAAAAAAAAAAAAAAAAAAAAAAAAAAAAAAAAAAAAAAAAAAAAAAAAAAAAAAAAAAAAAAAAAAAAAAAAAAAAAAAAAAAAAAAAAAAAAAAAAAAAAAAAAAAAAAAAAAAAAAAAAAAAAAAAAAAAAAAAAAAAAAAAAAAAAAAAAAAAAAAAAAAAAAAAAAAAAAAAAAAAAAAAAAAAAAAAAAAAAAAAAAAAAAAAAAAAAAAAAAAAAAAAAAAAAAAAAAAAAAAAAAAAAAAAAAAAAAAAAAAAAAAAAAAAAAAAAAAAAAAAAAAAAAAAAAAAAAAAAAAAAAAAAAAAAAAAAAAAAAAAAAAAAAAAAAAAAAAAAAAAAAAAAAAAAAAAAAAAAAAAAAAAAAAAAAAAAAAAAAAAAAAAAAAAAAAAAAAAAAAAAAAAAAAAAAAAAAAAAAAAAAAAAAAAAAAAAAAAAAAAAAAAAAAAAAAAAAAAAAAAAAAAAAAAAAAAAAAAAAAAAAAAAAAAAAAAAAAAAAAAAAAAAAAAAAAAAAAAAAAAAAAAAAAAAAAAAAAAAAAAAAAAAAAAAAAAAAAAAAAAAAAAAAAAAAAAAAAAAAAAAAAAAAAAAAAAAAAAAAAAAAAAAAAAAAAAAAAAAAAAAAAAAAAAAAAAAAAAAAAAAAAAAAAAAAAAAAAAAAAAAAAAAAAAAAAAAAAAAAAAAAAAAAAAAAAAAAAAAAAAAAAAAAAAAAAAAAAAAAAAAAAAAAAAAAAAAAAAAAAAAAAAAAAAAAAAAAAAAAAAAAAAAAAAAAAAAAAAAAAAAAAAAAAAAAAAAAAAAAAAAAAAAAAAAAAAAAAAAAAAAAAAAAAAAAAAAAAAAAAAAAAAAAAAAAAAAAAAAAAAAAAAAAAAAAAAAAAAAAAAAAAAAAAAAAAAAAAAAAAAAAAAAAAAAAAAAAAAAAAAAAAAAAAAAAAAAAAAAAAAAAAAAAAAAAAAAAAAAAAAAAAAAAAAAAAAAAAAAAAAAAAAAAAAAAAAAAAAAAAAAAAAAAAAAAAAAAAAAAAAAAAAAAAAAAAAAAAAAAAAAAAAAAAAAAAAAAAAAAAAAAAAAAAAAAAAAAAAAAAAAAAAAAAAAAAAAAAAAAAAAAAAAAAAAAAAAAAAAAAAAAAAAAAAAAAAAAAAAAAAAAAAAAAAAAAAAAAAAAAAAAAAAAAAAAAAAAAAAAAAAAAAAAAAAAAAAAAAAAAAAAAAAAAAAAAAAAAAAAAAAAAAAAAAAAAAAAAAAAAAAAAAAAAAAAAAAAAAAAAAAAAAAAAAAAAAAAAAAAAAAAAAAAAAAAAAAAAAAAAAAAAAAAAAAAAAAAAAAAAAAAAAAAAAAAAAAAAAAAAAAAAAAAAAAAAAAAAAAAAAAAAAAAAAAAAAAAAAAAAAAAAAAAAAAAAAAAAAAAAAAAAAAAAAAAAAAAAAAAAAAAAAAAAAAAAAAAAAAAAAAAAAAAAAAAAAAAAAAAAAAAAAAAAAAAAAAAAAAAAAAAAAAAAAAAAAAAAAAAAAAAAAAAAAAAAAAAAAAAAAAAAAAAAAAAAAAAAAAAAAAAAAAAAAAAAAAAAAAAAAAAAAAAAAAAAAAAAAAAAAAAAAAAAAAAAAAAAAAAAAAAAAAAAAAAAAAAAAAAAAAAAAAAAAAAAAAAAAAAAAAAAAAAAAAAAAAAAAAAAAAAAAAAAAAAAAAAAAAAAAAAAAAAAAAAAAAAAAAAAAAAAAAAAAAAAAAAAAAAAAAAAAAAAAAAAAAAAAAAAAAAAAAAAAAAAAAAAAAAAAAAAAAAAAAAAAAAAAAAAAAAAAAAAAAAAAAAAAAAAAAAAAAAAAAAAAAAAAAAAAAAAAAAAAAAAAAAAAAAAAAAAAAAAAAAAAAAAAAAAAAAAAAAAAAAAAAAAAAAAAAAAAAAAAAAAAAAAAAAAAAAAAAAAAAAAAAAAAAAAAAAAAAAAAAAAAAAAAAAAAAAAAAAAAAAAAAAAAAAAAAAAAAAAAAAAAAAAAAAAAAAAAAAAAAAAAAAAAAAAAAAAAAAAAAAAAAAAAAAAAAAAAAAAAAAAAAAAAAAAAAAAAAAAAAAAAAAAAAAAAAAAAAAAAAAAAAAAAAAAAAAAAAAAAAAAAAAAAAAAAAAAAAAAAAAAAAAAAAAAAAAAAAAAAAAAAAAAAAAAAAAAAAAAAAAAAAAAAAAAAAAAAAAAAAAAAAAAAAAAAAAAAAAAAAAAAAAAAAAAAAAAAAAAAAAAAAAAAAAAAAAAAAAAAAAAAAAAAAAAAAAAAAAAAAAAAAAAAAAAAAAAAAAAAAAAAAAAAAAAAAAAAAAAAAAAAAAAAAAAAAAAAAAAAAAAAAAAAAAAAAAAAAAAAAAAAAAAAAAAAAAAAAAAAAAAAAAAAAAAAAAAAAAAAAAAAAAAAAAAAAAAAAAAAAAAAAAAAAAAAAAAAAAAAAAAAAAAAAAAAAAAAAAAAAAAAAAAAAAAAAAAAAAAAAAAAAAAAAAAAAAAAAAAAAAAAAAAAAAAAAAAAAAAAAAAAAAAAAAAAAAAAAAAAAAAAAAAAAAAAAAAAAAAAAAAAAAAAAAAAAAAAAAAAAAAAAAAAAAAAAAAAAAAAAAAAAAAAAAAAAAAAAAAAAAAAAAAAAAAAAAAAAAAAAAAAAAAAAAAAAAAAAAAAAAAAAAAAAAAAAAAAAAAAAAAAAAAAAAAAAAAAAAAAAAAAAAAAAAAAAAAAAAAAAAAAAAAAAAAAAAAAAAAAAAAAAAAAAAAAAAAAAAAAAAAAAAAAAAAAAAAAAAAAAAAAAAAAAAAAAAAAAAAAAAAAAAAAAAAAAAAAAAAAAAAAAAAAAAAAAAAAAAAAAAAAAAAAAAAAAAAAAAAAAAAAAAAAAAAAAAAAAAAAAAAAAAAAAAAAAAAAAAAAAAAAAAAAAAAAAAAAAAAAAAAAAAAAAAAAAAAAAAAAAAAAAAAAAAAAAAAAAAAAAAAAAAAAAAAAAAAAAAAAAAAAAAAAAAAAAAAAAAAAAAAAAAAAAAAAAAAAAAAAAAAAAAAAAAAAAAAAAAAAAAAAAAAAAAAAAAAAAAAAAAAAAAAAAAAAAAAAAAAAAAAAAAAAAAAAAAAAAAAAAAAAAAAAAAAAAAAAAAAAAAAAAAAAAAAAAAAAAAAAAAAAAAAAAAAAAAAAAAAAAAAAAAAAAAAAAAAAAAAAAAAAAAAAAAAAAAAAAAAAAAAAAAAAAAAAAAAAAAAAAAAAAAAAAAAAAAAAAAAAAAAAAAAAAAAAAAAAAAAAAAAAAAAAAAAAAAAAAAAAAAAAAAAAAAAAAAAAAAAAAAAAAAAAAAAAAAAAAAAAAAAAAAAAAAAAAAAAAAAAAAAAAAAAAAAAAAAAAAAAAAAAAAAAAAAAAAAAAAAAAAAAAAAAAAAAAAAAAAAAAAAAAAAAAAAAAAAAAAAAAAAAAAAAAAAAAAAAAAAAAAAAAAAAAAAAAAAAAAAAAAAAAAAAAAAAAAAAAAAAAAAAAAAAAAAAAAAAAAAAAAAAAAAAAAAAAAAAAAAAAAAAAAAAAAAAAAAAAAAAAAAAAAAAAAAAAAAAAAAAAAAAAAAAAAAAAAAAAAAAAAAAAAAAAAAAAAAAAAAAAAAAAAAAAAAAAAAAAAAAAAAAAAAAAAAAAAAAAAAAAAAAAAAAAAAAAAAAAAAAAAAAAAAAAAAAAAAAAAAAAAAAAAAAAAAAAAAAAAAAAAAAAAAAAAAAAAAAAAAAAAAAAAAAAAAAAAAAAAAAAAAAAAAAAAAAAAAAAAAAAAAAAAAAAAAAAAAAAAAAAAAAAAAAAAAAAAAAAAAAAAAAAAAAAAAAAAAAAAAAAAAAAAAAAAAAAAAAAAAAAAAAAAAAAAAAAAAAAAAAAAAAAAAAAAAAAAAAAAAAAAAAAAAAAAAAAAAAAAAAAAAAAAAAAAAAAAAAAAAAAAAAAAAAAAAAAAAAAAAAAAAAAAAAAAAAAAAAAAAAAAAAAAAAAAAAAAAAAAAAAAAAAAAAAAAAAAAAAAAAAAAAAAAAAAAAAAAAAAAAAAAAAAAAAAAAAAAAAAAAAAAAAAAAAAAAAAAAAAAAAAAAAAAAAAAAAAAAAAAAAAAAAAAAAAAAAAAAAAAAAAAAAAAAAAAAAAAAAAAAAAAAAAAAAAAAAAAAAAAAAAAAAAAAAAAAAAAAAAAAAAAAAAAAAAAAAAAAAAAAAAAAAAAAAAAAAAAAAAAAAAAAAAAAAAAAAAAAAAAAAAAAAAAAAAAAAAAAAAAAAAAAAAAAAAAAAAAAAAAAAAAAAAAAAAAAAAAAAAAAAAAAAAAAAAAAAAAAAAAAFAAAAAwAAAAD/////BAD8CwAAAAAAAAAAAAAgAf///////////////wAAAP///////////////wUAAAACAP///////wUAAAACAP///////wUAAAADAP///////wUAAAADAP///////////////////////////////////////////////////////////////////////////////////////////////////////////////////////////////////////////////////////////////////////////////////////////////////////////////////////////////////////////////////////////////////////////////////////////////////////////////////////////////////////////////////////////////////////////////////////////////////////////////////////////////////////////////////////////////wEAIAH///////////////8AAA7///////8FAAAAAwD///////////////////////////////////////////////////////////////////////////////////////////////////////////////////////////////////////////////////////////////////////////////////////////////////////////////////////////////////////////////////////////////////////////////////////////////////////////////////////////////////////////////////////////////////////////////////////////////////////////////////////////////////////////////////////////////////////////////////////////////////////////////////////8CAAIBAwAAAAIA////////JQAGTGlua2VkU2hhcGVQcmVzZW50YXRpb25TZXR0aW5nc0RhdGFfMAQAAAAAAAUAAAAAAAUAAAADAAUAAAAAAAUAAAADAAMABAEDAAAAAwD///////8aAAZMaW5rZWRTaGFwZXNEYXRhUHJvcGVydHlfMQQAAAABAAUAAAACAAUAAAABAAUAAAACAP///////wUAAAAAAP///////wUAAAAAAP///////wAAAAAAAAAAAAAAAAAAAAAAAAAAAAAAAAAAAAAAAAAAAAAAAAAAAAAAAAAAAAAAAAAAAAAAAAAAAAAAAAAAAAAAAAAAAAAAAAAAAAAAAAAAAAAAAAAAAAAAAAAAAAAAAAAAAAAAAAAAAAAAAAAAAAAAAAAAAAAAAAAAAAAAAAAAAAAAAAAAAAAAAAAAAAAAAAAAAAAAAAAAAAAAAAAAAAAAAAAAAAAAAAAAAAAAAAAAAAAAAAAAAAAAAAAAAAAAAAAAAAAAAAAAAAAAAAAAAAAAAAAAAAAAAAAAAAAAAAAAAAAAAAAAAAAAAAAAAAAAAAAAAAAAAAAAAAAAAAAAAAAAAAAAAAAAAAAAAAAAAAAAAAAAAAAAAAAAAAAAAAAAAAAAAAAAAAAAAAAAAAAAAAAAAAAAAAAAAAAAAAAAAAAAAAAAAAAAAAAAAAAAAAAAAAAAAAAAAAAAAAAAAAAAAAAAAAAAAAAAAAAAAAAAAAAAAAAAAAAAAAAAAAAAAAAAAAAAAAAAAAAAAAAAAAAAAAAAAAAAAAAAAAAAAAAAAAAAAAAAAAAAAAAAAAAAAAAAAAAAAAAAAAAAAAAAAAAAAAAAAAAAAAAAAAAAAAAAAAAAAAAAAAAAAAAAAAAAAAAAAAAAAAAAAAAAAAAAAAAAAAAAAAAAAAAAAAAAAAAAAAAAAAAAAAAAAAAAAAAAAAAAAAAAAAAAAAAAAAAAAAAAAAAAAAAAAAAAAAAAAAAAAAAAAAAAAAAAAAAAAAAAAAAAAAAAAAAAAAAAAAAAAAAAAAAAAAAAAAAAAAAAAAAAAAAAAAAAAAAAAAAAAAAAAAAAAAAAAAAAAAAAAAAAAAAAAAAAAAAAAAAAAAAAAAAAAAAAAAAAAAAAAAAAAAAAAAAAAAAAAAAAAAAAAAAAAAAAAAAAAAAAAAAAAAAAAAAAAAAAAAAAAAAAAAAAAAAAAAAAAAAAAAAAAAAAAAAAAAAAAAAAAAAAAAAAAAAAAAAAAAAAAAAAAAAAAAAAAAAAAAAAAAAAAAAAAAAAAAAAAAAAAAAAAAAAAAAAAAAAAAAAAAAAAAAAAAAAAAAAAAAAAAAAAAAAAAAAAAAAAAAAAAAAAAAAAAAAAAAAAAAAAAAAAAAAAAAAAAAAAAAAAAAAAAAAAAAAAAAAAAAAAAAAAAAAAAAAAAAAAAAAAAAAAAAAAAAAAAAAAAAAAAAAAAAAAAAAAAAAAAAAAAAAAAAAAAAAAAAAAAAAAAAAAAAAAAAAAAAAAAAAAAAAAAAAAAAAAAAAAAAAAAAAAAAAAAAAAAAAAAAAAAAAAAAAAAAAAAAAAAAAAAAAAAAAAAAAAAAAAAAAAAAAAAAAAAAAAAAAAAAAAAAAAAAAAAAAAAAAAAAAAAAAAAAAAAAAAAAAAAAAAAAAAAAAAAAAAAAAAAAAAAAAAAAAAAAAAAAAAAAAAAAAAAAAAAAAAAAAAAAAAAAAAAAAAAAAAAAAAAAAAAAAAAAAAAAAAAAAAAAAAAAAAAAAAAAAAAAAAAAAAAAAAAAAAAAAAAAAAAAAAAAAAAAAAAAAAAAAAAAAAAAAAAAAAAAAAAAAAAAAAAAAAAAAAAAAAAAAAAAAAAAAAAAAAAAAAAAAAAAAAAAAAAAAAAAAAAAAAAAAAAAAAAAAAAAAAAAAAAAAAAAAAAAAAAAAAAAAAAAAAAAAAAAAAAAAAAAAAAAAAAAAAAAAAAAAAAAAAAAAAAAAAAAAAAAAAAAAAAAAAAAAAAAAAAAAAAAAAAAAAAAAAAAAAAAAAAAAAAAAAAAAAAAAAAAAAAAAAAAAAAAAAAAAAAAAAAAAAAAAAAAAAAAAAAAAAAAAAAAAAAAAAAAAAAAAAAAAAAAAAAAAAAAAAAAAAAAAAAAAAAAAAAAAAAAAAAAAAAAAAAAAAAAAAAAAAAAAAAAAAAAAAAAAAAAAAAAAAAAAAAAAAAAAAAAAAAAAAAAAAAAAAAAAAAAAAAAAAAAAAAAAAAAAAAAAAAAAAAAAAAAAAAAAAAAAAAAAAAAAAAAAAAAAAAAAAAAAAAAAAAAAAAAAAAAAAAAAAAAAAAAAAAAAAAAAAAAAAAAAAAAAAAAAAAAAAAAAAAAAAAAAAAAAAAAAAAAAAAAAAAAAAAAAAAAAAAAAAAAAAAAAAAAAAAAAAAAAAAAAAAAAAAAAAAAAAAAAAAAAAAAAAAAAAAAAAAAAAAAAAAAAAAAAAAAAAAAAAAAAAAAAAAAAAAAAAAAAAAAAAAAAAAAAAAAAAAAAAAAAAAAAAAAAAAAAAAAAAAAAAAAAAAAAAAAAAAAAAAAAAAAAAAAAAAAAAAAAAAAAAAAAAAAAAAAAAAAAAAAAAAAAAAAAAAAAAAAAAAAAAAAAAAAAAAAAAAAAAAAAAAAAAAAAAAAAAAAAAAAAAAAAAAAAAAAAAAAAAAAAAAAAAAAAAAAAAAAAAAAAAAAAAAAAAAAAAAAAAAAAAAAAAAAAAAAAAAAAAAAAAAAAAAAAAAAAAAAAAAAAAAAAAAAAAAAAAAAAAAAAAAAAAAAAAAAAAAAAAAAAAAAAAAAAAAAAAAAAAAAAAAAAAAAAAAAAAAAAAAAAAAAAAAAAAAAAAAAAAAAAAAAAAAAAAAAAAAAAAAAAAAAAAAAAAAAAAAAAAAAAAAAAAAAAAAAAAAAAAAAAAAAAAAAAAAAAAAAAAAAAAAAAAAAAAAAAAAAAAAAAAAAAAAAAAAAAAAAAAAAAAAAAAAAAAAAAAAAAAAAAAAAAAAAAAAAAAAAAAAAAAAAAAAAAAAAAAAAAAAAAAAAAAAAAAAAAAAAAAAAAAAAAAAAAAAAAAAAAAAAAAAAAAAAAAAAAAAAAAAAAAAAAAAAAAAAAAAAAAAAAAAAAAAAAAAAAAAAAAAAAAAAAAAAAAAAAAAAAAAAAAAAAAAAAAAAAAAAAAAAAAAAAAAAAAAAAAAAAAAAAAAAAAAAAAAAAAAAAAAAAAAAAAAAAAAAAAAAAAAAAAAAAAAAAAAAAAAAAAAAAAAAAAAAAAAAAAAAAAAAAAAAAAAAAAAAAAAAAAAAAAAAAAAAAAAAAAAAAAAAAAAAAAAAAAAAAAAAAAAAAAAAAAAAAAAAAAAAAAAAAAAAAAAAAAAAAAAAAAAAAAAAAAAAAAAAAAAAAAAAAAAAAAAAAAAAAAAAAAAAAAAAAAAAAAAAAAAAAAAAAAAAAAAAAAAAAAAAAAAAAAAAAAAAAAAAAAAAAAAAAAAAAAAAAAAAAAAAAAAAAAAAAAAAAAAAAAAAAAAAAAAAAAAAAAAAAAAAAAAAAAAAAAAAAAAAAAAAAAAAAAAAAAAAAAAAAAAAAAAAAAAAAAAAAAAAAAAAAAAAAAAAAAAAAAAAAAAAAAAAAAAAAAAAAAAAAAAAAAAAAAAAAAAAAAAAAAAAAAAAAAAAAAAAAAAAAAAAAAAAAAAAAAAAAAAAAAAAAAAAAAAAAAAAAAAAAAAAAAAAAAAAAAAAAAAAAAAAAAAAAAAAAAAAAAAAAAAAAAAAAAAAAAAAAAAAAAAAAAAAAAAAAAAAAAAAAAAAAAAAAAAAAAAAAAAAAAAAAAAAAAAAAAAAAAAAAAAAAAAAAAAAAAAAAAAAAAAAAAAAAAAAAAAAAAAAAAAAAAAAAAAAAAAAAAAAAAAAAAAAAAAAAAAAAAAAAAAAAAAAAAAAAAAAAAAAAAAAAAAAAAAAAAAAAAAAAAAAAAAAAAAAAAAAAAAAAAAAAAAAAAAAAAAAAAAAAAAAAAAAAAAAAAAAAAAAAAAAAAAAAAAAAAAAAAAAAAAAAAAAAAAAAAAAAAAAAAAAAAAAAAAAAAAAAAAAAAAAAAAAAAAAAAAAAAAAAAAAAAAAAAAAAAAAAAAAAAAAAAAAAAAAAAAAAAAAAAAAAAAAAAAAAAAAAAAAAAAAAAAAAAAAAAAAAAAAAAAAAAAAAAAAAAAAAAAAAAAAAAAAAAAAAAAAAAAAAAAAAAAAAAAAAAAAAAAAAAAAAAAAAAAAAAAAAAAAAAAAAAAAAAAAAAAAAAAAAAAAAAAAAAAAAAAAAAAAAAAAAAAAAAAAAAAAAAAAAAAAAAAAAAAAAAAAAAAAAAAAAAAAAAAAAAAAA"/>
+  <p:tag name="EMPOWERCHARTSPROPERTIES_SLOT" val="A"/>
+  <p:tag name="EMPOWERCHARTSPROPERTIES_LASTWRITEDATE" val="638888928185137095"/>
+  <p:tag name="EMPOWERCHARTSPROPERTIES_A_LENGTH" val="24576"/>
 </p:tagLst>
 </file>
 
 <file path=ppt/tags/tag2.xml><?xml version="1.0" encoding="utf-8"?>
-<p:tagLst xmlns:a="http://schemas.openxmlformats.org/drawingml/2006/main" xmlns:r="http://schemas.openxmlformats.org/officeDocument/2006/relationships" xmlns:p="http://schemas.openxmlformats.org/presentationml/2006/main">
-  <p:tag name="COLORSETGROUPCLASSNAME" val="ColorSetGroup4"/>
-</p:tagLst>
-</file>
-
-<file path=ppt/tags/tag3.xml><?xml version="1.0" encoding="utf-8"?>
-<p:tagLst xmlns:a="http://schemas.openxmlformats.org/drawingml/2006/main" xmlns:r="http://schemas.openxmlformats.org/officeDocument/2006/relationships" xmlns:p="http://schemas.openxmlformats.org/presentationml/2006/main">
-  <p:tag name="STYLENAME" val="Bodystyle"/>
-  <p:tag name="COLORSETGROUPCLASSNAME" val="ColorSetGroup4"/>
-</p:tagLst>
-</file>
-
-<file path=ppt/tags/tag4.xml><?xml version="1.0" encoding="utf-8"?>
 <p:tagLst xmlns:a="http://schemas.openxmlformats.org/drawingml/2006/main" xmlns:r="http://schemas.openxmlformats.org/officeDocument/2006/relationships" xmlns:p="http://schemas.openxmlformats.org/presentationml/2006/main">
   <p:tag name="COLORSETGROUPCLASSNAME" val="ColorSetGroup4"/>
   <p:tag name="COLORSETCLASSNAME" val="ColorSet2"/>
@@ -19955,13 +20054,35 @@
 </p:tagLst>
 </file>
 
-<file path=ppt/tags/tag5.xml><?xml version="1.0" encoding="utf-8"?>
+<file path=ppt/tags/tag3.xml><?xml version="1.0" encoding="utf-8"?>
 <p:tagLst xmlns:a="http://schemas.openxmlformats.org/drawingml/2006/main" xmlns:r="http://schemas.openxmlformats.org/officeDocument/2006/relationships" xmlns:p="http://schemas.openxmlformats.org/presentationml/2006/main">
   <p:tag name="COLORSETGROUPCLASSNAME" val="ColorSetGroup4"/>
 </p:tagLst>
 </file>
 
+<file path=ppt/tags/tag4.xml><?xml version="1.0" encoding="utf-8"?>
+<p:tagLst xmlns:a="http://schemas.openxmlformats.org/drawingml/2006/main" xmlns:r="http://schemas.openxmlformats.org/officeDocument/2006/relationships" xmlns:p="http://schemas.openxmlformats.org/presentationml/2006/main">
+  <p:tag name="STYLENAME" val="Bodystyle"/>
+  <p:tag name="COLORSETGROUPCLASSNAME" val="ColorSetGroup4"/>
+</p:tagLst>
+</file>
+
+<file path=ppt/tags/tag5.xml><?xml version="1.0" encoding="utf-8"?>
+<p:tagLst xmlns:a="http://schemas.openxmlformats.org/drawingml/2006/main" xmlns:r="http://schemas.openxmlformats.org/officeDocument/2006/relationships" xmlns:p="http://schemas.openxmlformats.org/presentationml/2006/main">
+  <p:tag name="COLORSETGROUPCLASSNAME" val="ColorSetGroup4"/>
+  <p:tag name="COLORSETCLASSNAME" val="ColorSet2"/>
+  <p:tag name="AGTX" val="Example model: Controlled Motor Drive"/>
+  <p:tag name="SAXCONVERTED" val="2"/>
+</p:tagLst>
+</file>
+
 <file path=ppt/tags/tag6.xml><?xml version="1.0" encoding="utf-8"?>
+<p:tagLst xmlns:a="http://schemas.openxmlformats.org/drawingml/2006/main" xmlns:r="http://schemas.openxmlformats.org/officeDocument/2006/relationships" xmlns:p="http://schemas.openxmlformats.org/presentationml/2006/main">
+  <p:tag name="COLORSETGROUPCLASSNAME" val="ColorSetGroup4"/>
+</p:tagLst>
+</file>
+
+<file path=ppt/tags/tag7.xml><?xml version="1.0" encoding="utf-8"?>
 <p:tagLst xmlns:a="http://schemas.openxmlformats.org/drawingml/2006/main" xmlns:r="http://schemas.openxmlformats.org/officeDocument/2006/relationships" xmlns:p="http://schemas.openxmlformats.org/presentationml/2006/main">
   <p:tag name="STYLENAME" val="Bodystyle"/>
   <p:tag name="COLORSETGROUPCLASSNAME" val="ColorSetGroup4"/>

</xml_diff>

<commit_message>
move FMI 3 examples to part 4
</commit_message>
<xml_diff>
--- a/part1/Introduction-to-FMI.pptx
+++ b/part1/Introduction-to-FMI.pptx
@@ -5,10 +5,10 @@
     <p:sldMasterId id="2147483649" r:id="rId3"/>
   </p:sldMasterIdLst>
   <p:notesMasterIdLst>
-    <p:notesMasterId r:id="rId37"/>
+    <p:notesMasterId r:id="rId35"/>
   </p:notesMasterIdLst>
   <p:handoutMasterIdLst>
-    <p:handoutMasterId r:id="rId38"/>
+    <p:handoutMasterId r:id="rId36"/>
   </p:handoutMasterIdLst>
   <p:sldIdLst>
     <p:sldId id="314" r:id="rId4"/>
@@ -37,18 +37,16 @@
     <p:sldId id="461" r:id="rId27"/>
     <p:sldId id="463" r:id="rId28"/>
     <p:sldId id="462" r:id="rId29"/>
-    <p:sldId id="479" r:id="rId30"/>
-    <p:sldId id="478" r:id="rId31"/>
-    <p:sldId id="466" r:id="rId32"/>
-    <p:sldId id="474" r:id="rId33"/>
-    <p:sldId id="471" r:id="rId34"/>
-    <p:sldId id="476" r:id="rId35"/>
-    <p:sldId id="477" r:id="rId36"/>
+    <p:sldId id="466" r:id="rId30"/>
+    <p:sldId id="474" r:id="rId31"/>
+    <p:sldId id="471" r:id="rId32"/>
+    <p:sldId id="476" r:id="rId33"/>
+    <p:sldId id="477" r:id="rId34"/>
   </p:sldIdLst>
   <p:sldSz cx="12192000" cy="6858000"/>
   <p:notesSz cx="6858000" cy="9144000"/>
   <p:custDataLst>
-    <p:tags r:id="rId39"/>
+    <p:tags r:id="rId37"/>
   </p:custDataLst>
   <p:defaultTextStyle>
     <a:defPPr>
@@ -587,7 +585,7 @@
               <a:pPr>
                 <a:defRPr/>
               </a:pPr>
-              <a:t>7/23/2025</a:t>
+              <a:t>7/24/2025</a:t>
             </a:fld>
             <a:endParaRPr lang="en-US"/>
           </a:p>
@@ -14486,282 +14484,6 @@
 <file path=ppt/slides/slide27.xml><?xml version="1.0" encoding="utf-8"?>
 <p:sld xmlns:a="http://schemas.openxmlformats.org/drawingml/2006/main" xmlns:r="http://schemas.openxmlformats.org/officeDocument/2006/relationships" xmlns:p="http://schemas.openxmlformats.org/presentationml/2006/main">
   <p:cSld>
-    <p:spTree>
-      <p:nvGrpSpPr>
-        <p:cNvPr id="1" name=""/>
-        <p:cNvGrpSpPr/>
-        <p:nvPr/>
-      </p:nvGrpSpPr>
-      <p:grpSpPr>
-        <a:xfrm>
-          <a:off x="0" y="0"/>
-          <a:ext cx="0" cy="0"/>
-          <a:chOff x="0" y="0"/>
-          <a:chExt cx="0" cy="0"/>
-        </a:xfrm>
-      </p:grpSpPr>
-      <p:sp>
-        <p:nvSpPr>
-          <p:cNvPr id="2" name="Inhaltsplatzhalter 1">
-            <a:extLst>
-              <a:ext uri="{FF2B5EF4-FFF2-40B4-BE49-F238E27FC236}">
-                <a16:creationId xmlns:a16="http://schemas.microsoft.com/office/drawing/2014/main" id="{46108B23-BD53-2C8A-D4AA-B3CEF98FA52C}"/>
-              </a:ext>
-            </a:extLst>
-          </p:cNvPr>
-          <p:cNvSpPr>
-            <a:spLocks noGrp="1"/>
-          </p:cNvSpPr>
-          <p:nvPr>
-            <p:ph idx="1"/>
-          </p:nvPr>
-        </p:nvSpPr>
-        <p:spPr/>
-        <p:txBody>
-          <a:bodyPr/>
-          <a:lstStyle/>
-          <a:p>
-            <a:endParaRPr lang="en-US"/>
-          </a:p>
-        </p:txBody>
-      </p:sp>
-      <p:sp>
-        <p:nvSpPr>
-          <p:cNvPr id="3" name="Titel 2">
-            <a:extLst>
-              <a:ext uri="{FF2B5EF4-FFF2-40B4-BE49-F238E27FC236}">
-                <a16:creationId xmlns:a16="http://schemas.microsoft.com/office/drawing/2014/main" id="{C92BA9CF-FE05-F0DC-4EA6-66E8BBCEC5C4}"/>
-              </a:ext>
-            </a:extLst>
-          </p:cNvPr>
-          <p:cNvSpPr>
-            <a:spLocks noGrp="1"/>
-          </p:cNvSpPr>
-          <p:nvPr>
-            <p:ph type="title"/>
-          </p:nvPr>
-        </p:nvSpPr>
-        <p:spPr/>
-        <p:txBody>
-          <a:bodyPr/>
-          <a:lstStyle/>
-          <a:p>
-            <a:r>
-              <a:rPr lang="en-US" dirty="0"/>
-              <a:t>Array variables</a:t>
-            </a:r>
-          </a:p>
-        </p:txBody>
-      </p:sp>
-      <p:pic>
-        <p:nvPicPr>
-          <p:cNvPr id="5" name="Grafik 4">
-            <a:extLst>
-              <a:ext uri="{FF2B5EF4-FFF2-40B4-BE49-F238E27FC236}">
-                <a16:creationId xmlns:a16="http://schemas.microsoft.com/office/drawing/2014/main" id="{2DAF8738-9BFF-3F3E-E1E7-46A076B8D4A7}"/>
-              </a:ext>
-            </a:extLst>
-          </p:cNvPr>
-          <p:cNvPicPr>
-            <a:picLocks noChangeAspect="1"/>
-          </p:cNvPicPr>
-          <p:nvPr/>
-        </p:nvPicPr>
-        <p:blipFill>
-          <a:blip r:embed="rId2"/>
-          <a:stretch>
-            <a:fillRect/>
-          </a:stretch>
-        </p:blipFill>
-        <p:spPr>
-          <a:xfrm>
-            <a:off x="1267289" y="1835945"/>
-            <a:ext cx="9657421" cy="3186110"/>
-          </a:xfrm>
-          <a:prstGeom prst="rect">
-            <a:avLst/>
-          </a:prstGeom>
-        </p:spPr>
-      </p:pic>
-    </p:spTree>
-    <p:extLst>
-      <p:ext uri="{BB962C8B-B14F-4D97-AF65-F5344CB8AC3E}">
-        <p14:creationId xmlns:p14="http://schemas.microsoft.com/office/powerpoint/2010/main" val="3534557293"/>
-      </p:ext>
-    </p:extLst>
-  </p:cSld>
-  <p:clrMapOvr>
-    <a:masterClrMapping/>
-  </p:clrMapOvr>
-  <p:transition/>
-</p:sld>
-</file>
-
-<file path=ppt/slides/slide28.xml><?xml version="1.0" encoding="utf-8"?>
-<p:sld xmlns:a="http://schemas.openxmlformats.org/drawingml/2006/main" xmlns:r="http://schemas.openxmlformats.org/officeDocument/2006/relationships" xmlns:p="http://schemas.openxmlformats.org/presentationml/2006/main">
-  <p:cSld>
-    <p:spTree>
-      <p:nvGrpSpPr>
-        <p:cNvPr id="1" name=""/>
-        <p:cNvGrpSpPr/>
-        <p:nvPr/>
-      </p:nvGrpSpPr>
-      <p:grpSpPr>
-        <a:xfrm>
-          <a:off x="0" y="0"/>
-          <a:ext cx="0" cy="0"/>
-          <a:chOff x="0" y="0"/>
-          <a:chExt cx="0" cy="0"/>
-        </a:xfrm>
-      </p:grpSpPr>
-      <p:sp>
-        <p:nvSpPr>
-          <p:cNvPr id="2" name="Inhaltsplatzhalter 1">
-            <a:extLst>
-              <a:ext uri="{FF2B5EF4-FFF2-40B4-BE49-F238E27FC236}">
-                <a16:creationId xmlns:a16="http://schemas.microsoft.com/office/drawing/2014/main" id="{CA0C9647-08D2-E5CE-ABEA-2ADBFAAA620D}"/>
-              </a:ext>
-            </a:extLst>
-          </p:cNvPr>
-          <p:cNvSpPr>
-            <a:spLocks noGrp="1"/>
-          </p:cNvSpPr>
-          <p:nvPr>
-            <p:ph idx="1"/>
-          </p:nvPr>
-        </p:nvSpPr>
-        <p:spPr/>
-        <p:txBody>
-          <a:bodyPr/>
-          <a:lstStyle/>
-          <a:p>
-            <a:r>
-              <a:rPr lang="en-US" dirty="0">
-                <a:hlinkClick r:id="rId2"/>
-              </a:rPr>
-              <a:t>https://github.com/t-sommer/fmi3-features</a:t>
-            </a:r>
-            <a:r>
-              <a:rPr lang="en-US" dirty="0"/>
-              <a:t> </a:t>
-            </a:r>
-          </a:p>
-          <a:p>
-            <a:endParaRPr lang="en-US" dirty="0"/>
-          </a:p>
-          <a:p>
-            <a:r>
-              <a:rPr lang="en-US" dirty="0"/>
-              <a:t>FMI 3 with events</a:t>
-            </a:r>
-          </a:p>
-        </p:txBody>
-      </p:sp>
-      <p:sp>
-        <p:nvSpPr>
-          <p:cNvPr id="3" name="Titel 2">
-            <a:extLst>
-              <a:ext uri="{FF2B5EF4-FFF2-40B4-BE49-F238E27FC236}">
-                <a16:creationId xmlns:a16="http://schemas.microsoft.com/office/drawing/2014/main" id="{E27E7D4E-0399-C144-13E6-67D458BADC01}"/>
-              </a:ext>
-            </a:extLst>
-          </p:cNvPr>
-          <p:cNvSpPr>
-            <a:spLocks noGrp="1"/>
-          </p:cNvSpPr>
-          <p:nvPr>
-            <p:ph type="title"/>
-          </p:nvPr>
-        </p:nvSpPr>
-        <p:spPr/>
-        <p:txBody>
-          <a:bodyPr/>
-          <a:lstStyle/>
-          <a:p>
-            <a:r>
-              <a:rPr lang="en-US" dirty="0"/>
-              <a:t>FMI 3 examples</a:t>
-            </a:r>
-          </a:p>
-        </p:txBody>
-      </p:sp>
-      <p:pic>
-        <p:nvPicPr>
-          <p:cNvPr id="5" name="Grafik 4">
-            <a:extLst>
-              <a:ext uri="{FF2B5EF4-FFF2-40B4-BE49-F238E27FC236}">
-                <a16:creationId xmlns:a16="http://schemas.microsoft.com/office/drawing/2014/main" id="{B60B9856-0C40-B144-B991-1D0059278770}"/>
-              </a:ext>
-            </a:extLst>
-          </p:cNvPr>
-          <p:cNvPicPr>
-            <a:picLocks noChangeAspect="1"/>
-          </p:cNvPicPr>
-          <p:nvPr/>
-        </p:nvPicPr>
-        <p:blipFill>
-          <a:blip r:embed="rId3"/>
-          <a:stretch>
-            <a:fillRect/>
-          </a:stretch>
-        </p:blipFill>
-        <p:spPr>
-          <a:xfrm>
-            <a:off x="6169439" y="3923722"/>
-            <a:ext cx="4369728" cy="2061773"/>
-          </a:xfrm>
-          <a:prstGeom prst="rect">
-            <a:avLst/>
-          </a:prstGeom>
-        </p:spPr>
-      </p:pic>
-      <p:pic>
-        <p:nvPicPr>
-          <p:cNvPr id="7" name="Grafik 6">
-            <a:extLst>
-              <a:ext uri="{FF2B5EF4-FFF2-40B4-BE49-F238E27FC236}">
-                <a16:creationId xmlns:a16="http://schemas.microsoft.com/office/drawing/2014/main" id="{855D4E45-CD58-87FA-1832-8488EC427C6D}"/>
-              </a:ext>
-            </a:extLst>
-          </p:cNvPr>
-          <p:cNvPicPr>
-            <a:picLocks noChangeAspect="1"/>
-          </p:cNvPicPr>
-          <p:nvPr/>
-        </p:nvPicPr>
-        <p:blipFill>
-          <a:blip r:embed="rId4"/>
-          <a:stretch>
-            <a:fillRect/>
-          </a:stretch>
-        </p:blipFill>
-        <p:spPr>
-          <a:xfrm>
-            <a:off x="610612" y="3789574"/>
-            <a:ext cx="4583009" cy="1831293"/>
-          </a:xfrm>
-          <a:prstGeom prst="rect">
-            <a:avLst/>
-          </a:prstGeom>
-        </p:spPr>
-      </p:pic>
-    </p:spTree>
-    <p:extLst>
-      <p:ext uri="{BB962C8B-B14F-4D97-AF65-F5344CB8AC3E}">
-        <p14:creationId xmlns:p14="http://schemas.microsoft.com/office/powerpoint/2010/main" val="3711406455"/>
-      </p:ext>
-    </p:extLst>
-  </p:cSld>
-  <p:clrMapOvr>
-    <a:masterClrMapping/>
-  </p:clrMapOvr>
-  <p:transition/>
-</p:sld>
-</file>
-
-<file path=ppt/slides/slide29.xml><?xml version="1.0" encoding="utf-8"?>
-<p:sld xmlns:a="http://schemas.openxmlformats.org/drawingml/2006/main" xmlns:r="http://schemas.openxmlformats.org/officeDocument/2006/relationships" xmlns:p="http://schemas.openxmlformats.org/presentationml/2006/main">
-  <p:cSld>
     <p:bg>
       <p:bgPr>
         <a:solidFill>
@@ -14858,350 +14580,7 @@
 </p:sld>
 </file>
 
-<file path=ppt/slides/slide3.xml><?xml version="1.0" encoding="utf-8"?>
-<p:sld xmlns:a="http://schemas.openxmlformats.org/drawingml/2006/main" xmlns:r="http://schemas.openxmlformats.org/officeDocument/2006/relationships" xmlns:p="http://schemas.openxmlformats.org/presentationml/2006/main">
-  <p:cSld>
-    <p:spTree>
-      <p:nvGrpSpPr>
-        <p:cNvPr id="1" name=""/>
-        <p:cNvGrpSpPr/>
-        <p:nvPr/>
-      </p:nvGrpSpPr>
-      <p:grpSpPr>
-        <a:xfrm>
-          <a:off x="0" y="0"/>
-          <a:ext cx="0" cy="0"/>
-          <a:chOff x="0" y="0"/>
-          <a:chExt cx="0" cy="0"/>
-        </a:xfrm>
-      </p:grpSpPr>
-      <p:sp>
-        <p:nvSpPr>
-          <p:cNvPr id="5" name="Inhaltsplatzhalter 4">
-            <a:extLst>
-              <a:ext uri="{FF2B5EF4-FFF2-40B4-BE49-F238E27FC236}">
-                <a16:creationId xmlns:a16="http://schemas.microsoft.com/office/drawing/2014/main" id="{67430165-842A-5F14-A591-01F55A119BD9}"/>
-              </a:ext>
-            </a:extLst>
-          </p:cNvPr>
-          <p:cNvSpPr>
-            <a:spLocks noGrp="1"/>
-          </p:cNvSpPr>
-          <p:nvPr>
-            <p:ph idx="1"/>
-          </p:nvPr>
-        </p:nvSpPr>
-        <p:spPr/>
-        <p:txBody>
-          <a:bodyPr/>
-          <a:lstStyle/>
-          <a:p>
-            <a:r>
-              <a:rPr lang="en-US" sz="4000" b="1" dirty="0"/>
-              <a:t>Introduction to FMI</a:t>
-            </a:r>
-            <a:endParaRPr lang="en-US" dirty="0"/>
-          </a:p>
-        </p:txBody>
-      </p:sp>
-      <p:sp>
-        <p:nvSpPr>
-          <p:cNvPr id="4" name="Titel 3">
-            <a:extLst>
-              <a:ext uri="{FF2B5EF4-FFF2-40B4-BE49-F238E27FC236}">
-                <a16:creationId xmlns:a16="http://schemas.microsoft.com/office/drawing/2014/main" id="{B1C8FE56-2E01-097C-45C4-D3BC2A5ADD27}"/>
-              </a:ext>
-            </a:extLst>
-          </p:cNvPr>
-          <p:cNvSpPr>
-            <a:spLocks noGrp="1"/>
-          </p:cNvSpPr>
-          <p:nvPr>
-            <p:ph type="title"/>
-          </p:nvPr>
-        </p:nvSpPr>
-        <p:spPr/>
-        <p:txBody>
-          <a:bodyPr/>
-          <a:lstStyle/>
-          <a:p>
-            <a:r>
-              <a:rPr lang="en-US" dirty="0"/>
-              <a:t> </a:t>
-            </a:r>
-          </a:p>
-        </p:txBody>
-      </p:sp>
-      <p:pic>
-        <p:nvPicPr>
-          <p:cNvPr id="2" name="Picture 4">
-            <a:extLst>
-              <a:ext uri="{FF2B5EF4-FFF2-40B4-BE49-F238E27FC236}">
-                <a16:creationId xmlns:a16="http://schemas.microsoft.com/office/drawing/2014/main" id="{C6F665E4-16E4-89B7-F29E-C5589A9A5087}"/>
-              </a:ext>
-            </a:extLst>
-          </p:cNvPr>
-          <p:cNvPicPr>
-            <a:picLocks noChangeAspect="1"/>
-          </p:cNvPicPr>
-          <p:nvPr/>
-        </p:nvPicPr>
-        <p:blipFill>
-          <a:blip r:embed="rId2">
-            <a:extLst>
-              <a:ext uri="{28A0092B-C50C-407E-A947-70E740481C1C}">
-                <a14:useLocalDpi xmlns:a14="http://schemas.microsoft.com/office/drawing/2010/main" val="0"/>
-              </a:ext>
-            </a:extLst>
-          </a:blip>
-          <a:stretch>
-            <a:fillRect/>
-          </a:stretch>
-        </p:blipFill>
-        <p:spPr>
-          <a:xfrm>
-            <a:off x="620184" y="3130345"/>
-            <a:ext cx="5818812" cy="2378376"/>
-          </a:xfrm>
-          <a:prstGeom prst="rect">
-            <a:avLst/>
-          </a:prstGeom>
-        </p:spPr>
-      </p:pic>
-      <p:sp>
-        <p:nvSpPr>
-          <p:cNvPr id="3" name="TextBox 2">
-            <a:extLst>
-              <a:ext uri="{FF2B5EF4-FFF2-40B4-BE49-F238E27FC236}">
-                <a16:creationId xmlns:a16="http://schemas.microsoft.com/office/drawing/2014/main" id="{D9B8BF98-CDEA-294F-5A40-BA21B6EEF1E0}"/>
-              </a:ext>
-            </a:extLst>
-          </p:cNvPr>
-          <p:cNvSpPr txBox="1"/>
-          <p:nvPr/>
-        </p:nvSpPr>
-        <p:spPr>
-          <a:xfrm>
-            <a:off x="664119" y="2022364"/>
-            <a:ext cx="4823460" cy="646331"/>
-          </a:xfrm>
-          <a:prstGeom prst="rect">
-            <a:avLst/>
-          </a:prstGeom>
-          <a:noFill/>
-        </p:spPr>
-        <p:txBody>
-          <a:bodyPr wrap="square" rtlCol="0">
-            <a:spAutoFit/>
-          </a:bodyPr>
-          <a:lstStyle/>
-          <a:p>
-            <a:r>
-              <a:rPr lang="en-US" sz="1800" dirty="0">
-                <a:solidFill>
-                  <a:srgbClr val="5E676E"/>
-                </a:solidFill>
-                <a:latin typeface="+mn-lt"/>
-                <a:cs typeface="+mn-cs"/>
-              </a:rPr>
-              <a:t>Presenter:</a:t>
-            </a:r>
-            <a:br>
-              <a:rPr lang="en-US" sz="1800" dirty="0">
-                <a:solidFill>
-                  <a:srgbClr val="5E676E"/>
-                </a:solidFill>
-                <a:latin typeface="+mn-lt"/>
-                <a:cs typeface="+mn-cs"/>
-              </a:rPr>
-            </a:br>
-            <a:r>
-              <a:rPr lang="en-US" sz="1800" dirty="0">
-                <a:solidFill>
-                  <a:srgbClr val="5E676E"/>
-                </a:solidFill>
-                <a:latin typeface="+mn-lt"/>
-                <a:cs typeface="+mn-cs"/>
-              </a:rPr>
-              <a:t>Christian Bertsch, Bosch Research</a:t>
-            </a:r>
-          </a:p>
-        </p:txBody>
-      </p:sp>
-      <p:sp>
-        <p:nvSpPr>
-          <p:cNvPr id="7" name="TextBox 4">
-            <a:extLst>
-              <a:ext uri="{FF2B5EF4-FFF2-40B4-BE49-F238E27FC236}">
-                <a16:creationId xmlns:a16="http://schemas.microsoft.com/office/drawing/2014/main" id="{978ADD06-3B1E-7161-A229-C13B73EE0EAF}"/>
-              </a:ext>
-            </a:extLst>
-          </p:cNvPr>
-          <p:cNvSpPr txBox="1"/>
-          <p:nvPr/>
-        </p:nvSpPr>
-        <p:spPr>
-          <a:xfrm>
-            <a:off x="9619757" y="3586701"/>
-            <a:ext cx="2142256" cy="369332"/>
-          </a:xfrm>
-          <a:prstGeom prst="rect">
-            <a:avLst/>
-          </a:prstGeom>
-          <a:noFill/>
-        </p:spPr>
-        <p:txBody>
-          <a:bodyPr wrap="square" rtlCol="0">
-            <a:spAutoFit/>
-          </a:bodyPr>
-          <a:lstStyle/>
-          <a:p>
-            <a:r>
-              <a:rPr lang="en-US" sz="1800" dirty="0">
-                <a:solidFill>
-                  <a:srgbClr val="5E676E"/>
-                </a:solidFill>
-                <a:latin typeface="+mn-lt"/>
-                <a:cs typeface="+mn-cs"/>
-              </a:rPr>
-              <a:t>Online Materials:</a:t>
-            </a:r>
-          </a:p>
-        </p:txBody>
-      </p:sp>
-      <p:sp>
-        <p:nvSpPr>
-          <p:cNvPr id="10" name="TextBox 6">
-            <a:extLst>
-              <a:ext uri="{FF2B5EF4-FFF2-40B4-BE49-F238E27FC236}">
-                <a16:creationId xmlns:a16="http://schemas.microsoft.com/office/drawing/2014/main" id="{029415F6-21ED-FE69-17BC-A2F9B50AC688}"/>
-              </a:ext>
-            </a:extLst>
-          </p:cNvPr>
-          <p:cNvSpPr txBox="1"/>
-          <p:nvPr/>
-        </p:nvSpPr>
-        <p:spPr>
-          <a:xfrm>
-            <a:off x="9619757" y="5961260"/>
-            <a:ext cx="4823460" cy="738664"/>
-          </a:xfrm>
-          <a:prstGeom prst="rect">
-            <a:avLst/>
-          </a:prstGeom>
-          <a:noFill/>
-        </p:spPr>
-        <p:txBody>
-          <a:bodyPr wrap="square" rtlCol="0">
-            <a:spAutoFit/>
-          </a:bodyPr>
-          <a:lstStyle/>
-          <a:p>
-            <a:r>
-              <a:rPr lang="en-US" sz="1200" dirty="0">
-                <a:solidFill>
-                  <a:srgbClr val="5E676E"/>
-                </a:solidFill>
-                <a:latin typeface="+mn-lt"/>
-                <a:cs typeface="+mn-cs"/>
-                <a:hlinkClick r:id="rId3"/>
-              </a:rPr>
-              <a:t>https://github.com/modelica/</a:t>
-            </a:r>
-            <a:br>
-              <a:rPr lang="en-US" sz="1200" dirty="0">
-                <a:solidFill>
-                  <a:srgbClr val="5E676E"/>
-                </a:solidFill>
-                <a:latin typeface="+mn-lt"/>
-                <a:cs typeface="+mn-cs"/>
-                <a:hlinkClick r:id="rId3"/>
-              </a:rPr>
-            </a:br>
-            <a:r>
-              <a:rPr lang="en-US" sz="1200" dirty="0">
-                <a:solidFill>
-                  <a:srgbClr val="5E676E"/>
-                </a:solidFill>
-                <a:latin typeface="+mn-lt"/>
-                <a:cs typeface="+mn-cs"/>
-                <a:hlinkClick r:id="rId3"/>
-              </a:rPr>
-              <a:t>fmi-beginners-tutorial-2024/tree/main</a:t>
-            </a:r>
-            <a:endParaRPr lang="en-US" sz="1200" dirty="0">
-              <a:solidFill>
-                <a:srgbClr val="5E676E"/>
-              </a:solidFill>
-              <a:latin typeface="+mn-lt"/>
-              <a:cs typeface="+mn-cs"/>
-            </a:endParaRPr>
-          </a:p>
-          <a:p>
-            <a:endParaRPr lang="en-US" sz="1800" dirty="0">
-              <a:solidFill>
-                <a:srgbClr val="5E676E"/>
-              </a:solidFill>
-              <a:latin typeface="+mn-lt"/>
-              <a:cs typeface="+mn-cs"/>
-            </a:endParaRPr>
-          </a:p>
-        </p:txBody>
-      </p:sp>
-      <p:pic>
-        <p:nvPicPr>
-          <p:cNvPr id="11" name="Grafik 10">
-            <a:extLst>
-              <a:ext uri="{FF2B5EF4-FFF2-40B4-BE49-F238E27FC236}">
-                <a16:creationId xmlns:a16="http://schemas.microsoft.com/office/drawing/2014/main" id="{85547DFE-87A6-5D51-B6B2-16817869D8DB}"/>
-              </a:ext>
-            </a:extLst>
-          </p:cNvPr>
-          <p:cNvPicPr>
-            <a:picLocks noChangeAspect="1"/>
-          </p:cNvPicPr>
-          <p:nvPr/>
-        </p:nvPicPr>
-        <p:blipFill>
-          <a:blip r:embed="rId4">
-            <a:extLst>
-              <a:ext uri="{28A0092B-C50C-407E-A947-70E740481C1C}">
-                <a14:useLocalDpi xmlns:a14="http://schemas.microsoft.com/office/drawing/2010/main" val="0"/>
-              </a:ext>
-              <a:ext uri="{96DAC541-7B7A-43D3-8B79-37D633B846F1}">
-                <asvg:svgBlip xmlns:asvg="http://schemas.microsoft.com/office/drawing/2016/SVG/main" r:embed="rId5"/>
-              </a:ext>
-            </a:extLst>
-          </a:blip>
-          <a:stretch>
-            <a:fillRect/>
-          </a:stretch>
-        </p:blipFill>
-        <p:spPr>
-          <a:xfrm>
-            <a:off x="9787923" y="4049318"/>
-            <a:ext cx="1974090" cy="1974090"/>
-          </a:xfrm>
-          <a:prstGeom prst="rect">
-            <a:avLst/>
-          </a:prstGeom>
-        </p:spPr>
-      </p:pic>
-    </p:spTree>
-    <p:extLst>
-      <p:ext uri="{BB962C8B-B14F-4D97-AF65-F5344CB8AC3E}">
-        <p14:creationId xmlns:p14="http://schemas.microsoft.com/office/powerpoint/2010/main" val="3567263522"/>
-      </p:ext>
-    </p:extLst>
-  </p:cSld>
-  <p:clrMapOvr>
-    <a:masterClrMapping/>
-  </p:clrMapOvr>
-  <p:transition/>
-</p:sld>
-</file>
-
-<file path=ppt/slides/slide30.xml><?xml version="1.0" encoding="utf-8"?>
+<file path=ppt/slides/slide28.xml><?xml version="1.0" encoding="utf-8"?>
 <p:sld xmlns:a="http://schemas.openxmlformats.org/drawingml/2006/main" xmlns:r="http://schemas.openxmlformats.org/officeDocument/2006/relationships" xmlns:p="http://schemas.openxmlformats.org/presentationml/2006/main">
   <p:cSld>
     <p:spTree>
@@ -15620,7 +14999,7 @@
 </p:sld>
 </file>
 
-<file path=ppt/slides/slide31.xml><?xml version="1.0" encoding="utf-8"?>
+<file path=ppt/slides/slide29.xml><?xml version="1.0" encoding="utf-8"?>
 <p:sld xmlns:a="http://schemas.openxmlformats.org/drawingml/2006/main" xmlns:r="http://schemas.openxmlformats.org/officeDocument/2006/relationships" xmlns:p="http://schemas.openxmlformats.org/presentationml/2006/main">
   <p:cSld>
     <p:spTree>
@@ -17093,7 +16472,350 @@
 </p:sld>
 </file>
 
-<file path=ppt/slides/slide32.xml><?xml version="1.0" encoding="utf-8"?>
+<file path=ppt/slides/slide3.xml><?xml version="1.0" encoding="utf-8"?>
+<p:sld xmlns:a="http://schemas.openxmlformats.org/drawingml/2006/main" xmlns:r="http://schemas.openxmlformats.org/officeDocument/2006/relationships" xmlns:p="http://schemas.openxmlformats.org/presentationml/2006/main">
+  <p:cSld>
+    <p:spTree>
+      <p:nvGrpSpPr>
+        <p:cNvPr id="1" name=""/>
+        <p:cNvGrpSpPr/>
+        <p:nvPr/>
+      </p:nvGrpSpPr>
+      <p:grpSpPr>
+        <a:xfrm>
+          <a:off x="0" y="0"/>
+          <a:ext cx="0" cy="0"/>
+          <a:chOff x="0" y="0"/>
+          <a:chExt cx="0" cy="0"/>
+        </a:xfrm>
+      </p:grpSpPr>
+      <p:sp>
+        <p:nvSpPr>
+          <p:cNvPr id="5" name="Inhaltsplatzhalter 4">
+            <a:extLst>
+              <a:ext uri="{FF2B5EF4-FFF2-40B4-BE49-F238E27FC236}">
+                <a16:creationId xmlns:a16="http://schemas.microsoft.com/office/drawing/2014/main" id="{67430165-842A-5F14-A591-01F55A119BD9}"/>
+              </a:ext>
+            </a:extLst>
+          </p:cNvPr>
+          <p:cNvSpPr>
+            <a:spLocks noGrp="1"/>
+          </p:cNvSpPr>
+          <p:nvPr>
+            <p:ph idx="1"/>
+          </p:nvPr>
+        </p:nvSpPr>
+        <p:spPr/>
+        <p:txBody>
+          <a:bodyPr/>
+          <a:lstStyle/>
+          <a:p>
+            <a:r>
+              <a:rPr lang="en-US" sz="4000" b="1" dirty="0"/>
+              <a:t>Introduction to FMI</a:t>
+            </a:r>
+            <a:endParaRPr lang="en-US" dirty="0"/>
+          </a:p>
+        </p:txBody>
+      </p:sp>
+      <p:sp>
+        <p:nvSpPr>
+          <p:cNvPr id="4" name="Titel 3">
+            <a:extLst>
+              <a:ext uri="{FF2B5EF4-FFF2-40B4-BE49-F238E27FC236}">
+                <a16:creationId xmlns:a16="http://schemas.microsoft.com/office/drawing/2014/main" id="{B1C8FE56-2E01-097C-45C4-D3BC2A5ADD27}"/>
+              </a:ext>
+            </a:extLst>
+          </p:cNvPr>
+          <p:cNvSpPr>
+            <a:spLocks noGrp="1"/>
+          </p:cNvSpPr>
+          <p:nvPr>
+            <p:ph type="title"/>
+          </p:nvPr>
+        </p:nvSpPr>
+        <p:spPr/>
+        <p:txBody>
+          <a:bodyPr/>
+          <a:lstStyle/>
+          <a:p>
+            <a:r>
+              <a:rPr lang="en-US" dirty="0"/>
+              <a:t> </a:t>
+            </a:r>
+          </a:p>
+        </p:txBody>
+      </p:sp>
+      <p:pic>
+        <p:nvPicPr>
+          <p:cNvPr id="2" name="Picture 4">
+            <a:extLst>
+              <a:ext uri="{FF2B5EF4-FFF2-40B4-BE49-F238E27FC236}">
+                <a16:creationId xmlns:a16="http://schemas.microsoft.com/office/drawing/2014/main" id="{C6F665E4-16E4-89B7-F29E-C5589A9A5087}"/>
+              </a:ext>
+            </a:extLst>
+          </p:cNvPr>
+          <p:cNvPicPr>
+            <a:picLocks noChangeAspect="1"/>
+          </p:cNvPicPr>
+          <p:nvPr/>
+        </p:nvPicPr>
+        <p:blipFill>
+          <a:blip r:embed="rId2">
+            <a:extLst>
+              <a:ext uri="{28A0092B-C50C-407E-A947-70E740481C1C}">
+                <a14:useLocalDpi xmlns:a14="http://schemas.microsoft.com/office/drawing/2010/main" val="0"/>
+              </a:ext>
+            </a:extLst>
+          </a:blip>
+          <a:stretch>
+            <a:fillRect/>
+          </a:stretch>
+        </p:blipFill>
+        <p:spPr>
+          <a:xfrm>
+            <a:off x="620184" y="3130345"/>
+            <a:ext cx="5818812" cy="2378376"/>
+          </a:xfrm>
+          <a:prstGeom prst="rect">
+            <a:avLst/>
+          </a:prstGeom>
+        </p:spPr>
+      </p:pic>
+      <p:sp>
+        <p:nvSpPr>
+          <p:cNvPr id="3" name="TextBox 2">
+            <a:extLst>
+              <a:ext uri="{FF2B5EF4-FFF2-40B4-BE49-F238E27FC236}">
+                <a16:creationId xmlns:a16="http://schemas.microsoft.com/office/drawing/2014/main" id="{D9B8BF98-CDEA-294F-5A40-BA21B6EEF1E0}"/>
+              </a:ext>
+            </a:extLst>
+          </p:cNvPr>
+          <p:cNvSpPr txBox="1"/>
+          <p:nvPr/>
+        </p:nvSpPr>
+        <p:spPr>
+          <a:xfrm>
+            <a:off x="664119" y="2022364"/>
+            <a:ext cx="4823460" cy="646331"/>
+          </a:xfrm>
+          <a:prstGeom prst="rect">
+            <a:avLst/>
+          </a:prstGeom>
+          <a:noFill/>
+        </p:spPr>
+        <p:txBody>
+          <a:bodyPr wrap="square" rtlCol="0">
+            <a:spAutoFit/>
+          </a:bodyPr>
+          <a:lstStyle/>
+          <a:p>
+            <a:r>
+              <a:rPr lang="en-US" sz="1800" dirty="0">
+                <a:solidFill>
+                  <a:srgbClr val="5E676E"/>
+                </a:solidFill>
+                <a:latin typeface="+mn-lt"/>
+                <a:cs typeface="+mn-cs"/>
+              </a:rPr>
+              <a:t>Presenter:</a:t>
+            </a:r>
+            <a:br>
+              <a:rPr lang="en-US" sz="1800" dirty="0">
+                <a:solidFill>
+                  <a:srgbClr val="5E676E"/>
+                </a:solidFill>
+                <a:latin typeface="+mn-lt"/>
+                <a:cs typeface="+mn-cs"/>
+              </a:rPr>
+            </a:br>
+            <a:r>
+              <a:rPr lang="en-US" sz="1800" dirty="0">
+                <a:solidFill>
+                  <a:srgbClr val="5E676E"/>
+                </a:solidFill>
+                <a:latin typeface="+mn-lt"/>
+                <a:cs typeface="+mn-cs"/>
+              </a:rPr>
+              <a:t>Christian Bertsch, Bosch Research</a:t>
+            </a:r>
+          </a:p>
+        </p:txBody>
+      </p:sp>
+      <p:sp>
+        <p:nvSpPr>
+          <p:cNvPr id="7" name="TextBox 4">
+            <a:extLst>
+              <a:ext uri="{FF2B5EF4-FFF2-40B4-BE49-F238E27FC236}">
+                <a16:creationId xmlns:a16="http://schemas.microsoft.com/office/drawing/2014/main" id="{978ADD06-3B1E-7161-A229-C13B73EE0EAF}"/>
+              </a:ext>
+            </a:extLst>
+          </p:cNvPr>
+          <p:cNvSpPr txBox="1"/>
+          <p:nvPr/>
+        </p:nvSpPr>
+        <p:spPr>
+          <a:xfrm>
+            <a:off x="9619757" y="3586701"/>
+            <a:ext cx="2142256" cy="369332"/>
+          </a:xfrm>
+          <a:prstGeom prst="rect">
+            <a:avLst/>
+          </a:prstGeom>
+          <a:noFill/>
+        </p:spPr>
+        <p:txBody>
+          <a:bodyPr wrap="square" rtlCol="0">
+            <a:spAutoFit/>
+          </a:bodyPr>
+          <a:lstStyle/>
+          <a:p>
+            <a:r>
+              <a:rPr lang="en-US" sz="1800" dirty="0">
+                <a:solidFill>
+                  <a:srgbClr val="5E676E"/>
+                </a:solidFill>
+                <a:latin typeface="+mn-lt"/>
+                <a:cs typeface="+mn-cs"/>
+              </a:rPr>
+              <a:t>Online Materials:</a:t>
+            </a:r>
+          </a:p>
+        </p:txBody>
+      </p:sp>
+      <p:sp>
+        <p:nvSpPr>
+          <p:cNvPr id="10" name="TextBox 6">
+            <a:extLst>
+              <a:ext uri="{FF2B5EF4-FFF2-40B4-BE49-F238E27FC236}">
+                <a16:creationId xmlns:a16="http://schemas.microsoft.com/office/drawing/2014/main" id="{029415F6-21ED-FE69-17BC-A2F9B50AC688}"/>
+              </a:ext>
+            </a:extLst>
+          </p:cNvPr>
+          <p:cNvSpPr txBox="1"/>
+          <p:nvPr/>
+        </p:nvSpPr>
+        <p:spPr>
+          <a:xfrm>
+            <a:off x="9619757" y="5961260"/>
+            <a:ext cx="4823460" cy="738664"/>
+          </a:xfrm>
+          <a:prstGeom prst="rect">
+            <a:avLst/>
+          </a:prstGeom>
+          <a:noFill/>
+        </p:spPr>
+        <p:txBody>
+          <a:bodyPr wrap="square" rtlCol="0">
+            <a:spAutoFit/>
+          </a:bodyPr>
+          <a:lstStyle/>
+          <a:p>
+            <a:r>
+              <a:rPr lang="en-US" sz="1200" dirty="0">
+                <a:solidFill>
+                  <a:srgbClr val="5E676E"/>
+                </a:solidFill>
+                <a:latin typeface="+mn-lt"/>
+                <a:cs typeface="+mn-cs"/>
+                <a:hlinkClick r:id="rId3"/>
+              </a:rPr>
+              <a:t>https://github.com/modelica/</a:t>
+            </a:r>
+            <a:br>
+              <a:rPr lang="en-US" sz="1200" dirty="0">
+                <a:solidFill>
+                  <a:srgbClr val="5E676E"/>
+                </a:solidFill>
+                <a:latin typeface="+mn-lt"/>
+                <a:cs typeface="+mn-cs"/>
+                <a:hlinkClick r:id="rId3"/>
+              </a:rPr>
+            </a:br>
+            <a:r>
+              <a:rPr lang="en-US" sz="1200" dirty="0">
+                <a:solidFill>
+                  <a:srgbClr val="5E676E"/>
+                </a:solidFill>
+                <a:latin typeface="+mn-lt"/>
+                <a:cs typeface="+mn-cs"/>
+                <a:hlinkClick r:id="rId3"/>
+              </a:rPr>
+              <a:t>fmi-beginners-tutorial-2024/tree/main</a:t>
+            </a:r>
+            <a:endParaRPr lang="en-US" sz="1200" dirty="0">
+              <a:solidFill>
+                <a:srgbClr val="5E676E"/>
+              </a:solidFill>
+              <a:latin typeface="+mn-lt"/>
+              <a:cs typeface="+mn-cs"/>
+            </a:endParaRPr>
+          </a:p>
+          <a:p>
+            <a:endParaRPr lang="en-US" sz="1800" dirty="0">
+              <a:solidFill>
+                <a:srgbClr val="5E676E"/>
+              </a:solidFill>
+              <a:latin typeface="+mn-lt"/>
+              <a:cs typeface="+mn-cs"/>
+            </a:endParaRPr>
+          </a:p>
+        </p:txBody>
+      </p:sp>
+      <p:pic>
+        <p:nvPicPr>
+          <p:cNvPr id="11" name="Grafik 10">
+            <a:extLst>
+              <a:ext uri="{FF2B5EF4-FFF2-40B4-BE49-F238E27FC236}">
+                <a16:creationId xmlns:a16="http://schemas.microsoft.com/office/drawing/2014/main" id="{85547DFE-87A6-5D51-B6B2-16817869D8DB}"/>
+              </a:ext>
+            </a:extLst>
+          </p:cNvPr>
+          <p:cNvPicPr>
+            <a:picLocks noChangeAspect="1"/>
+          </p:cNvPicPr>
+          <p:nvPr/>
+        </p:nvPicPr>
+        <p:blipFill>
+          <a:blip r:embed="rId4">
+            <a:extLst>
+              <a:ext uri="{28A0092B-C50C-407E-A947-70E740481C1C}">
+                <a14:useLocalDpi xmlns:a14="http://schemas.microsoft.com/office/drawing/2010/main" val="0"/>
+              </a:ext>
+              <a:ext uri="{96DAC541-7B7A-43D3-8B79-37D633B846F1}">
+                <asvg:svgBlip xmlns:asvg="http://schemas.microsoft.com/office/drawing/2016/SVG/main" r:embed="rId5"/>
+              </a:ext>
+            </a:extLst>
+          </a:blip>
+          <a:stretch>
+            <a:fillRect/>
+          </a:stretch>
+        </p:blipFill>
+        <p:spPr>
+          <a:xfrm>
+            <a:off x="9787923" y="4049318"/>
+            <a:ext cx="1974090" cy="1974090"/>
+          </a:xfrm>
+          <a:prstGeom prst="rect">
+            <a:avLst/>
+          </a:prstGeom>
+        </p:spPr>
+      </p:pic>
+    </p:spTree>
+    <p:extLst>
+      <p:ext uri="{BB962C8B-B14F-4D97-AF65-F5344CB8AC3E}">
+        <p14:creationId xmlns:p14="http://schemas.microsoft.com/office/powerpoint/2010/main" val="3567263522"/>
+      </p:ext>
+    </p:extLst>
+  </p:cSld>
+  <p:clrMapOvr>
+    <a:masterClrMapping/>
+  </p:clrMapOvr>
+  <p:transition/>
+</p:sld>
+</file>
+
+<file path=ppt/slides/slide30.xml><?xml version="1.0" encoding="utf-8"?>
 <p:sld xmlns:a="http://schemas.openxmlformats.org/drawingml/2006/main" xmlns:r="http://schemas.openxmlformats.org/officeDocument/2006/relationships" xmlns:p="http://schemas.openxmlformats.org/presentationml/2006/main">
   <p:cSld>
     <p:spTree>
@@ -17331,7 +17053,7 @@
 </p:sld>
 </file>
 
-<file path=ppt/slides/slide33.xml><?xml version="1.0" encoding="utf-8"?>
+<file path=ppt/slides/slide31.xml><?xml version="1.0" encoding="utf-8"?>
 <p:sld xmlns:a="http://schemas.openxmlformats.org/drawingml/2006/main" xmlns:r="http://schemas.openxmlformats.org/officeDocument/2006/relationships" xmlns:p="http://schemas.openxmlformats.org/presentationml/2006/main">
   <p:cSld>
     <p:spTree>
@@ -21010,6 +20732,12 @@
 </file>
 
 <file path=customXml/item1.xml><?xml version="1.0" encoding="utf-8"?>
+<p:properties xmlns:p="http://schemas.microsoft.com/office/2006/metadata/properties" xmlns:xsi="http://www.w3.org/2001/XMLSchema-instance" xmlns:pc="http://schemas.microsoft.com/office/infopath/2007/PartnerControls">
+  <documentManagement/>
+</p:properties>
+</file>
+
+<file path=customXml/item2.xml><?xml version="1.0" encoding="utf-8"?>
 <ct:contentTypeSchema xmlns:ct="http://schemas.microsoft.com/office/2006/metadata/contentType" xmlns:ma="http://schemas.microsoft.com/office/2006/metadata/properties/metaAttributes" ct:_="" ma:_="" ma:contentTypeName="Document" ma:contentTypeID="0x0101004E5FCAD8E6222F478CF98AE6458717E4" ma:contentTypeVersion="0" ma:contentTypeDescription="Create a new document." ma:contentTypeScope="" ma:versionID="ae4c969974cdc097ec4092e4953e579e">
   <xsd:schema xmlns:xsd="http://www.w3.org/2001/XMLSchema" xmlns:p="http://schemas.microsoft.com/office/2006/metadata/properties" targetNamespace="http://schemas.microsoft.com/office/2006/metadata/properties" ma:root="true" ma:fieldsID="9684e7e44b4b32ae9d4fdaa413507a5d">
     <xsd:element name="properties">
@@ -21058,13 +20786,22 @@
 </ct:contentTypeSchema>
 </file>
 
-<file path=customXml/item2.xml><?xml version="1.0" encoding="utf-8"?>
-<p:properties xmlns:p="http://schemas.microsoft.com/office/2006/metadata/properties" xmlns:xsi="http://www.w3.org/2001/XMLSchema-instance" xmlns:pc="http://schemas.microsoft.com/office/infopath/2007/PartnerControls">
-  <documentManagement/>
-</p:properties>
+<file path=customXml/itemProps1.xml><?xml version="1.0" encoding="utf-8"?>
+<ds:datastoreItem xmlns:ds="http://schemas.openxmlformats.org/officeDocument/2006/customXml" ds:itemID="{2605D1E8-C791-4C95-A083-CBF3AF871BEC}">
+  <ds:schemaRefs>
+    <ds:schemaRef ds:uri="http://purl.org/dc/terms/"/>
+    <ds:schemaRef ds:uri="http://purl.org/dc/elements/1.1/"/>
+    <ds:schemaRef ds:uri="http://schemas.openxmlformats.org/package/2006/metadata/core-properties"/>
+    <ds:schemaRef ds:uri="http://schemas.microsoft.com/office/2006/documentManagement/types"/>
+    <ds:schemaRef ds:uri="http://schemas.microsoft.com/office/2006/metadata/properties"/>
+    <ds:schemaRef ds:uri="http://www.w3.org/XML/1998/namespace"/>
+    <ds:schemaRef ds:uri="http://purl.org/dc/dcmitype/"/>
+    <ds:schemaRef ds:uri="http://schemas.microsoft.com/office/infopath/2007/PartnerControls"/>
+  </ds:schemaRefs>
+</ds:datastoreItem>
 </file>
 
-<file path=customXml/itemProps1.xml><?xml version="1.0" encoding="utf-8"?>
+<file path=customXml/itemProps2.xml><?xml version="1.0" encoding="utf-8"?>
 <ds:datastoreItem xmlns:ds="http://schemas.openxmlformats.org/officeDocument/2006/customXml" ds:itemID="{D6DDF4F8-48B7-40A7-A044-30F13F7F87CD}">
   <ds:schemaRefs>
     <ds:schemaRef ds:uri="http://schemas.microsoft.com/office/2006/metadata/contentType"/>
@@ -21077,19 +20814,4 @@
     <ds:schemaRef ds:uri="http://schemas.microsoft.com/office/internal/2005/internalDocumentation"/>
   </ds:schemaRefs>
 </ds:datastoreItem>
-</file>
-
-<file path=customXml/itemProps2.xml><?xml version="1.0" encoding="utf-8"?>
-<ds:datastoreItem xmlns:ds="http://schemas.openxmlformats.org/officeDocument/2006/customXml" ds:itemID="{2605D1E8-C791-4C95-A083-CBF3AF871BEC}">
-  <ds:schemaRefs>
-    <ds:schemaRef ds:uri="http://purl.org/dc/terms/"/>
-    <ds:schemaRef ds:uri="http://purl.org/dc/elements/1.1/"/>
-    <ds:schemaRef ds:uri="http://schemas.openxmlformats.org/package/2006/metadata/core-properties"/>
-    <ds:schemaRef ds:uri="http://schemas.microsoft.com/office/2006/documentManagement/types"/>
-    <ds:schemaRef ds:uri="http://schemas.microsoft.com/office/2006/metadata/properties"/>
-    <ds:schemaRef ds:uri="http://www.w3.org/XML/1998/namespace"/>
-    <ds:schemaRef ds:uri="http://purl.org/dc/dcmitype/"/>
-    <ds:schemaRef ds:uri="http://schemas.microsoft.com/office/infopath/2007/PartnerControls"/>
-  </ds:schemaRefs>
-</ds:datastoreItem>
 </file>
</xml_diff>

<commit_message>
update part 1 slides
</commit_message>
<xml_diff>
--- a/part1/Introduction-to-FMI.pptx
+++ b/part1/Introduction-to-FMI.pptx
@@ -5,10 +5,10 @@
     <p:sldMasterId id="2147483649" r:id="rId3"/>
   </p:sldMasterIdLst>
   <p:notesMasterIdLst>
-    <p:notesMasterId r:id="rId35"/>
+    <p:notesMasterId r:id="rId38"/>
   </p:notesMasterIdLst>
   <p:handoutMasterIdLst>
-    <p:handoutMasterId r:id="rId36"/>
+    <p:handoutMasterId r:id="rId39"/>
   </p:handoutMasterIdLst>
   <p:sldIdLst>
     <p:sldId id="314" r:id="rId4"/>
@@ -18,35 +18,38 @@
     <p:sldId id="435" r:id="rId8"/>
     <p:sldId id="437" r:id="rId9"/>
     <p:sldId id="448" r:id="rId10"/>
-    <p:sldId id="440" r:id="rId11"/>
-    <p:sldId id="425" r:id="rId12"/>
-    <p:sldId id="450" r:id="rId13"/>
-    <p:sldId id="438" r:id="rId14"/>
-    <p:sldId id="441" r:id="rId15"/>
-    <p:sldId id="446" r:id="rId16"/>
-    <p:sldId id="451" r:id="rId17"/>
-    <p:sldId id="452" r:id="rId18"/>
-    <p:sldId id="468" r:id="rId19"/>
-    <p:sldId id="475" r:id="rId20"/>
-    <p:sldId id="473" r:id="rId21"/>
-    <p:sldId id="445" r:id="rId22"/>
-    <p:sldId id="457" r:id="rId23"/>
-    <p:sldId id="455" r:id="rId24"/>
-    <p:sldId id="456" r:id="rId25"/>
-    <p:sldId id="464" r:id="rId26"/>
-    <p:sldId id="461" r:id="rId27"/>
-    <p:sldId id="463" r:id="rId28"/>
-    <p:sldId id="462" r:id="rId29"/>
-    <p:sldId id="466" r:id="rId30"/>
-    <p:sldId id="474" r:id="rId31"/>
-    <p:sldId id="471" r:id="rId32"/>
-    <p:sldId id="476" r:id="rId33"/>
-    <p:sldId id="477" r:id="rId34"/>
+    <p:sldId id="499" r:id="rId11"/>
+    <p:sldId id="500" r:id="rId12"/>
+    <p:sldId id="501" r:id="rId13"/>
+    <p:sldId id="440" r:id="rId14"/>
+    <p:sldId id="425" r:id="rId15"/>
+    <p:sldId id="450" r:id="rId16"/>
+    <p:sldId id="438" r:id="rId17"/>
+    <p:sldId id="441" r:id="rId18"/>
+    <p:sldId id="446" r:id="rId19"/>
+    <p:sldId id="451" r:id="rId20"/>
+    <p:sldId id="452" r:id="rId21"/>
+    <p:sldId id="468" r:id="rId22"/>
+    <p:sldId id="475" r:id="rId23"/>
+    <p:sldId id="473" r:id="rId24"/>
+    <p:sldId id="445" r:id="rId25"/>
+    <p:sldId id="457" r:id="rId26"/>
+    <p:sldId id="455" r:id="rId27"/>
+    <p:sldId id="456" r:id="rId28"/>
+    <p:sldId id="464" r:id="rId29"/>
+    <p:sldId id="461" r:id="rId30"/>
+    <p:sldId id="463" r:id="rId31"/>
+    <p:sldId id="462" r:id="rId32"/>
+    <p:sldId id="466" r:id="rId33"/>
+    <p:sldId id="474" r:id="rId34"/>
+    <p:sldId id="471" r:id="rId35"/>
+    <p:sldId id="476" r:id="rId36"/>
+    <p:sldId id="477" r:id="rId37"/>
   </p:sldIdLst>
   <p:sldSz cx="12192000" cy="6858000"/>
   <p:notesSz cx="6858000" cy="9144000"/>
   <p:custDataLst>
-    <p:tags r:id="rId37"/>
+    <p:tags r:id="rId40"/>
   </p:custDataLst>
   <p:defaultTextStyle>
     <a:defPPr>
@@ -585,7 +588,7 @@
               <a:pPr>
                 <a:defRPr/>
               </a:pPr>
-              <a:t>7/24/2025</a:t>
+              <a:t>8/7/2025</a:t>
             </a:fld>
             <a:endParaRPr lang="en-US"/>
           </a:p>
@@ -1091,7 +1094,7 @@
               <a:pPr>
                 <a:defRPr/>
               </a:pPr>
-              <a:t>25</a:t>
+              <a:t>28</a:t>
             </a:fld>
             <a:endParaRPr lang="en-US" altLang="en-US"/>
           </a:p>
@@ -1184,7 +1187,7 @@
               <a:pPr>
                 <a:defRPr/>
               </a:pPr>
-              <a:t>26</a:t>
+              <a:t>29</a:t>
             </a:fld>
             <a:endParaRPr lang="en-US" altLang="en-US"/>
           </a:p>
@@ -4106,6 +4109,1730 @@
       </p:grpSpPr>
       <p:sp>
         <p:nvSpPr>
+          <p:cNvPr id="2" name="Inhaltsplatzhalter 1">
+            <a:extLst>
+              <a:ext uri="{FF2B5EF4-FFF2-40B4-BE49-F238E27FC236}">
+                <a16:creationId xmlns:a16="http://schemas.microsoft.com/office/drawing/2014/main" id="{9E217379-87CA-751E-D14A-FD5615DE7781}"/>
+              </a:ext>
+            </a:extLst>
+          </p:cNvPr>
+          <p:cNvSpPr>
+            <a:spLocks noGrp="1"/>
+          </p:cNvSpPr>
+          <p:nvPr>
+            <p:ph idx="1"/>
+          </p:nvPr>
+        </p:nvSpPr>
+        <p:spPr>
+          <a:xfrm>
+            <a:off x="641138" y="1307272"/>
+            <a:ext cx="7913351" cy="4760007"/>
+          </a:xfrm>
+        </p:spPr>
+        <p:txBody>
+          <a:bodyPr/>
+          <a:lstStyle/>
+          <a:p>
+            <a:r>
+              <a:rPr lang="de-DE" sz="1600" dirty="0"/>
+              <a:t>The development of </a:t>
+            </a:r>
+            <a:r>
+              <a:rPr lang="de-DE" sz="1600" dirty="0" err="1"/>
+              <a:t>the</a:t>
+            </a:r>
+            <a:r>
+              <a:rPr lang="de-DE" sz="1600" dirty="0"/>
+              <a:t> FMI Standard </a:t>
+            </a:r>
+            <a:r>
+              <a:rPr lang="de-DE" sz="1600" dirty="0" err="1"/>
+              <a:t>is</a:t>
+            </a:r>
+            <a:r>
+              <a:rPr lang="de-DE" sz="1600" dirty="0"/>
+              <a:t> </a:t>
+            </a:r>
+            <a:r>
+              <a:rPr lang="de-DE" sz="1600" dirty="0" err="1"/>
+              <a:t>organised</a:t>
+            </a:r>
+            <a:r>
+              <a:rPr lang="de-DE" sz="1600" dirty="0"/>
+              <a:t> </a:t>
+            </a:r>
+            <a:r>
+              <a:rPr lang="de-DE" sz="1600" dirty="0" err="1"/>
+              <a:t>as</a:t>
+            </a:r>
+            <a:r>
+              <a:rPr lang="de-DE" sz="1600" dirty="0"/>
+              <a:t> </a:t>
+            </a:r>
+            <a:r>
+              <a:rPr lang="de-DE" sz="1600" dirty="0" err="1"/>
+              <a:t>the</a:t>
+            </a:r>
+            <a:r>
+              <a:rPr lang="de-DE" sz="1600" dirty="0"/>
+              <a:t> </a:t>
+            </a:r>
+            <a:r>
+              <a:rPr lang="de-DE" sz="1600" dirty="0">
+                <a:hlinkClick r:id="rId2"/>
+              </a:rPr>
+              <a:t>Modelica Association Project</a:t>
+            </a:r>
+            <a:r>
+              <a:rPr lang="de-DE" sz="1600" dirty="0"/>
+              <a:t> </a:t>
+            </a:r>
+            <a:r>
+              <a:rPr lang="de-DE" sz="1600" i="1" dirty="0"/>
+              <a:t>Functional Mock-</a:t>
+            </a:r>
+            <a:r>
+              <a:rPr lang="de-DE" sz="1600" i="1" dirty="0" err="1"/>
+              <a:t>up</a:t>
+            </a:r>
+            <a:r>
+              <a:rPr lang="de-DE" sz="1600" i="1" dirty="0"/>
+              <a:t> Interface</a:t>
+            </a:r>
+            <a:r>
+              <a:rPr lang="de-DE" sz="1600" dirty="0"/>
+              <a:t> </a:t>
+            </a:r>
+            <a:r>
+              <a:rPr lang="de-DE" sz="1600" dirty="0" err="1"/>
+              <a:t>under</a:t>
+            </a:r>
+            <a:r>
+              <a:rPr lang="de-DE" sz="1600" dirty="0"/>
+              <a:t> </a:t>
+            </a:r>
+            <a:r>
+              <a:rPr lang="de-DE" sz="1600" dirty="0" err="1"/>
+              <a:t>the</a:t>
+            </a:r>
+            <a:r>
+              <a:rPr lang="de-DE" sz="1600" dirty="0"/>
+              <a:t> </a:t>
+            </a:r>
+            <a:r>
+              <a:rPr lang="de-DE" sz="1600" dirty="0" err="1"/>
+              <a:t>roof</a:t>
+            </a:r>
+            <a:r>
+              <a:rPr lang="de-DE" sz="1600" dirty="0"/>
+              <a:t> of </a:t>
+            </a:r>
+            <a:r>
+              <a:rPr lang="de-DE" sz="1600" dirty="0" err="1"/>
+              <a:t>the</a:t>
+            </a:r>
+            <a:r>
+              <a:rPr lang="de-DE" sz="1600" dirty="0"/>
+              <a:t> </a:t>
+            </a:r>
+            <a:r>
+              <a:rPr lang="de-DE" sz="1600" dirty="0">
+                <a:hlinkClick r:id="rId3"/>
+              </a:rPr>
+              <a:t>Modelica Association</a:t>
+            </a:r>
+            <a:r>
+              <a:rPr lang="de-DE" sz="1600" dirty="0"/>
+              <a:t>. </a:t>
+            </a:r>
+            <a:r>
+              <a:rPr lang="de-DE" sz="1600" dirty="0" err="1"/>
+              <a:t>It</a:t>
+            </a:r>
+            <a:r>
+              <a:rPr lang="de-DE" sz="1600" dirty="0"/>
+              <a:t> </a:t>
+            </a:r>
+            <a:r>
+              <a:rPr lang="de-DE" sz="1600" dirty="0" err="1"/>
+              <a:t>follows</a:t>
+            </a:r>
+            <a:r>
+              <a:rPr lang="de-DE" sz="1600" dirty="0"/>
+              <a:t> </a:t>
+            </a:r>
+            <a:r>
+              <a:rPr lang="de-DE" sz="1600" dirty="0" err="1"/>
+              <a:t>the</a:t>
+            </a:r>
+            <a:r>
+              <a:rPr lang="de-DE" sz="1600" dirty="0"/>
+              <a:t> </a:t>
+            </a:r>
+            <a:r>
+              <a:rPr lang="de-DE" sz="1600" dirty="0">
+                <a:hlinkClick r:id="rId4"/>
+              </a:rPr>
+              <a:t>Project Rules</a:t>
+            </a:r>
+            <a:r>
+              <a:rPr lang="de-DE" sz="1600" dirty="0"/>
+              <a:t> </a:t>
+            </a:r>
+            <a:r>
+              <a:rPr lang="de-DE" sz="1600" dirty="0" err="1"/>
+              <a:t>approved</a:t>
+            </a:r>
+            <a:r>
+              <a:rPr lang="de-DE" sz="1600" dirty="0"/>
+              <a:t> </a:t>
+            </a:r>
+            <a:r>
+              <a:rPr lang="de-DE" sz="1600" dirty="0" err="1"/>
+              <a:t>by</a:t>
+            </a:r>
+            <a:r>
+              <a:rPr lang="de-DE" sz="1600" dirty="0"/>
+              <a:t> </a:t>
+            </a:r>
+            <a:r>
+              <a:rPr lang="de-DE" sz="1600" dirty="0" err="1"/>
+              <a:t>the</a:t>
+            </a:r>
+            <a:r>
+              <a:rPr lang="de-DE" sz="1600" dirty="0"/>
+              <a:t> FMI Steering Committee.</a:t>
+            </a:r>
+          </a:p>
+          <a:p>
+            <a:r>
+              <a:rPr lang="de-DE" sz="1600" b="1" dirty="0"/>
+              <a:t>Project Leader and Deputy:</a:t>
+            </a:r>
+            <a:br>
+              <a:rPr lang="de-DE" sz="1600" dirty="0"/>
+            </a:br>
+            <a:r>
+              <a:rPr lang="de-DE" sz="1600" dirty="0"/>
+              <a:t>Christian Bertsch (BOSCH) and Torsten Sommer (Dassault </a:t>
+            </a:r>
+            <a:r>
+              <a:rPr lang="de-DE" sz="1600" dirty="0" err="1"/>
+              <a:t>Systèmes</a:t>
+            </a:r>
+            <a:r>
+              <a:rPr lang="de-DE" sz="1600" dirty="0"/>
+              <a:t>) </a:t>
+            </a:r>
+          </a:p>
+          <a:p>
+            <a:r>
+              <a:rPr lang="de-DE" sz="1600" b="1" dirty="0"/>
+              <a:t>Members of </a:t>
+            </a:r>
+            <a:r>
+              <a:rPr lang="de-DE" sz="1600" b="1" dirty="0" err="1"/>
+              <a:t>the</a:t>
+            </a:r>
+            <a:r>
+              <a:rPr lang="de-DE" sz="1600" b="1" dirty="0"/>
+              <a:t> Steering Committee:</a:t>
+            </a:r>
+            <a:br>
+              <a:rPr lang="de-DE" sz="1600" dirty="0"/>
+            </a:br>
+            <a:r>
+              <a:rPr lang="de-DE" sz="1600" dirty="0"/>
+              <a:t>AVL List, BOSCH, Dassault Systemes, dSPACE, ESI Group, Maplesoft, </a:t>
+            </a:r>
+            <a:r>
+              <a:rPr lang="de-DE" sz="1600" dirty="0" err="1"/>
+              <a:t>Modelon</a:t>
+            </a:r>
+            <a:r>
+              <a:rPr lang="de-DE" sz="1600" dirty="0"/>
+              <a:t>, PMSF, Siemens PLM, </a:t>
+            </a:r>
+            <a:r>
+              <a:rPr lang="de-DE" sz="1600" dirty="0" err="1"/>
+              <a:t>Synopsys</a:t>
+            </a:r>
+            <a:endParaRPr lang="de-DE" sz="1600" dirty="0"/>
+          </a:p>
+          <a:p>
+            <a:r>
+              <a:rPr lang="de-DE" sz="1600" b="1" dirty="0"/>
+              <a:t>Further </a:t>
+            </a:r>
+            <a:r>
+              <a:rPr lang="de-DE" sz="1600" b="1" dirty="0" err="1"/>
+              <a:t>Contributing</a:t>
+            </a:r>
+            <a:r>
+              <a:rPr lang="de-DE" sz="1600" b="1" dirty="0"/>
+              <a:t> Members:</a:t>
+            </a:r>
+            <a:br>
+              <a:rPr lang="de-DE" sz="1600" dirty="0"/>
+            </a:br>
+            <a:r>
+              <a:rPr lang="de-DE" sz="1600" dirty="0"/>
+              <a:t>Aarhus University, ABB, Altair, Akkodis, AMEPERE, </a:t>
+            </a:r>
+            <a:r>
+              <a:rPr lang="de-DE" sz="1600" dirty="0" err="1"/>
+              <a:t>Ansys</a:t>
+            </a:r>
+            <a:r>
+              <a:rPr lang="de-DE" sz="1600" dirty="0"/>
+              <a:t>, Augsburg University, Beckhoff, Boeing, Danfoss, DLR, EKS INTEC, ETAS, Fraunhofer IEM, IAV, ITK Engineering, </a:t>
+            </a:r>
+            <a:r>
+              <a:rPr lang="de-DE" sz="1600" dirty="0" err="1"/>
+              <a:t>iVH</a:t>
+            </a:r>
+            <a:r>
+              <a:rPr lang="de-DE" sz="1600" dirty="0"/>
+              <a:t>, </a:t>
+            </a:r>
+            <a:r>
+              <a:rPr lang="de-DE" sz="1600" dirty="0" err="1"/>
+              <a:t>JuliaComputing</a:t>
+            </a:r>
+            <a:r>
+              <a:rPr lang="de-DE" sz="1600" dirty="0"/>
+              <a:t>, LTX, </a:t>
+            </a:r>
+            <a:r>
+              <a:rPr lang="de-DE" sz="1600" dirty="0" err="1"/>
+              <a:t>MachineWare</a:t>
+            </a:r>
+            <a:r>
+              <a:rPr lang="de-DE" sz="1600" dirty="0"/>
+              <a:t>, Renault, Saab Group, Virtual Vehicle Research, Wolfram </a:t>
+            </a:r>
+            <a:r>
+              <a:rPr lang="de-DE" sz="1600" dirty="0" err="1"/>
+              <a:t>MathCore</a:t>
+            </a:r>
+            <a:r>
+              <a:rPr lang="de-DE" sz="1600" dirty="0"/>
+              <a:t> AB, TLK </a:t>
+            </a:r>
+            <a:r>
+              <a:rPr lang="de-DE" sz="1600" dirty="0" err="1"/>
+              <a:t>Thermo</a:t>
+            </a:r>
+            <a:r>
+              <a:rPr lang="de-DE" sz="1600" dirty="0"/>
+              <a:t>, </a:t>
+            </a:r>
+            <a:r>
+              <a:rPr lang="de-DE" sz="1600" dirty="0" err="1"/>
+              <a:t>tracetronic</a:t>
+            </a:r>
+            <a:r>
+              <a:rPr lang="de-DE" sz="1600" dirty="0"/>
+              <a:t>, TU Dresden </a:t>
+            </a:r>
+            <a:r>
+              <a:rPr lang="de-DE" sz="1600" i="1" dirty="0"/>
+              <a:t>and all Steering Committee Members</a:t>
+            </a:r>
+            <a:endParaRPr lang="de-DE" sz="1600" dirty="0"/>
+          </a:p>
+          <a:p>
+            <a:r>
+              <a:rPr lang="de-DE" sz="1600" b="1" dirty="0"/>
+              <a:t>Members of </a:t>
+            </a:r>
+            <a:r>
+              <a:rPr lang="de-DE" sz="1600" b="1" dirty="0" err="1"/>
+              <a:t>the</a:t>
+            </a:r>
+            <a:r>
+              <a:rPr lang="de-DE" sz="1600" b="1" dirty="0"/>
+              <a:t> Advisory Committee:</a:t>
+            </a:r>
+            <a:r>
+              <a:rPr lang="de-DE" sz="1600" dirty="0"/>
+              <a:t> AIRBUS, </a:t>
+            </a:r>
+            <a:r>
+              <a:rPr lang="de-DE" sz="1600" dirty="0" err="1"/>
+              <a:t>blue</a:t>
+            </a:r>
+            <a:r>
+              <a:rPr lang="de-DE" sz="1600" dirty="0"/>
+              <a:t> </a:t>
+            </a:r>
+            <a:r>
+              <a:rPr lang="de-DE" sz="1600" dirty="0" err="1"/>
+              <a:t>automation</a:t>
+            </a:r>
+            <a:r>
+              <a:rPr lang="de-DE" sz="1600" dirty="0"/>
+              <a:t>, </a:t>
+            </a:r>
+            <a:r>
+              <a:rPr lang="de-DE" sz="1600" dirty="0" err="1"/>
+              <a:t>Claytex</a:t>
+            </a:r>
+            <a:r>
+              <a:rPr lang="de-DE" sz="1600" dirty="0"/>
+              <a:t>, COMSOL, DNV, Fraunhofer (IIS/EAS First, SCAI), GM Motorsports, KEB Automation, LBL, NVIDIA, Knorr-Bremse Rail Vehicle Systems, MathWorks, Open Modelica </a:t>
+            </a:r>
+            <a:r>
+              <a:rPr lang="de-DE" sz="1600" dirty="0" err="1"/>
+              <a:t>Consortium</a:t>
+            </a:r>
+            <a:r>
+              <a:rPr lang="de-DE" sz="1600" dirty="0"/>
+              <a:t>, </a:t>
+            </a:r>
+            <a:r>
+              <a:rPr lang="de-DE" sz="1600" dirty="0" err="1"/>
+              <a:t>Samares</a:t>
+            </a:r>
+            <a:r>
+              <a:rPr lang="de-DE" sz="1600" dirty="0"/>
+              <a:t> Engineering, SINTEF </a:t>
+            </a:r>
+            <a:r>
+              <a:rPr lang="de-DE" sz="1600" dirty="0" err="1"/>
+              <a:t>Nordvest</a:t>
+            </a:r>
+            <a:r>
+              <a:rPr lang="de-DE" sz="1600" dirty="0"/>
+              <a:t>, University of Halle, Volkswagen, Volvo </a:t>
+            </a:r>
+            <a:r>
+              <a:rPr lang="de-DE" sz="1600" dirty="0" err="1"/>
+              <a:t>Autonomous</a:t>
+            </a:r>
+            <a:r>
+              <a:rPr lang="de-DE" sz="1600" dirty="0"/>
+              <a:t> Solutions, VTI, </a:t>
+            </a:r>
+            <a:r>
+              <a:rPr lang="de-DE" sz="1600" i="1" dirty="0"/>
+              <a:t>and all </a:t>
+            </a:r>
+            <a:r>
+              <a:rPr lang="de-DE" sz="1600" i="1" dirty="0" err="1"/>
+              <a:t>Contributing</a:t>
+            </a:r>
+            <a:r>
+              <a:rPr lang="de-DE" sz="1600" i="1" dirty="0"/>
+              <a:t> and Steering Committee Members</a:t>
+            </a:r>
+            <a:endParaRPr lang="de-DE" sz="1600" dirty="0"/>
+          </a:p>
+          <a:p>
+            <a:endParaRPr lang="en-US" dirty="0"/>
+          </a:p>
+        </p:txBody>
+      </p:sp>
+      <p:sp>
+        <p:nvSpPr>
+          <p:cNvPr id="3" name="Titel 2">
+            <a:extLst>
+              <a:ext uri="{FF2B5EF4-FFF2-40B4-BE49-F238E27FC236}">
+                <a16:creationId xmlns:a16="http://schemas.microsoft.com/office/drawing/2014/main" id="{F6CFA86B-56DD-21F9-3C2C-305BBCE15D0A}"/>
+              </a:ext>
+            </a:extLst>
+          </p:cNvPr>
+          <p:cNvSpPr>
+            <a:spLocks noGrp="1"/>
+          </p:cNvSpPr>
+          <p:nvPr>
+            <p:ph type="title"/>
+          </p:nvPr>
+        </p:nvSpPr>
+        <p:spPr/>
+        <p:txBody>
+          <a:bodyPr/>
+          <a:lstStyle/>
+          <a:p>
+            <a:r>
+              <a:rPr lang="en-US" dirty="0"/>
+              <a:t>The Modelica Association FMI Project</a:t>
+            </a:r>
+          </a:p>
+        </p:txBody>
+      </p:sp>
+      <p:pic>
+        <p:nvPicPr>
+          <p:cNvPr id="4" name="Grafik 3">
+            <a:extLst>
+              <a:ext uri="{FF2B5EF4-FFF2-40B4-BE49-F238E27FC236}">
+                <a16:creationId xmlns:a16="http://schemas.microsoft.com/office/drawing/2014/main" id="{FAAE9317-C7DE-C82C-9E83-9C191FC7A2C2}"/>
+              </a:ext>
+            </a:extLst>
+          </p:cNvPr>
+          <p:cNvPicPr>
+            <a:picLocks noChangeAspect="1"/>
+          </p:cNvPicPr>
+          <p:nvPr/>
+        </p:nvPicPr>
+        <p:blipFill>
+          <a:blip r:embed="rId5"/>
+          <a:stretch>
+            <a:fillRect/>
+          </a:stretch>
+        </p:blipFill>
+        <p:spPr>
+          <a:xfrm>
+            <a:off x="8671143" y="1026319"/>
+            <a:ext cx="3229142" cy="4122151"/>
+          </a:xfrm>
+          <a:prstGeom prst="rect">
+            <a:avLst/>
+          </a:prstGeom>
+        </p:spPr>
+      </p:pic>
+      <p:pic>
+        <p:nvPicPr>
+          <p:cNvPr id="5" name="Grafik 4">
+            <a:extLst>
+              <a:ext uri="{FF2B5EF4-FFF2-40B4-BE49-F238E27FC236}">
+                <a16:creationId xmlns:a16="http://schemas.microsoft.com/office/drawing/2014/main" id="{B4FDEEC6-E8BF-AD55-00CE-83F795FC8956}"/>
+              </a:ext>
+            </a:extLst>
+          </p:cNvPr>
+          <p:cNvPicPr>
+            <a:picLocks noChangeAspect="1"/>
+          </p:cNvPicPr>
+          <p:nvPr/>
+        </p:nvPicPr>
+        <p:blipFill rotWithShape="1">
+          <a:blip r:embed="rId6">
+            <a:extLst>
+              <a:ext uri="{28A0092B-C50C-407E-A947-70E740481C1C}">
+                <a14:useLocalDpi xmlns:a14="http://schemas.microsoft.com/office/drawing/2010/main" val="0"/>
+              </a:ext>
+            </a:extLst>
+          </a:blip>
+          <a:srcRect t="19676" b="29147"/>
+          <a:stretch/>
+        </p:blipFill>
+        <p:spPr>
+          <a:xfrm>
+            <a:off x="10575156" y="5697546"/>
+            <a:ext cx="1085561" cy="555555"/>
+          </a:xfrm>
+          <a:prstGeom prst="rect">
+            <a:avLst/>
+          </a:prstGeom>
+        </p:spPr>
+      </p:pic>
+      <p:sp>
+        <p:nvSpPr>
+          <p:cNvPr id="6" name="Textfeld 5">
+            <a:extLst>
+              <a:ext uri="{FF2B5EF4-FFF2-40B4-BE49-F238E27FC236}">
+                <a16:creationId xmlns:a16="http://schemas.microsoft.com/office/drawing/2014/main" id="{9207D1A2-75B3-8A8B-F189-3FB32A37A78B}"/>
+              </a:ext>
+            </a:extLst>
+          </p:cNvPr>
+          <p:cNvSpPr txBox="1"/>
+          <p:nvPr/>
+        </p:nvSpPr>
+        <p:spPr>
+          <a:xfrm>
+            <a:off x="9143114" y="5754626"/>
+            <a:ext cx="1351221" cy="400110"/>
+          </a:xfrm>
+          <a:prstGeom prst="rect">
+            <a:avLst/>
+          </a:prstGeom>
+          <a:noFill/>
+        </p:spPr>
+        <p:txBody>
+          <a:bodyPr wrap="square">
+            <a:spAutoFit/>
+          </a:bodyPr>
+          <a:lstStyle>
+            <a:defPPr>
+              <a:defRPr lang="de-DE"/>
+            </a:defPPr>
+            <a:lvl1pPr>
+              <a:defRPr b="1"/>
+            </a:lvl1pPr>
+          </a:lstStyle>
+          <a:p>
+            <a:pPr marL="0" marR="0" lvl="0" indent="0" algn="l" defTabSz="914400" rtl="0" eaLnBrk="0" fontAlgn="base" latinLnBrk="0" hangingPunct="0">
+              <a:lnSpc>
+                <a:spcPct val="100000"/>
+              </a:lnSpc>
+              <a:spcBef>
+                <a:spcPct val="0"/>
+              </a:spcBef>
+              <a:spcAft>
+                <a:spcPct val="0"/>
+              </a:spcAft>
+              <a:buClrTx/>
+              <a:buSzTx/>
+              <a:buFontTx/>
+              <a:buNone/>
+              <a:tabLst/>
+              <a:defRPr/>
+            </a:pPr>
+            <a:r>
+              <a:rPr kumimoji="0" lang="en-US" sz="2000" b="0" i="0" u="none" strike="noStrike" kern="1200" cap="none" spc="0" normalizeH="0" baseline="0" noProof="0" dirty="0">
+                <a:ln>
+                  <a:noFill/>
+                </a:ln>
+                <a:solidFill>
+                  <a:srgbClr val="5E676E"/>
+                </a:solidFill>
+                <a:effectLst/>
+                <a:uLnTx/>
+                <a:uFillTx/>
+                <a:latin typeface="Arial"/>
+                <a:ea typeface="+mn-ea"/>
+                <a:cs typeface="Arial" panose="020B0604020202020204" pitchFamily="34" charset="0"/>
+              </a:rPr>
+              <a:t>within  the </a:t>
+            </a:r>
+            <a:endParaRPr kumimoji="0" lang="en-US" sz="1600" b="0" i="0" u="none" strike="noStrike" kern="1200" cap="none" spc="0" normalizeH="0" baseline="0" noProof="0" dirty="0">
+              <a:ln>
+                <a:noFill/>
+              </a:ln>
+              <a:solidFill>
+                <a:srgbClr val="120C80"/>
+              </a:solidFill>
+              <a:effectLst/>
+              <a:uLnTx/>
+              <a:uFillTx/>
+              <a:latin typeface="Arial" panose="020B0604020202020204" pitchFamily="34" charset="0"/>
+              <a:ea typeface="+mn-ea"/>
+              <a:cs typeface="Arial" panose="020B0604020202020204" pitchFamily="34" charset="0"/>
+            </a:endParaRPr>
+          </a:p>
+        </p:txBody>
+      </p:sp>
+      <p:sp>
+        <p:nvSpPr>
+          <p:cNvPr id="7" name="Rectangle 6">
+            <a:extLst>
+              <a:ext uri="{FF2B5EF4-FFF2-40B4-BE49-F238E27FC236}">
+                <a16:creationId xmlns:a16="http://schemas.microsoft.com/office/drawing/2014/main" id="{A5336A7B-88C6-BF45-64AD-2A7149E2DCB2}"/>
+              </a:ext>
+            </a:extLst>
+          </p:cNvPr>
+          <p:cNvSpPr/>
+          <p:nvPr/>
+        </p:nvSpPr>
+        <p:spPr>
+          <a:xfrm>
+            <a:off x="0" y="6379297"/>
+            <a:ext cx="4629150" cy="326303"/>
+          </a:xfrm>
+          <a:prstGeom prst="rect">
+            <a:avLst/>
+          </a:prstGeom>
+          <a:solidFill>
+            <a:srgbClr val="FFFFFF"/>
+          </a:solidFill>
+          <a:ln>
+            <a:noFill/>
+          </a:ln>
+        </p:spPr>
+        <p:style>
+          <a:lnRef idx="2">
+            <a:schemeClr val="dk1">
+              <a:shade val="15000"/>
+            </a:schemeClr>
+          </a:lnRef>
+          <a:fillRef idx="1">
+            <a:schemeClr val="dk1"/>
+          </a:fillRef>
+          <a:effectRef idx="0">
+            <a:schemeClr val="dk1"/>
+          </a:effectRef>
+          <a:fontRef idx="minor">
+            <a:schemeClr val="lt1"/>
+          </a:fontRef>
+        </p:style>
+        <p:txBody>
+          <a:bodyPr rtlCol="0" anchor="ctr"/>
+          <a:lstStyle/>
+          <a:p>
+            <a:pPr algn="ctr"/>
+            <a:r>
+              <a:rPr lang="de-DE" sz="1000" dirty="0">
+                <a:solidFill>
+                  <a:srgbClr val="C00000"/>
+                </a:solidFill>
+              </a:rPr>
+              <a:t>© 2025 Modelica </a:t>
+            </a:r>
+            <a:r>
+              <a:rPr lang="de-DE" sz="1000" dirty="0" err="1">
+                <a:solidFill>
+                  <a:srgbClr val="C00000"/>
+                </a:solidFill>
+              </a:rPr>
+              <a:t>Association</a:t>
+            </a:r>
+            <a:r>
+              <a:rPr lang="de-DE" sz="1000" dirty="0">
+                <a:solidFill>
+                  <a:srgbClr val="C00000"/>
+                </a:solidFill>
+              </a:rPr>
+              <a:t> Project FMI | fmi-standard.org</a:t>
+            </a:r>
+          </a:p>
+        </p:txBody>
+      </p:sp>
+    </p:spTree>
+    <p:extLst>
+      <p:ext uri="{BB962C8B-B14F-4D97-AF65-F5344CB8AC3E}">
+        <p14:creationId xmlns:p14="http://schemas.microsoft.com/office/powerpoint/2010/main" val="3862228329"/>
+      </p:ext>
+    </p:extLst>
+  </p:cSld>
+  <p:clrMapOvr>
+    <a:masterClrMapping/>
+  </p:clrMapOvr>
+  <p:transition/>
+</p:sld>
+</file>
+
+<file path=ppt/slides/slide11.xml><?xml version="1.0" encoding="utf-8"?>
+<p:sld xmlns:a="http://schemas.openxmlformats.org/drawingml/2006/main" xmlns:r="http://schemas.openxmlformats.org/officeDocument/2006/relationships" xmlns:p="http://schemas.openxmlformats.org/presentationml/2006/main">
+  <p:cSld>
+    <p:bg>
+      <p:bgPr>
+        <a:solidFill>
+          <a:schemeClr val="accent5"/>
+        </a:solidFill>
+        <a:effectLst/>
+      </p:bgPr>
+    </p:bg>
+    <p:spTree>
+      <p:nvGrpSpPr>
+        <p:cNvPr id="1" name=""/>
+        <p:cNvGrpSpPr/>
+        <p:nvPr/>
+      </p:nvGrpSpPr>
+      <p:grpSpPr>
+        <a:xfrm>
+          <a:off x="0" y="0"/>
+          <a:ext cx="0" cy="0"/>
+          <a:chOff x="0" y="0"/>
+          <a:chExt cx="0" cy="0"/>
+        </a:xfrm>
+      </p:grpSpPr>
+      <p:sp>
+        <p:nvSpPr>
+          <p:cNvPr id="2" name="Inhaltsplatzhalter 1">
+            <a:extLst>
+              <a:ext uri="{FF2B5EF4-FFF2-40B4-BE49-F238E27FC236}">
+                <a16:creationId xmlns:a16="http://schemas.microsoft.com/office/drawing/2014/main" id="{0942DFE2-B8E9-A1D6-3FAF-EB02B96DC61F}"/>
+              </a:ext>
+            </a:extLst>
+          </p:cNvPr>
+          <p:cNvSpPr>
+            <a:spLocks noGrp="1"/>
+          </p:cNvSpPr>
+          <p:nvPr>
+            <p:ph idx="1"/>
+          </p:nvPr>
+        </p:nvSpPr>
+        <p:spPr/>
+        <p:txBody>
+          <a:bodyPr/>
+          <a:lstStyle/>
+          <a:p>
+            <a:r>
+              <a:rPr lang="en-US" sz="4000" b="1" dirty="0"/>
+              <a:t>FMI: Technical Fundamentals</a:t>
+            </a:r>
+          </a:p>
+          <a:p>
+            <a:endParaRPr lang="en-US" sz="4000" b="1" dirty="0"/>
+          </a:p>
+          <a:p>
+            <a:r>
+              <a:rPr lang="en-US" sz="4000" i="1" dirty="0"/>
+              <a:t>“How does FMI work?”</a:t>
+            </a:r>
+          </a:p>
+        </p:txBody>
+      </p:sp>
+      <p:sp>
+        <p:nvSpPr>
+          <p:cNvPr id="3" name="Titel 2">
+            <a:extLst>
+              <a:ext uri="{FF2B5EF4-FFF2-40B4-BE49-F238E27FC236}">
+                <a16:creationId xmlns:a16="http://schemas.microsoft.com/office/drawing/2014/main" id="{EF0451EF-4275-B5F4-7844-13C179D59EED}"/>
+              </a:ext>
+            </a:extLst>
+          </p:cNvPr>
+          <p:cNvSpPr>
+            <a:spLocks noGrp="1"/>
+          </p:cNvSpPr>
+          <p:nvPr>
+            <p:ph type="title"/>
+          </p:nvPr>
+        </p:nvSpPr>
+        <p:spPr/>
+        <p:txBody>
+          <a:bodyPr/>
+          <a:lstStyle/>
+          <a:p>
+            <a:r>
+              <a:rPr lang="en-US" dirty="0"/>
+              <a:t> </a:t>
+            </a:r>
+          </a:p>
+        </p:txBody>
+      </p:sp>
+    </p:spTree>
+    <p:extLst>
+      <p:ext uri="{BB962C8B-B14F-4D97-AF65-F5344CB8AC3E}">
+        <p14:creationId xmlns:p14="http://schemas.microsoft.com/office/powerpoint/2010/main" val="3325233337"/>
+      </p:ext>
+    </p:extLst>
+  </p:cSld>
+  <p:clrMapOvr>
+    <a:masterClrMapping/>
+  </p:clrMapOvr>
+  <p:transition/>
+</p:sld>
+</file>
+
+<file path=ppt/slides/slide12.xml><?xml version="1.0" encoding="utf-8"?>
+<p:sld xmlns:a="http://schemas.openxmlformats.org/drawingml/2006/main" xmlns:r="http://schemas.openxmlformats.org/officeDocument/2006/relationships" xmlns:p="http://schemas.openxmlformats.org/presentationml/2006/main">
+  <p:cSld>
+    <p:spTree>
+      <p:nvGrpSpPr>
+        <p:cNvPr id="1" name=""/>
+        <p:cNvGrpSpPr/>
+        <p:nvPr/>
+      </p:nvGrpSpPr>
+      <p:grpSpPr>
+        <a:xfrm>
+          <a:off x="0" y="0"/>
+          <a:ext cx="0" cy="0"/>
+          <a:chOff x="0" y="0"/>
+          <a:chExt cx="0" cy="0"/>
+        </a:xfrm>
+      </p:grpSpPr>
+      <p:sp>
+        <p:nvSpPr>
+          <p:cNvPr id="2" name="Inhaltsplatzhalter 1">
+            <a:extLst>
+              <a:ext uri="{FF2B5EF4-FFF2-40B4-BE49-F238E27FC236}">
+                <a16:creationId xmlns:a16="http://schemas.microsoft.com/office/drawing/2014/main" id="{6E30A60D-6EC1-A8E9-1E69-3CE6DED3015B}"/>
+              </a:ext>
+            </a:extLst>
+          </p:cNvPr>
+          <p:cNvSpPr>
+            <a:spLocks noGrp="1"/>
+          </p:cNvSpPr>
+          <p:nvPr>
+            <p:ph idx="1"/>
+          </p:nvPr>
+        </p:nvSpPr>
+        <p:spPr/>
+        <p:txBody>
+          <a:bodyPr/>
+          <a:lstStyle/>
+          <a:p>
+            <a:r>
+              <a:rPr lang="en-US" dirty="0"/>
+              <a:t> </a:t>
+            </a:r>
+          </a:p>
+        </p:txBody>
+      </p:sp>
+      <p:sp>
+        <p:nvSpPr>
+          <p:cNvPr id="3" name="Titel 2">
+            <a:extLst>
+              <a:ext uri="{FF2B5EF4-FFF2-40B4-BE49-F238E27FC236}">
+                <a16:creationId xmlns:a16="http://schemas.microsoft.com/office/drawing/2014/main" id="{D6192EB5-44BC-97D1-4460-5710216A5101}"/>
+              </a:ext>
+            </a:extLst>
+          </p:cNvPr>
+          <p:cNvSpPr>
+            <a:spLocks noGrp="1"/>
+          </p:cNvSpPr>
+          <p:nvPr>
+            <p:ph type="title"/>
+          </p:nvPr>
+        </p:nvSpPr>
+        <p:spPr/>
+        <p:txBody>
+          <a:bodyPr/>
+          <a:lstStyle/>
+          <a:p>
+            <a:r>
+              <a:rPr lang="en-US" dirty="0"/>
+              <a:t>Exporting vs. Importing tool</a:t>
+            </a:r>
+          </a:p>
+        </p:txBody>
+      </p:sp>
+      <p:sp>
+        <p:nvSpPr>
+          <p:cNvPr id="138" name="TextBox 156">
+            <a:extLst>
+              <a:ext uri="{FF2B5EF4-FFF2-40B4-BE49-F238E27FC236}">
+                <a16:creationId xmlns:a16="http://schemas.microsoft.com/office/drawing/2014/main" id="{45E3F80A-360F-F324-4396-74ED16B437AC}"/>
+              </a:ext>
+            </a:extLst>
+          </p:cNvPr>
+          <p:cNvSpPr txBox="1"/>
+          <p:nvPr/>
+        </p:nvSpPr>
+        <p:spPr>
+          <a:xfrm>
+            <a:off x="6297810" y="2540427"/>
+            <a:ext cx="4977973" cy="323236"/>
+          </a:xfrm>
+          <a:prstGeom prst="rect">
+            <a:avLst/>
+          </a:prstGeom>
+          <a:noFill/>
+        </p:spPr>
+        <p:txBody>
+          <a:bodyPr wrap="square" lIns="0" tIns="0" rIns="0" bIns="0" rtlCol="0">
+            <a:noAutofit/>
+          </a:bodyPr>
+          <a:lstStyle/>
+          <a:p>
+            <a:pPr marL="228600" marR="0" indent="-228600" defTabSz="914400" eaLnBrk="1" fontAlgn="auto" latinLnBrk="0" hangingPunct="1">
+              <a:lnSpc>
+                <a:spcPts val="2300"/>
+              </a:lnSpc>
+              <a:spcBef>
+                <a:spcPts val="500"/>
+              </a:spcBef>
+              <a:spcAft>
+                <a:spcPts val="0"/>
+              </a:spcAft>
+              <a:buClrTx/>
+              <a:buSzTx/>
+              <a:buFont typeface="+mj-lt"/>
+              <a:buAutoNum type="arabicPeriod" startAt="2"/>
+              <a:tabLst/>
+            </a:pPr>
+            <a:r>
+              <a:rPr kumimoji="0" lang="en-US" b="0" i="0" u="none" strike="noStrike" kern="0" cap="none" spc="0" normalizeH="0" baseline="0" noProof="0" dirty="0">
+                <a:ln>
+                  <a:noFill/>
+                </a:ln>
+                <a:solidFill>
+                  <a:srgbClr val="000000"/>
+                </a:solidFill>
+                <a:effectLst/>
+                <a:uLnTx/>
+                <a:uFillTx/>
+              </a:rPr>
+              <a:t>export as </a:t>
+            </a:r>
+            <a:r>
+              <a:rPr kumimoji="0" lang="en-US" b="1" i="0" u="none" strike="noStrike" kern="0" cap="none" spc="0" normalizeH="0" baseline="0" noProof="0" dirty="0">
+                <a:ln>
+                  <a:noFill/>
+                </a:ln>
+                <a:solidFill>
+                  <a:srgbClr val="000000"/>
+                </a:solidFill>
+                <a:effectLst/>
+                <a:uLnTx/>
+                <a:uFillTx/>
+              </a:rPr>
+              <a:t>Functional Mockup Unit (FMU)</a:t>
+            </a:r>
+            <a:r>
+              <a:rPr kumimoji="0" lang="en-US" b="0" i="0" u="none" strike="noStrike" kern="0" cap="none" spc="0" normalizeH="0" baseline="0" noProof="0" dirty="0">
+                <a:ln>
+                  <a:noFill/>
+                </a:ln>
+                <a:solidFill>
+                  <a:srgbClr val="000000"/>
+                </a:solidFill>
+                <a:effectLst/>
+                <a:uLnTx/>
+                <a:uFillTx/>
+              </a:rPr>
+              <a:t> according</a:t>
+            </a:r>
+            <a:r>
+              <a:rPr lang="en-US" kern="0" dirty="0">
+                <a:solidFill>
+                  <a:srgbClr val="000000"/>
+                </a:solidFill>
+              </a:rPr>
+              <a:t>g to the </a:t>
+            </a:r>
+            <a:r>
+              <a:rPr lang="en-US" b="1" kern="0" dirty="0">
+                <a:solidFill>
+                  <a:srgbClr val="000000"/>
+                </a:solidFill>
+              </a:rPr>
+              <a:t>FMI Standard</a:t>
+            </a:r>
+            <a:endParaRPr kumimoji="0" lang="en-US" b="1" i="0" u="none" strike="noStrike" kern="0" cap="none" spc="0" normalizeH="0" baseline="0" noProof="0" dirty="0">
+              <a:ln>
+                <a:noFill/>
+              </a:ln>
+              <a:solidFill>
+                <a:srgbClr val="000000"/>
+              </a:solidFill>
+              <a:effectLst/>
+              <a:uLnTx/>
+              <a:uFillTx/>
+            </a:endParaRPr>
+          </a:p>
+        </p:txBody>
+      </p:sp>
+      <p:cxnSp>
+        <p:nvCxnSpPr>
+          <p:cNvPr id="139" name="Straight Arrow Connector 160">
+            <a:extLst>
+              <a:ext uri="{FF2B5EF4-FFF2-40B4-BE49-F238E27FC236}">
+                <a16:creationId xmlns:a16="http://schemas.microsoft.com/office/drawing/2014/main" id="{EFDD8117-50B2-D754-4320-F9C53BA7EC34}"/>
+              </a:ext>
+            </a:extLst>
+          </p:cNvPr>
+          <p:cNvCxnSpPr>
+            <a:cxnSpLocks/>
+            <a:endCxn id="141" idx="0"/>
+          </p:cNvCxnSpPr>
+          <p:nvPr/>
+        </p:nvCxnSpPr>
+        <p:spPr>
+          <a:xfrm>
+            <a:off x="5698783" y="3203115"/>
+            <a:ext cx="0" cy="309022"/>
+          </a:xfrm>
+          <a:prstGeom prst="straightConnector1">
+            <a:avLst/>
+          </a:prstGeom>
+          <a:ln>
+            <a:solidFill>
+              <a:schemeClr val="accent1"/>
+            </a:solidFill>
+            <a:tailEnd type="triangle"/>
+          </a:ln>
+        </p:spPr>
+        <p:style>
+          <a:lnRef idx="1">
+            <a:srgbClr val="007BC0"/>
+          </a:lnRef>
+          <a:fillRef idx="0">
+            <a:srgbClr val="007BC0"/>
+          </a:fillRef>
+          <a:effectRef idx="0">
+            <a:srgbClr val="007BC0"/>
+          </a:effectRef>
+          <a:fontRef idx="minor">
+            <a:schemeClr val="tx1"/>
+          </a:fontRef>
+        </p:style>
+      </p:cxnSp>
+      <p:sp>
+        <p:nvSpPr>
+          <p:cNvPr id="140" name="TextBox 165">
+            <a:extLst>
+              <a:ext uri="{FF2B5EF4-FFF2-40B4-BE49-F238E27FC236}">
+                <a16:creationId xmlns:a16="http://schemas.microsoft.com/office/drawing/2014/main" id="{B9A767D2-96C5-D46E-C2FA-20A8514CFAA9}"/>
+              </a:ext>
+            </a:extLst>
+          </p:cNvPr>
+          <p:cNvSpPr txBox="1"/>
+          <p:nvPr/>
+        </p:nvSpPr>
+        <p:spPr>
+          <a:xfrm>
+            <a:off x="6297810" y="2093694"/>
+            <a:ext cx="4265669" cy="328916"/>
+          </a:xfrm>
+          <a:prstGeom prst="rect">
+            <a:avLst/>
+          </a:prstGeom>
+          <a:noFill/>
+        </p:spPr>
+        <p:txBody>
+          <a:bodyPr wrap="square" lIns="0" tIns="0" rIns="0" bIns="0" rtlCol="0">
+            <a:noAutofit/>
+          </a:bodyPr>
+          <a:lstStyle/>
+          <a:p>
+            <a:pPr marL="228600" marR="0" indent="-228600" defTabSz="914400" eaLnBrk="1" fontAlgn="auto" latinLnBrk="0" hangingPunct="1">
+              <a:lnSpc>
+                <a:spcPts val="2300"/>
+              </a:lnSpc>
+              <a:spcBef>
+                <a:spcPts val="500"/>
+              </a:spcBef>
+              <a:spcAft>
+                <a:spcPts val="0"/>
+              </a:spcAft>
+              <a:buClrTx/>
+              <a:buSzTx/>
+              <a:buFont typeface="+mj-lt"/>
+              <a:buAutoNum type="arabicPeriod"/>
+              <a:tabLst/>
+            </a:pPr>
+            <a:r>
+              <a:rPr lang="en-US" kern="0" dirty="0">
+                <a:solidFill>
+                  <a:srgbClr val="000000"/>
+                </a:solidFill>
+              </a:rPr>
+              <a:t>develop model</a:t>
+            </a:r>
+            <a:endParaRPr kumimoji="0" lang="en-US" b="0" i="0" u="none" strike="noStrike" kern="0" cap="none" spc="0" normalizeH="0" baseline="0" noProof="0" dirty="0">
+              <a:ln>
+                <a:noFill/>
+              </a:ln>
+              <a:solidFill>
+                <a:srgbClr val="000000"/>
+              </a:solidFill>
+              <a:effectLst/>
+              <a:uLnTx/>
+              <a:uFillTx/>
+            </a:endParaRPr>
+          </a:p>
+        </p:txBody>
+      </p:sp>
+      <p:sp>
+        <p:nvSpPr>
+          <p:cNvPr id="141" name="Rectangle 8">
+            <a:extLst>
+              <a:ext uri="{FF2B5EF4-FFF2-40B4-BE49-F238E27FC236}">
+                <a16:creationId xmlns:a16="http://schemas.microsoft.com/office/drawing/2014/main" id="{2064C99B-969F-48AC-1571-860BF13D81F4}"/>
+              </a:ext>
+            </a:extLst>
+          </p:cNvPr>
+          <p:cNvSpPr/>
+          <p:nvPr/>
+        </p:nvSpPr>
+        <p:spPr>
+          <a:xfrm>
+            <a:off x="5295195" y="3512137"/>
+            <a:ext cx="807175" cy="346965"/>
+          </a:xfrm>
+          <a:prstGeom prst="rect">
+            <a:avLst/>
+          </a:prstGeom>
+          <a:solidFill>
+            <a:schemeClr val="accent6">
+              <a:lumMod val="75000"/>
+            </a:schemeClr>
+          </a:solidFill>
+          <a:ln w="28575" cap="flat" cmpd="sng" algn="ctr">
+            <a:solidFill>
+              <a:schemeClr val="bg1"/>
+            </a:solidFill>
+            <a:prstDash val="solid"/>
+          </a:ln>
+          <a:effectLst/>
+        </p:spPr>
+        <p:txBody>
+          <a:bodyPr rtlCol="0" anchor="ctr"/>
+          <a:lstStyle/>
+          <a:p>
+            <a:pPr marL="0" marR="0" indent="0" algn="ctr" defTabSz="914400" eaLnBrk="1" fontAlgn="auto" latinLnBrk="0" hangingPunct="1">
+              <a:lnSpc>
+                <a:spcPct val="100000"/>
+              </a:lnSpc>
+              <a:spcBef>
+                <a:spcPts val="0"/>
+              </a:spcBef>
+              <a:spcAft>
+                <a:spcPts val="0"/>
+              </a:spcAft>
+              <a:buClrTx/>
+              <a:buSzTx/>
+              <a:buFontTx/>
+              <a:buNone/>
+              <a:tabLst/>
+            </a:pPr>
+            <a:r>
+              <a:rPr kumimoji="0" lang="en-US" sz="1800" b="0" i="0" u="none" strike="noStrike" kern="0" cap="none" spc="0" normalizeH="0" baseline="0" noProof="0" dirty="0">
+                <a:ln>
+                  <a:noFill/>
+                </a:ln>
+                <a:solidFill>
+                  <a:srgbClr val="FFFFFF"/>
+                </a:solidFill>
+                <a:effectLst/>
+                <a:uLnTx/>
+                <a:uFillTx/>
+                <a:latin typeface="+mn-lt"/>
+                <a:ea typeface="+mn-ea"/>
+                <a:cs typeface="+mn-cs"/>
+              </a:rPr>
+              <a:t>FMU</a:t>
+            </a:r>
+          </a:p>
+        </p:txBody>
+      </p:sp>
+      <p:sp>
+        <p:nvSpPr>
+          <p:cNvPr id="144" name="TextBox 173">
+            <a:extLst>
+              <a:ext uri="{FF2B5EF4-FFF2-40B4-BE49-F238E27FC236}">
+                <a16:creationId xmlns:a16="http://schemas.microsoft.com/office/drawing/2014/main" id="{B3ABB214-0855-F674-1A1A-109FAC2964D4}"/>
+              </a:ext>
+            </a:extLst>
+          </p:cNvPr>
+          <p:cNvSpPr txBox="1"/>
+          <p:nvPr/>
+        </p:nvSpPr>
+        <p:spPr>
+          <a:xfrm>
+            <a:off x="2526120" y="4377669"/>
+            <a:ext cx="2405109" cy="891017"/>
+          </a:xfrm>
+          <a:prstGeom prst="rect">
+            <a:avLst/>
+          </a:prstGeom>
+          <a:noFill/>
+        </p:spPr>
+        <p:txBody>
+          <a:bodyPr wrap="square" lIns="0" tIns="0" rIns="0" bIns="0" rtlCol="0">
+            <a:noAutofit/>
+          </a:bodyPr>
+          <a:lstStyle/>
+          <a:p>
+            <a:pPr marL="228600" marR="0" indent="-228600" defTabSz="914400" eaLnBrk="1" fontAlgn="auto" latinLnBrk="0" hangingPunct="1">
+              <a:lnSpc>
+                <a:spcPts val="2300"/>
+              </a:lnSpc>
+              <a:spcBef>
+                <a:spcPts val="500"/>
+              </a:spcBef>
+              <a:spcAft>
+                <a:spcPts val="0"/>
+              </a:spcAft>
+              <a:buClrTx/>
+              <a:buSzTx/>
+              <a:buFont typeface="+mj-lt"/>
+              <a:buAutoNum type="arabicPeriod" startAt="3"/>
+              <a:tabLst/>
+            </a:pPr>
+            <a:r>
+              <a:rPr kumimoji="0" lang="en-US" b="1" i="0" u="none" strike="noStrike" kern="0" cap="none" spc="0" normalizeH="0" baseline="0" noProof="0" dirty="0">
+                <a:ln>
+                  <a:noFill/>
+                </a:ln>
+                <a:solidFill>
+                  <a:srgbClr val="000000"/>
+                </a:solidFill>
+                <a:effectLst/>
+                <a:uLnTx/>
+                <a:uFillTx/>
+              </a:rPr>
+              <a:t>import FMU </a:t>
+            </a:r>
+          </a:p>
+          <a:p>
+            <a:pPr marL="228600" indent="-228600" eaLnBrk="1" fontAlgn="auto" hangingPunct="1">
+              <a:lnSpc>
+                <a:spcPts val="2300"/>
+              </a:lnSpc>
+              <a:spcBef>
+                <a:spcPts val="500"/>
+              </a:spcBef>
+              <a:spcAft>
+                <a:spcPts val="0"/>
+              </a:spcAft>
+              <a:buFont typeface="+mj-lt"/>
+              <a:buAutoNum type="arabicPeriod" startAt="3"/>
+            </a:pPr>
+            <a:r>
+              <a:rPr lang="en-US" sz="1600" kern="0" dirty="0">
+                <a:solidFill>
+                  <a:srgbClr val="000000"/>
+                </a:solidFill>
+              </a:rPr>
+              <a:t>(co-) </a:t>
+            </a:r>
+            <a:r>
+              <a:rPr lang="en-US" sz="1600" b="1" kern="0" dirty="0">
+                <a:solidFill>
+                  <a:srgbClr val="000000"/>
+                </a:solidFill>
+              </a:rPr>
+              <a:t>simulate model </a:t>
+            </a:r>
+            <a:endParaRPr kumimoji="0" lang="en-US" sz="1600" b="1" i="0" u="none" strike="noStrike" kern="0" cap="none" spc="0" normalizeH="0" baseline="0" noProof="0" dirty="0">
+              <a:ln>
+                <a:noFill/>
+              </a:ln>
+              <a:solidFill>
+                <a:srgbClr val="000000"/>
+              </a:solidFill>
+              <a:effectLst/>
+              <a:uLnTx/>
+              <a:uFillTx/>
+            </a:endParaRPr>
+          </a:p>
+          <a:p>
+            <a:pPr marL="228600" marR="0" indent="-228600" defTabSz="914400" eaLnBrk="1" fontAlgn="auto" latinLnBrk="0" hangingPunct="1">
+              <a:lnSpc>
+                <a:spcPts val="2300"/>
+              </a:lnSpc>
+              <a:spcBef>
+                <a:spcPts val="500"/>
+              </a:spcBef>
+              <a:spcAft>
+                <a:spcPts val="0"/>
+              </a:spcAft>
+              <a:buClrTx/>
+              <a:buSzTx/>
+              <a:buFont typeface="+mj-lt"/>
+              <a:buAutoNum type="arabicPeriod" startAt="3"/>
+              <a:tabLst/>
+            </a:pPr>
+            <a:endParaRPr kumimoji="0" lang="en-US" b="0" i="0" u="none" strike="noStrike" kern="0" cap="none" spc="0" normalizeH="0" baseline="0" noProof="0" dirty="0">
+              <a:ln>
+                <a:noFill/>
+              </a:ln>
+              <a:solidFill>
+                <a:srgbClr val="000000"/>
+              </a:solidFill>
+              <a:effectLst/>
+              <a:uLnTx/>
+              <a:uFillTx/>
+            </a:endParaRPr>
+          </a:p>
+        </p:txBody>
+      </p:sp>
+      <p:cxnSp>
+        <p:nvCxnSpPr>
+          <p:cNvPr id="146" name="Straight Arrow Connector 157">
+            <a:extLst>
+              <a:ext uri="{FF2B5EF4-FFF2-40B4-BE49-F238E27FC236}">
+                <a16:creationId xmlns:a16="http://schemas.microsoft.com/office/drawing/2014/main" id="{55E41A82-12DB-8AF0-99FD-7E3E86F7B38C}"/>
+              </a:ext>
+            </a:extLst>
+          </p:cNvPr>
+          <p:cNvCxnSpPr>
+            <a:cxnSpLocks/>
+          </p:cNvCxnSpPr>
+          <p:nvPr/>
+        </p:nvCxnSpPr>
+        <p:spPr>
+          <a:xfrm>
+            <a:off x="5698782" y="3870346"/>
+            <a:ext cx="0" cy="309022"/>
+          </a:xfrm>
+          <a:prstGeom prst="straightConnector1">
+            <a:avLst/>
+          </a:prstGeom>
+          <a:ln>
+            <a:solidFill>
+              <a:schemeClr val="accent1"/>
+            </a:solidFill>
+            <a:tailEnd type="triangle"/>
+          </a:ln>
+        </p:spPr>
+        <p:style>
+          <a:lnRef idx="1">
+            <a:srgbClr val="007BC0"/>
+          </a:lnRef>
+          <a:fillRef idx="0">
+            <a:srgbClr val="007BC0"/>
+          </a:fillRef>
+          <a:effectRef idx="0">
+            <a:srgbClr val="007BC0"/>
+          </a:effectRef>
+          <a:fontRef idx="minor">
+            <a:schemeClr val="tx1"/>
+          </a:fontRef>
+        </p:style>
+      </p:cxnSp>
+      <p:sp>
+        <p:nvSpPr>
+          <p:cNvPr id="147" name="TextBox 146">
+            <a:extLst>
+              <a:ext uri="{FF2B5EF4-FFF2-40B4-BE49-F238E27FC236}">
+                <a16:creationId xmlns:a16="http://schemas.microsoft.com/office/drawing/2014/main" id="{837EBB6A-3627-727A-EB38-D3A9E1159390}"/>
+              </a:ext>
+            </a:extLst>
+          </p:cNvPr>
+          <p:cNvSpPr txBox="1"/>
+          <p:nvPr/>
+        </p:nvSpPr>
+        <p:spPr>
+          <a:xfrm>
+            <a:off x="2152602" y="1585602"/>
+            <a:ext cx="1689886" cy="338554"/>
+          </a:xfrm>
+          <a:prstGeom prst="rect">
+            <a:avLst/>
+          </a:prstGeom>
+          <a:noFill/>
+        </p:spPr>
+        <p:txBody>
+          <a:bodyPr wrap="none" rtlCol="0">
+            <a:spAutoFit/>
+          </a:bodyPr>
+          <a:lstStyle/>
+          <a:p>
+            <a:r>
+              <a:rPr lang="en-US" b="1" dirty="0">
+                <a:solidFill>
+                  <a:schemeClr val="accent6">
+                    <a:lumMod val="75000"/>
+                  </a:schemeClr>
+                </a:solidFill>
+              </a:rPr>
+              <a:t>Exporting tools</a:t>
+            </a:r>
+          </a:p>
+        </p:txBody>
+      </p:sp>
+      <p:sp>
+        <p:nvSpPr>
+          <p:cNvPr id="148" name="TextBox 147">
+            <a:extLst>
+              <a:ext uri="{FF2B5EF4-FFF2-40B4-BE49-F238E27FC236}">
+                <a16:creationId xmlns:a16="http://schemas.microsoft.com/office/drawing/2014/main" id="{A4FB0666-6CC6-4722-4DA1-E5563B231A85}"/>
+              </a:ext>
+            </a:extLst>
+          </p:cNvPr>
+          <p:cNvSpPr txBox="1"/>
+          <p:nvPr/>
+        </p:nvSpPr>
+        <p:spPr>
+          <a:xfrm>
+            <a:off x="5274512" y="5498548"/>
+            <a:ext cx="1566454" cy="338554"/>
+          </a:xfrm>
+          <a:prstGeom prst="rect">
+            <a:avLst/>
+          </a:prstGeom>
+          <a:noFill/>
+        </p:spPr>
+        <p:txBody>
+          <a:bodyPr wrap="none" rtlCol="0">
+            <a:spAutoFit/>
+          </a:bodyPr>
+          <a:lstStyle/>
+          <a:p>
+            <a:r>
+              <a:rPr lang="en-US" b="1" dirty="0">
+                <a:solidFill>
+                  <a:schemeClr val="accent6">
+                    <a:lumMod val="75000"/>
+                  </a:schemeClr>
+                </a:solidFill>
+              </a:rPr>
+              <a:t>Importing tool</a:t>
+            </a:r>
+          </a:p>
+        </p:txBody>
+      </p:sp>
+      <p:sp>
+        <p:nvSpPr>
+          <p:cNvPr id="4" name="Rectangle 3">
+            <a:extLst>
+              <a:ext uri="{FF2B5EF4-FFF2-40B4-BE49-F238E27FC236}">
+                <a16:creationId xmlns:a16="http://schemas.microsoft.com/office/drawing/2014/main" id="{C4E4F902-8D9D-E7F9-9C9E-672F33F101E6}"/>
+              </a:ext>
+            </a:extLst>
+          </p:cNvPr>
+          <p:cNvSpPr/>
+          <p:nvPr/>
+        </p:nvSpPr>
+        <p:spPr bwMode="auto">
+          <a:xfrm>
+            <a:off x="2253345" y="1994792"/>
+            <a:ext cx="3849025" cy="1206329"/>
+          </a:xfrm>
+          <a:prstGeom prst="rect">
+            <a:avLst/>
+          </a:prstGeom>
+          <a:noFill/>
+          <a:ln w="9525" cap="flat" cmpd="sng" algn="ctr">
+            <a:solidFill>
+              <a:schemeClr val="accent6">
+                <a:lumMod val="75000"/>
+              </a:schemeClr>
+            </a:solidFill>
+            <a:prstDash val="solid"/>
+            <a:round/>
+            <a:headEnd type="none" w="med" len="med"/>
+            <a:tailEnd type="arrow" w="med" len="med"/>
+          </a:ln>
+          <a:effectLst/>
+        </p:spPr>
+        <p:txBody>
+          <a:bodyPr vert="horz" wrap="square" lIns="90000" tIns="46800" rIns="36000" bIns="46800" numCol="1" rtlCol="0" anchor="t" anchorCtr="0" compatLnSpc="1">
+            <a:prstTxWarp prst="textNoShape">
+              <a:avLst/>
+            </a:prstTxWarp>
+            <a:spAutoFit/>
+          </a:bodyPr>
+          <a:lstStyle/>
+          <a:p>
+            <a:pPr marL="0" marR="0" indent="0" algn="l" defTabSz="914400" rtl="0" eaLnBrk="0" fontAlgn="base" latinLnBrk="0" hangingPunct="0">
+              <a:lnSpc>
+                <a:spcPct val="100000"/>
+              </a:lnSpc>
+              <a:spcBef>
+                <a:spcPct val="50000"/>
+              </a:spcBef>
+              <a:spcAft>
+                <a:spcPct val="0"/>
+              </a:spcAft>
+              <a:buClrTx/>
+              <a:buSzTx/>
+              <a:buFontTx/>
+              <a:buNone/>
+              <a:tabLst/>
+            </a:pPr>
+            <a:endParaRPr kumimoji="0" lang="en-US" sz="1600" b="0" i="0" u="none" strike="noStrike" cap="none" normalizeH="0" baseline="0">
+              <a:ln>
+                <a:noFill/>
+              </a:ln>
+              <a:solidFill>
+                <a:srgbClr val="120C80"/>
+              </a:solidFill>
+              <a:effectLst/>
+              <a:latin typeface="Arial" charset="0"/>
+              <a:cs typeface="Arial" charset="0"/>
+            </a:endParaRPr>
+          </a:p>
+        </p:txBody>
+      </p:sp>
+      <p:sp>
+        <p:nvSpPr>
+          <p:cNvPr id="150" name="Rectangle 149">
+            <a:extLst>
+              <a:ext uri="{FF2B5EF4-FFF2-40B4-BE49-F238E27FC236}">
+                <a16:creationId xmlns:a16="http://schemas.microsoft.com/office/drawing/2014/main" id="{CB265A1F-7F90-8B44-3E24-F893093748DA}"/>
+              </a:ext>
+            </a:extLst>
+          </p:cNvPr>
+          <p:cNvSpPr/>
+          <p:nvPr/>
+        </p:nvSpPr>
+        <p:spPr bwMode="auto">
+          <a:xfrm>
+            <a:off x="5274513" y="4170118"/>
+            <a:ext cx="2715602" cy="1206329"/>
+          </a:xfrm>
+          <a:prstGeom prst="rect">
+            <a:avLst/>
+          </a:prstGeom>
+          <a:noFill/>
+          <a:ln w="9525" cap="flat" cmpd="sng" algn="ctr">
+            <a:solidFill>
+              <a:schemeClr val="accent6">
+                <a:lumMod val="75000"/>
+              </a:schemeClr>
+            </a:solidFill>
+            <a:prstDash val="solid"/>
+            <a:round/>
+            <a:headEnd type="none" w="med" len="med"/>
+            <a:tailEnd type="arrow" w="med" len="med"/>
+          </a:ln>
+          <a:effectLst/>
+        </p:spPr>
+        <p:txBody>
+          <a:bodyPr vert="horz" wrap="square" lIns="90000" tIns="46800" rIns="36000" bIns="46800" numCol="1" rtlCol="0" anchor="t" anchorCtr="0" compatLnSpc="1">
+            <a:prstTxWarp prst="textNoShape">
+              <a:avLst/>
+            </a:prstTxWarp>
+            <a:spAutoFit/>
+          </a:bodyPr>
+          <a:lstStyle/>
+          <a:p>
+            <a:pPr marL="0" marR="0" indent="0" algn="l" defTabSz="914400" rtl="0" eaLnBrk="0" fontAlgn="base" latinLnBrk="0" hangingPunct="0">
+              <a:lnSpc>
+                <a:spcPct val="100000"/>
+              </a:lnSpc>
+              <a:spcBef>
+                <a:spcPct val="50000"/>
+              </a:spcBef>
+              <a:spcAft>
+                <a:spcPct val="0"/>
+              </a:spcAft>
+              <a:buClrTx/>
+              <a:buSzTx/>
+              <a:buFontTx/>
+              <a:buNone/>
+              <a:tabLst/>
+            </a:pPr>
+            <a:endParaRPr kumimoji="0" lang="en-US" sz="1600" b="0" i="0" u="none" strike="noStrike" cap="none" normalizeH="0" baseline="0">
+              <a:ln>
+                <a:noFill/>
+              </a:ln>
+              <a:solidFill>
+                <a:srgbClr val="120C80"/>
+              </a:solidFill>
+              <a:effectLst/>
+              <a:latin typeface="Arial" charset="0"/>
+              <a:cs typeface="Arial" charset="0"/>
+            </a:endParaRPr>
+          </a:p>
+        </p:txBody>
+      </p:sp>
+      <p:pic>
+        <p:nvPicPr>
+          <p:cNvPr id="152" name="Picture 151">
+            <a:extLst>
+              <a:ext uri="{FF2B5EF4-FFF2-40B4-BE49-F238E27FC236}">
+                <a16:creationId xmlns:a16="http://schemas.microsoft.com/office/drawing/2014/main" id="{214385AA-7F75-E093-2563-CB48FF21F492}"/>
+              </a:ext>
+            </a:extLst>
+          </p:cNvPr>
+          <p:cNvPicPr>
+            <a:picLocks noChangeAspect="1"/>
+          </p:cNvPicPr>
+          <p:nvPr/>
+        </p:nvPicPr>
+        <p:blipFill rotWithShape="1">
+          <a:blip r:embed="rId2"/>
+          <a:srcRect b="50593"/>
+          <a:stretch/>
+        </p:blipFill>
+        <p:spPr>
+          <a:xfrm>
+            <a:off x="2345824" y="2136065"/>
+            <a:ext cx="1700127" cy="911542"/>
+          </a:xfrm>
+          <a:prstGeom prst="rect">
+            <a:avLst/>
+          </a:prstGeom>
+        </p:spPr>
+      </p:pic>
+      <p:pic>
+        <p:nvPicPr>
+          <p:cNvPr id="153" name="Picture 152">
+            <a:extLst>
+              <a:ext uri="{FF2B5EF4-FFF2-40B4-BE49-F238E27FC236}">
+                <a16:creationId xmlns:a16="http://schemas.microsoft.com/office/drawing/2014/main" id="{DC094FE4-04D7-2506-0745-48FAC2034FDA}"/>
+              </a:ext>
+            </a:extLst>
+          </p:cNvPr>
+          <p:cNvPicPr>
+            <a:picLocks noChangeAspect="1"/>
+          </p:cNvPicPr>
+          <p:nvPr/>
+        </p:nvPicPr>
+        <p:blipFill rotWithShape="1">
+          <a:blip r:embed="rId2"/>
+          <a:srcRect t="45923"/>
+          <a:stretch/>
+        </p:blipFill>
+        <p:spPr>
+          <a:xfrm>
+            <a:off x="4104372" y="2049883"/>
+            <a:ext cx="1700127" cy="997724"/>
+          </a:xfrm>
+          <a:prstGeom prst="rect">
+            <a:avLst/>
+          </a:prstGeom>
+        </p:spPr>
+      </p:pic>
+      <p:pic>
+        <p:nvPicPr>
+          <p:cNvPr id="155" name="Picture 154">
+            <a:extLst>
+              <a:ext uri="{FF2B5EF4-FFF2-40B4-BE49-F238E27FC236}">
+                <a16:creationId xmlns:a16="http://schemas.microsoft.com/office/drawing/2014/main" id="{DB39975B-FB5C-96E8-2997-B4B11670AC35}"/>
+              </a:ext>
+            </a:extLst>
+          </p:cNvPr>
+          <p:cNvPicPr>
+            <a:picLocks noChangeAspect="1"/>
+          </p:cNvPicPr>
+          <p:nvPr/>
+        </p:nvPicPr>
+        <p:blipFill>
+          <a:blip r:embed="rId3"/>
+          <a:stretch>
+            <a:fillRect/>
+          </a:stretch>
+        </p:blipFill>
+        <p:spPr>
+          <a:xfrm>
+            <a:off x="5698782" y="4384625"/>
+            <a:ext cx="1434220" cy="877103"/>
+          </a:xfrm>
+          <a:prstGeom prst="rect">
+            <a:avLst/>
+          </a:prstGeom>
+        </p:spPr>
+      </p:pic>
+      <p:pic>
+        <p:nvPicPr>
+          <p:cNvPr id="157" name="Picture 156">
+            <a:extLst>
+              <a:ext uri="{FF2B5EF4-FFF2-40B4-BE49-F238E27FC236}">
+                <a16:creationId xmlns:a16="http://schemas.microsoft.com/office/drawing/2014/main" id="{B59A83F1-834A-F9D4-8ECA-F74FE98AC59A}"/>
+              </a:ext>
+            </a:extLst>
+          </p:cNvPr>
+          <p:cNvPicPr>
+            <a:picLocks noChangeAspect="1"/>
+          </p:cNvPicPr>
+          <p:nvPr/>
+        </p:nvPicPr>
+        <p:blipFill>
+          <a:blip r:embed="rId4"/>
+          <a:stretch>
+            <a:fillRect/>
+          </a:stretch>
+        </p:blipFill>
+        <p:spPr>
+          <a:xfrm>
+            <a:off x="6415892" y="3383849"/>
+            <a:ext cx="2186483" cy="603541"/>
+          </a:xfrm>
+          <a:prstGeom prst="rect">
+            <a:avLst/>
+          </a:prstGeom>
+        </p:spPr>
+      </p:pic>
+    </p:spTree>
+    <p:extLst>
+      <p:ext uri="{BB962C8B-B14F-4D97-AF65-F5344CB8AC3E}">
+        <p14:creationId xmlns:p14="http://schemas.microsoft.com/office/powerpoint/2010/main" val="157138638"/>
+      </p:ext>
+    </p:extLst>
+  </p:cSld>
+  <p:clrMapOvr>
+    <a:masterClrMapping/>
+  </p:clrMapOvr>
+  <p:transition/>
+</p:sld>
+</file>
+
+<file path=ppt/slides/slide13.xml><?xml version="1.0" encoding="utf-8"?>
+<p:sld xmlns:a="http://schemas.openxmlformats.org/drawingml/2006/main" xmlns:r="http://schemas.openxmlformats.org/officeDocument/2006/relationships" xmlns:p="http://schemas.openxmlformats.org/presentationml/2006/main">
+  <p:cSld>
+    <p:spTree>
+      <p:nvGrpSpPr>
+        <p:cNvPr id="1" name=""/>
+        <p:cNvGrpSpPr/>
+        <p:nvPr/>
+      </p:nvGrpSpPr>
+      <p:grpSpPr>
+        <a:xfrm>
+          <a:off x="0" y="0"/>
+          <a:ext cx="0" cy="0"/>
+          <a:chOff x="0" y="0"/>
+          <a:chExt cx="0" cy="0"/>
+        </a:xfrm>
+      </p:grpSpPr>
+      <p:sp>
+        <p:nvSpPr>
           <p:cNvPr id="2" name="Content Placeholder 1">
             <a:extLst>
               <a:ext uri="{FF2B5EF4-FFF2-40B4-BE49-F238E27FC236}">
@@ -4342,7 +6069,7 @@
 </p:sld>
 </file>
 
-<file path=ppt/slides/slide11.xml><?xml version="1.0" encoding="utf-8"?>
+<file path=ppt/slides/slide14.xml><?xml version="1.0" encoding="utf-8"?>
 <p:sld xmlns:a="http://schemas.openxmlformats.org/drawingml/2006/main" xmlns:r="http://schemas.openxmlformats.org/officeDocument/2006/relationships" xmlns:p="http://schemas.openxmlformats.org/presentationml/2006/main">
   <p:cSld>
     <p:spTree>
@@ -4537,7 +6264,7 @@
 </p:sld>
 </file>
 
-<file path=ppt/slides/slide12.xml><?xml version="1.0" encoding="utf-8"?>
+<file path=ppt/slides/slide15.xml><?xml version="1.0" encoding="utf-8"?>
 <p:sld xmlns:a="http://schemas.openxmlformats.org/drawingml/2006/main" xmlns:r="http://schemas.openxmlformats.org/officeDocument/2006/relationships" xmlns:p="http://schemas.openxmlformats.org/presentationml/2006/main">
   <p:cSld>
     <p:spTree>
@@ -4736,7 +6463,7 @@
 </p:sld>
 </file>
 
-<file path=ppt/slides/slide13.xml><?xml version="1.0" encoding="utf-8"?>
+<file path=ppt/slides/slide16.xml><?xml version="1.0" encoding="utf-8"?>
 <p:sld xmlns:a="http://schemas.openxmlformats.org/drawingml/2006/main" xmlns:r="http://schemas.openxmlformats.org/officeDocument/2006/relationships" xmlns:p="http://schemas.openxmlformats.org/presentationml/2006/main">
   <p:cSld>
     <p:spTree>
@@ -5865,7 +7592,7 @@
 </p:sld>
 </file>
 
-<file path=ppt/slides/slide14.xml><?xml version="1.0" encoding="utf-8"?>
+<file path=ppt/slides/slide17.xml><?xml version="1.0" encoding="utf-8"?>
 <p:sld xmlns:a="http://schemas.openxmlformats.org/drawingml/2006/main" xmlns:r="http://schemas.openxmlformats.org/officeDocument/2006/relationships" xmlns:p="http://schemas.openxmlformats.org/presentationml/2006/main">
   <p:cSld>
     <p:spTree>
@@ -8077,7 +9804,7 @@
 </p:sld>
 </file>
 
-<file path=ppt/slides/slide15.xml><?xml version="1.0" encoding="utf-8"?>
+<file path=ppt/slides/slide18.xml><?xml version="1.0" encoding="utf-8"?>
 <p:sld xmlns:a="http://schemas.openxmlformats.org/drawingml/2006/main" xmlns:r="http://schemas.openxmlformats.org/officeDocument/2006/relationships" xmlns:p="http://schemas.openxmlformats.org/presentationml/2006/main">
   <p:cSld>
     <p:spTree>
@@ -8334,7 +10061,7 @@
 </p:sld>
 </file>
 
-<file path=ppt/slides/slide16.xml><?xml version="1.0" encoding="utf-8"?>
+<file path=ppt/slides/slide19.xml><?xml version="1.0" encoding="utf-8"?>
 <p:sld xmlns:a="http://schemas.openxmlformats.org/drawingml/2006/main" xmlns:r="http://schemas.openxmlformats.org/officeDocument/2006/relationships" xmlns:p="http://schemas.openxmlformats.org/presentationml/2006/main">
   <p:cSld>
     <p:spTree>
@@ -8527,7 +10254,173 @@
 </p:sld>
 </file>
 
-<file path=ppt/slides/slide17.xml><?xml version="1.0" encoding="utf-8"?>
+<file path=ppt/slides/slide2.xml><?xml version="1.0" encoding="utf-8"?>
+<p:sld xmlns:a="http://schemas.openxmlformats.org/drawingml/2006/main" xmlns:r="http://schemas.openxmlformats.org/officeDocument/2006/relationships" xmlns:p="http://schemas.openxmlformats.org/presentationml/2006/main">
+  <p:cSld>
+    <p:spTree>
+      <p:nvGrpSpPr>
+        <p:cNvPr id="1" name=""/>
+        <p:cNvGrpSpPr/>
+        <p:nvPr/>
+      </p:nvGrpSpPr>
+      <p:grpSpPr>
+        <a:xfrm>
+          <a:off x="0" y="0"/>
+          <a:ext cx="0" cy="0"/>
+          <a:chOff x="0" y="0"/>
+          <a:chExt cx="0" cy="0"/>
+        </a:xfrm>
+      </p:grpSpPr>
+      <p:sp>
+        <p:nvSpPr>
+          <p:cNvPr id="2" name="Content Placeholder 1">
+            <a:extLst>
+              <a:ext uri="{FF2B5EF4-FFF2-40B4-BE49-F238E27FC236}">
+                <a16:creationId xmlns:a16="http://schemas.microsoft.com/office/drawing/2014/main" id="{3734C688-16B3-B453-B079-67DC29D4D0C5}"/>
+              </a:ext>
+            </a:extLst>
+          </p:cNvPr>
+          <p:cNvSpPr>
+            <a:spLocks noGrp="1"/>
+          </p:cNvSpPr>
+          <p:nvPr>
+            <p:ph idx="1"/>
+          </p:nvPr>
+        </p:nvSpPr>
+        <p:spPr/>
+        <p:txBody>
+          <a:bodyPr/>
+          <a:lstStyle/>
+          <a:p>
+            <a:r>
+              <a:rPr lang="en-US" b="1" dirty="0"/>
+              <a:t>Part 1: Introduction to FMI (40Min)</a:t>
+            </a:r>
+          </a:p>
+          <a:p>
+            <a:pPr lvl="1"/>
+            <a:r>
+              <a:rPr lang="en-US" dirty="0"/>
+              <a:t>Motivation / History</a:t>
+            </a:r>
+          </a:p>
+          <a:p>
+            <a:pPr lvl="1"/>
+            <a:r>
+              <a:rPr lang="en-US" dirty="0"/>
+              <a:t>How does FMI work?</a:t>
+            </a:r>
+          </a:p>
+          <a:p>
+            <a:pPr lvl="1"/>
+            <a:r>
+              <a:rPr lang="en-US" dirty="0"/>
+              <a:t>Tool support</a:t>
+            </a:r>
+          </a:p>
+          <a:p>
+            <a:pPr lvl="1"/>
+            <a:r>
+              <a:rPr lang="en-US" dirty="0"/>
+              <a:t>New features in FMI 3.0</a:t>
+            </a:r>
+          </a:p>
+          <a:p>
+            <a:pPr lvl="1"/>
+            <a:endParaRPr lang="en-US" dirty="0"/>
+          </a:p>
+          <a:p>
+            <a:r>
+              <a:rPr lang="en-US" b="1" dirty="0"/>
+              <a:t>Part 2: Working with (single) FMUs (45 min)</a:t>
+            </a:r>
+          </a:p>
+          <a:p>
+            <a:endParaRPr lang="en-US" b="1" dirty="0"/>
+          </a:p>
+          <a:p>
+            <a:r>
+              <a:rPr lang="en-US" b="1" dirty="0"/>
+              <a:t>Part 3: Interacting with multiple FMUs (45 min)</a:t>
+            </a:r>
+          </a:p>
+          <a:p>
+            <a:endParaRPr lang="en-US" b="1" dirty="0"/>
+          </a:p>
+          <a:p>
+            <a:r>
+              <a:rPr lang="en-US" b="1" dirty="0"/>
+              <a:t>Part 4: Closing Session (10 min)</a:t>
+            </a:r>
+          </a:p>
+          <a:p>
+            <a:endParaRPr lang="en-US" b="1" dirty="0"/>
+          </a:p>
+          <a:p>
+            <a:r>
+              <a:rPr lang="en-US" b="1" dirty="0"/>
+              <a:t>Q&amp;A</a:t>
+            </a:r>
+          </a:p>
+          <a:p>
+            <a:endParaRPr lang="en-US" dirty="0"/>
+          </a:p>
+          <a:p>
+            <a:pPr lvl="1"/>
+            <a:endParaRPr lang="en-US" dirty="0"/>
+          </a:p>
+          <a:p>
+            <a:pPr marL="1588" lvl="1" indent="0">
+              <a:buNone/>
+            </a:pPr>
+            <a:endParaRPr lang="en-US" dirty="0"/>
+          </a:p>
+        </p:txBody>
+      </p:sp>
+      <p:sp>
+        <p:nvSpPr>
+          <p:cNvPr id="3" name="Title 2">
+            <a:extLst>
+              <a:ext uri="{FF2B5EF4-FFF2-40B4-BE49-F238E27FC236}">
+                <a16:creationId xmlns:a16="http://schemas.microsoft.com/office/drawing/2014/main" id="{40E7EA68-8D1C-689A-76B2-62492C233FCE}"/>
+              </a:ext>
+            </a:extLst>
+          </p:cNvPr>
+          <p:cNvSpPr>
+            <a:spLocks noGrp="1"/>
+          </p:cNvSpPr>
+          <p:nvPr>
+            <p:ph type="title"/>
+          </p:nvPr>
+        </p:nvSpPr>
+        <p:spPr/>
+        <p:txBody>
+          <a:bodyPr/>
+          <a:lstStyle/>
+          <a:p>
+            <a:r>
+              <a:rPr lang="de-DE" dirty="0"/>
+              <a:t>Agenda</a:t>
+            </a:r>
+            <a:endParaRPr lang="en-US" dirty="0"/>
+          </a:p>
+        </p:txBody>
+      </p:sp>
+    </p:spTree>
+    <p:extLst>
+      <p:ext uri="{BB962C8B-B14F-4D97-AF65-F5344CB8AC3E}">
+        <p14:creationId xmlns:p14="http://schemas.microsoft.com/office/powerpoint/2010/main" val="654693617"/>
+      </p:ext>
+    </p:extLst>
+  </p:cSld>
+  <p:clrMapOvr>
+    <a:masterClrMapping/>
+  </p:clrMapOvr>
+  <p:transition/>
+</p:sld>
+</file>
+
+<file path=ppt/slides/slide20.xml><?xml version="1.0" encoding="utf-8"?>
 <p:sld xmlns:a="http://schemas.openxmlformats.org/drawingml/2006/main" xmlns:r="http://schemas.openxmlformats.org/officeDocument/2006/relationships" xmlns:p="http://schemas.openxmlformats.org/presentationml/2006/main">
   <p:cSld>
     <p:spTree>
@@ -9985,7 +11878,7 @@
 </p:sld>
 </file>
 
-<file path=ppt/slides/slide18.xml><?xml version="1.0" encoding="utf-8"?>
+<file path=ppt/slides/slide21.xml><?xml version="1.0" encoding="utf-8"?>
 <p:sld xmlns:a="http://schemas.openxmlformats.org/drawingml/2006/main" xmlns:r="http://schemas.openxmlformats.org/officeDocument/2006/relationships" xmlns:p="http://schemas.openxmlformats.org/presentationml/2006/main">
   <p:cSld>
     <p:spTree>
@@ -10319,7 +12212,7 @@
 </p:sld>
 </file>
 
-<file path=ppt/slides/slide19.xml><?xml version="1.0" encoding="utf-8"?>
+<file path=ppt/slides/slide22.xml><?xml version="1.0" encoding="utf-8"?>
 <p:sld xmlns:a="http://schemas.openxmlformats.org/drawingml/2006/main" xmlns:r="http://schemas.openxmlformats.org/officeDocument/2006/relationships" xmlns:p="http://schemas.openxmlformats.org/presentationml/2006/main">
   <p:cSld>
     <p:spTree>
@@ -10575,173 +12468,7 @@
 </p:sld>
 </file>
 
-<file path=ppt/slides/slide2.xml><?xml version="1.0" encoding="utf-8"?>
-<p:sld xmlns:a="http://schemas.openxmlformats.org/drawingml/2006/main" xmlns:r="http://schemas.openxmlformats.org/officeDocument/2006/relationships" xmlns:p="http://schemas.openxmlformats.org/presentationml/2006/main">
-  <p:cSld>
-    <p:spTree>
-      <p:nvGrpSpPr>
-        <p:cNvPr id="1" name=""/>
-        <p:cNvGrpSpPr/>
-        <p:nvPr/>
-      </p:nvGrpSpPr>
-      <p:grpSpPr>
-        <a:xfrm>
-          <a:off x="0" y="0"/>
-          <a:ext cx="0" cy="0"/>
-          <a:chOff x="0" y="0"/>
-          <a:chExt cx="0" cy="0"/>
-        </a:xfrm>
-      </p:grpSpPr>
-      <p:sp>
-        <p:nvSpPr>
-          <p:cNvPr id="2" name="Content Placeholder 1">
-            <a:extLst>
-              <a:ext uri="{FF2B5EF4-FFF2-40B4-BE49-F238E27FC236}">
-                <a16:creationId xmlns:a16="http://schemas.microsoft.com/office/drawing/2014/main" id="{3734C688-16B3-B453-B079-67DC29D4D0C5}"/>
-              </a:ext>
-            </a:extLst>
-          </p:cNvPr>
-          <p:cNvSpPr>
-            <a:spLocks noGrp="1"/>
-          </p:cNvSpPr>
-          <p:nvPr>
-            <p:ph idx="1"/>
-          </p:nvPr>
-        </p:nvSpPr>
-        <p:spPr/>
-        <p:txBody>
-          <a:bodyPr/>
-          <a:lstStyle/>
-          <a:p>
-            <a:r>
-              <a:rPr lang="en-US" b="1" dirty="0"/>
-              <a:t>Part 1: Introduction to FMI (40Min)</a:t>
-            </a:r>
-          </a:p>
-          <a:p>
-            <a:pPr lvl="1"/>
-            <a:r>
-              <a:rPr lang="en-US" dirty="0"/>
-              <a:t>Motivation / History</a:t>
-            </a:r>
-          </a:p>
-          <a:p>
-            <a:pPr lvl="1"/>
-            <a:r>
-              <a:rPr lang="en-US" dirty="0"/>
-              <a:t>How does FMI work?</a:t>
-            </a:r>
-          </a:p>
-          <a:p>
-            <a:pPr lvl="1"/>
-            <a:r>
-              <a:rPr lang="en-US" dirty="0"/>
-              <a:t>Tool support</a:t>
-            </a:r>
-          </a:p>
-          <a:p>
-            <a:pPr lvl="1"/>
-            <a:r>
-              <a:rPr lang="en-US" dirty="0"/>
-              <a:t>New features in FMI 3.0</a:t>
-            </a:r>
-          </a:p>
-          <a:p>
-            <a:pPr lvl="1"/>
-            <a:endParaRPr lang="en-US" dirty="0"/>
-          </a:p>
-          <a:p>
-            <a:r>
-              <a:rPr lang="en-US" b="1" dirty="0"/>
-              <a:t>Part 2: Working with (single) FMUs (45 min)</a:t>
-            </a:r>
-          </a:p>
-          <a:p>
-            <a:endParaRPr lang="en-US" b="1" dirty="0"/>
-          </a:p>
-          <a:p>
-            <a:r>
-              <a:rPr lang="en-US" b="1" dirty="0"/>
-              <a:t>Part 3: Interacting with multiple FMUs (45 min)</a:t>
-            </a:r>
-          </a:p>
-          <a:p>
-            <a:endParaRPr lang="en-US" b="1" dirty="0"/>
-          </a:p>
-          <a:p>
-            <a:r>
-              <a:rPr lang="en-US" b="1" dirty="0"/>
-              <a:t>Part 4: Closing Session (10 min)</a:t>
-            </a:r>
-          </a:p>
-          <a:p>
-            <a:endParaRPr lang="en-US" b="1" dirty="0"/>
-          </a:p>
-          <a:p>
-            <a:r>
-              <a:rPr lang="en-US" b="1" dirty="0"/>
-              <a:t>Q&amp;A</a:t>
-            </a:r>
-          </a:p>
-          <a:p>
-            <a:endParaRPr lang="en-US" dirty="0"/>
-          </a:p>
-          <a:p>
-            <a:pPr lvl="1"/>
-            <a:endParaRPr lang="en-US" dirty="0"/>
-          </a:p>
-          <a:p>
-            <a:pPr marL="1588" lvl="1" indent="0">
-              <a:buNone/>
-            </a:pPr>
-            <a:endParaRPr lang="en-US" dirty="0"/>
-          </a:p>
-        </p:txBody>
-      </p:sp>
-      <p:sp>
-        <p:nvSpPr>
-          <p:cNvPr id="3" name="Title 2">
-            <a:extLst>
-              <a:ext uri="{FF2B5EF4-FFF2-40B4-BE49-F238E27FC236}">
-                <a16:creationId xmlns:a16="http://schemas.microsoft.com/office/drawing/2014/main" id="{40E7EA68-8D1C-689A-76B2-62492C233FCE}"/>
-              </a:ext>
-            </a:extLst>
-          </p:cNvPr>
-          <p:cNvSpPr>
-            <a:spLocks noGrp="1"/>
-          </p:cNvSpPr>
-          <p:nvPr>
-            <p:ph type="title"/>
-          </p:nvPr>
-        </p:nvSpPr>
-        <p:spPr/>
-        <p:txBody>
-          <a:bodyPr/>
-          <a:lstStyle/>
-          <a:p>
-            <a:r>
-              <a:rPr lang="de-DE" dirty="0"/>
-              <a:t>Agenda</a:t>
-            </a:r>
-            <a:endParaRPr lang="en-US" dirty="0"/>
-          </a:p>
-        </p:txBody>
-      </p:sp>
-    </p:spTree>
-    <p:extLst>
-      <p:ext uri="{BB962C8B-B14F-4D97-AF65-F5344CB8AC3E}">
-        <p14:creationId xmlns:p14="http://schemas.microsoft.com/office/powerpoint/2010/main" val="654693617"/>
-      </p:ext>
-    </p:extLst>
-  </p:cSld>
-  <p:clrMapOvr>
-    <a:masterClrMapping/>
-  </p:clrMapOvr>
-  <p:transition/>
-</p:sld>
-</file>
-
-<file path=ppt/slides/slide20.xml><?xml version="1.0" encoding="utf-8"?>
+<file path=ppt/slides/slide23.xml><?xml version="1.0" encoding="utf-8"?>
 <p:sld xmlns:a="http://schemas.openxmlformats.org/drawingml/2006/main" xmlns:r="http://schemas.openxmlformats.org/officeDocument/2006/relationships" xmlns:p="http://schemas.openxmlformats.org/presentationml/2006/main">
   <p:cSld>
     <p:spTree>
@@ -10787,7 +12514,7 @@
             </a:r>
             <a:r>
               <a:rPr lang="en-US" dirty="0"/>
-              <a:t>: FMI supported by &gt;= 180 Tools</a:t>
+              <a:t>: FMI supported by &gt;= 250 Tools</a:t>
             </a:r>
           </a:p>
           <a:p>
@@ -10925,7 +12652,7 @@
 </p:sld>
 </file>
 
-<file path=ppt/slides/slide21.xml><?xml version="1.0" encoding="utf-8"?>
+<file path=ppt/slides/slide24.xml><?xml version="1.0" encoding="utf-8"?>
 <p:sld xmlns:a="http://schemas.openxmlformats.org/drawingml/2006/main" xmlns:r="http://schemas.openxmlformats.org/officeDocument/2006/relationships" xmlns:p="http://schemas.openxmlformats.org/presentationml/2006/main">
   <p:cSld>
     <p:spTree>
@@ -10984,6 +12711,31 @@
               <a:buFont typeface="Wingdings" panose="05000000000000000000" pitchFamily="2" charset="2"/>
               <a:buChar char="§"/>
             </a:pPr>
+            <a:r>
+              <a:rPr lang="en-US" dirty="0"/>
+              <a:t>Information on </a:t>
+            </a:r>
+            <a:r>
+              <a:rPr lang="en-US" dirty="0" err="1"/>
+              <a:t>on</a:t>
+            </a:r>
+            <a:r>
+              <a:rPr lang="en-US" dirty="0"/>
+              <a:t> how FMI export and import have been tested</a:t>
+            </a:r>
+            <a:br>
+              <a:rPr lang="en-US" dirty="0"/>
+            </a:br>
+            <a:r>
+              <a:rPr lang="en-US" dirty="0"/>
+              <a:t>provided by the tool vendors and linked in the </a:t>
+            </a:r>
+            <a:r>
+              <a:rPr lang="en-US" dirty="0">
+                <a:hlinkClick r:id="rId2"/>
+              </a:rPr>
+              <a:t>tools list </a:t>
+            </a:r>
             <a:endParaRPr lang="en-US" dirty="0"/>
           </a:p>
           <a:p>
@@ -10993,28 +12745,23 @@
             </a:pPr>
             <a:r>
               <a:rPr lang="en-US" dirty="0"/>
-              <a:t>Information on </a:t>
-            </a:r>
-            <a:r>
-              <a:rPr lang="en-US" dirty="0" err="1"/>
-              <a:t>on</a:t>
-            </a:r>
-            <a:r>
-              <a:rPr lang="en-US" dirty="0"/>
-              <a:t> how FMI export and import have been tested</a:t>
+              <a:t>Tools providing compatibility information are marked with </a:t>
             </a:r>
             <a:br>
               <a:rPr lang="en-US" dirty="0"/>
             </a:br>
             <a:r>
               <a:rPr lang="en-US" dirty="0"/>
-              <a:t>provided by the tool vendors and linked in the </a:t>
-            </a:r>
+              <a:t>a golden star and listed on top of the tools list </a:t>
+            </a:r>
+            <a:br>
+              <a:rPr lang="en-US" dirty="0"/>
+            </a:br>
             <a:r>
               <a:rPr lang="en-US" dirty="0">
-                <a:hlinkClick r:id="rId2"/>
+                <a:hlinkClick r:id="rId3"/>
               </a:rPr>
-              <a:t>tools list </a:t>
+              <a:t>https://fmi-standard.org/tools/</a:t>
             </a:r>
             <a:endParaRPr lang="en-US" dirty="0"/>
           </a:p>
@@ -11032,28 +12779,81 @@
             </a:pPr>
             <a:r>
               <a:rPr lang="en-US" dirty="0"/>
-              <a:t>Tools providing compatibility information are marked with </a:t>
-            </a:r>
-            <a:br>
+              <a:t>Four FMU checkers provided on </a:t>
+            </a:r>
+            <a:r>
+              <a:rPr lang="en-US" dirty="0">
+                <a:hlinkClick r:id="rId4"/>
+              </a:rPr>
+              <a:t>https://fmi-standard.org/validation/</a:t>
+            </a:r>
+            <a:r>
               <a:rPr lang="en-US" dirty="0"/>
-            </a:br>
+              <a:t> </a:t>
+            </a:r>
+          </a:p>
+          <a:p>
+            <a:pPr marL="608013" lvl="1" indent="-342900"/>
+            <a:r>
+              <a:rPr lang="en-US" dirty="0">
+                <a:hlinkClick r:id="rId5"/>
+              </a:rPr>
+              <a:t>FMU Check </a:t>
+            </a:r>
             <a:r>
               <a:rPr lang="en-US" dirty="0"/>
-              <a:t>a golden star and listed on top of the tools list </a:t>
-            </a:r>
-            <a:br>
+              <a:t>(static check, web-based, based on fmpy)</a:t>
+            </a:r>
+          </a:p>
+          <a:p>
+            <a:pPr marL="608013" lvl="1" indent="-342900"/>
+            <a:r>
+              <a:rPr lang="en-US" dirty="0">
+                <a:hlinkClick r:id="rId6"/>
+              </a:rPr>
+              <a:t>fmpy</a:t>
+            </a:r>
+            <a:r>
               <a:rPr lang="en-US" dirty="0"/>
-            </a:br>
+              <a:t> </a:t>
+            </a:r>
+          </a:p>
+          <a:p>
+            <a:pPr marL="608013" lvl="1" indent="-342900"/>
+            <a:r>
+              <a:rPr lang="en-US" dirty="0" err="1"/>
+              <a:t>fmusim</a:t>
+            </a:r>
+            <a:r>
+              <a:rPr lang="en-US" dirty="0"/>
+              <a:t> from the Reference </a:t>
+            </a:r>
             <a:r>
               <a:rPr lang="en-US" dirty="0">
-                <a:hlinkClick r:id="rId3"/>
+                <a:hlinkClick r:id="rId7"/>
               </a:rPr>
-              <a:t>https://fmi-standard.org/tools/</a:t>
+              <a:t>FMUs</a:t>
+            </a:r>
+            <a:endParaRPr lang="en-US" dirty="0"/>
+          </a:p>
+          <a:p>
+            <a:pPr marL="608013" lvl="1" indent="-342900"/>
+            <a:r>
+              <a:rPr lang="en-US" dirty="0">
+                <a:hlinkClick r:id="rId8"/>
+              </a:rPr>
+              <a:t>FMI-VDM-Model </a:t>
             </a:r>
             <a:r>
               <a:rPr lang="en-US" dirty="0"/>
-              <a:t>: </a:t>
-            </a:r>
+              <a:t>Checker</a:t>
+            </a:r>
+          </a:p>
+          <a:p>
+            <a:endParaRPr lang="en-US" dirty="0"/>
+          </a:p>
+          <a:p>
+            <a:endParaRPr lang="en-US" dirty="0"/>
           </a:p>
           <a:p>
             <a:endParaRPr lang="en-US" dirty="0"/>
@@ -11083,8 +12883,13 @@
           <a:p>
             <a:r>
               <a:rPr lang="en-US" dirty="0"/>
-              <a:t>Compatibility Information</a:t>
-            </a:r>
+              <a:t>Compatibility Information and validation </a:t>
+            </a:r>
+            <a:r>
+              <a:rPr lang="en-US" dirty="0" err="1"/>
+              <a:t>tols</a:t>
+            </a:r>
+            <a:endParaRPr lang="en-US" dirty="0"/>
           </a:p>
         </p:txBody>
       </p:sp>
@@ -11103,7 +12908,7 @@
           <p:nvPr/>
         </p:nvPicPr>
         <p:blipFill>
-          <a:blip r:embed="rId4">
+          <a:blip r:embed="rId9">
             <a:extLst>
               <a:ext uri="{28A0092B-C50C-407E-A947-70E740481C1C}">
                 <a14:useLocalDpi xmlns:a14="http://schemas.microsoft.com/office/drawing/2010/main" val="0"/>
@@ -11116,7 +12921,7 @@
         </p:blipFill>
         <p:spPr>
           <a:xfrm>
-            <a:off x="8234338" y="2560788"/>
+            <a:off x="8164764" y="1924684"/>
             <a:ext cx="3957662" cy="1736424"/>
           </a:xfrm>
           <a:prstGeom prst="rect">
@@ -11138,7 +12943,7 @@
 </p:sld>
 </file>
 
-<file path=ppt/slides/slide22.xml><?xml version="1.0" encoding="utf-8"?>
+<file path=ppt/slides/slide25.xml><?xml version="1.0" encoding="utf-8"?>
 <p:sld xmlns:a="http://schemas.openxmlformats.org/drawingml/2006/main" xmlns:r="http://schemas.openxmlformats.org/officeDocument/2006/relationships" xmlns:p="http://schemas.openxmlformats.org/presentationml/2006/main">
   <p:cSld>
     <p:spTree>
@@ -11327,7 +13132,7 @@
 </p:sld>
 </file>
 
-<file path=ppt/slides/slide23.xml><?xml version="1.0" encoding="utf-8"?>
+<file path=ppt/slides/slide26.xml><?xml version="1.0" encoding="utf-8"?>
 <p:sld xmlns:a="http://schemas.openxmlformats.org/drawingml/2006/main" xmlns:r="http://schemas.openxmlformats.org/officeDocument/2006/relationships" xmlns:p="http://schemas.openxmlformats.org/presentationml/2006/main">
   <p:cSld>
     <p:bg>
@@ -11426,7 +13231,7 @@
 </p:sld>
 </file>
 
-<file path=ppt/slides/slide24.xml><?xml version="1.0" encoding="utf-8"?>
+<file path=ppt/slides/slide27.xml><?xml version="1.0" encoding="utf-8"?>
 <p:sld xmlns:a="http://schemas.openxmlformats.org/drawingml/2006/main" xmlns:r="http://schemas.openxmlformats.org/officeDocument/2006/relationships" xmlns:p="http://schemas.openxmlformats.org/presentationml/2006/main">
   <p:cSld>
     <p:spTree>
@@ -12610,7 +14415,7 @@
 </p:sld>
 </file>
 
-<file path=ppt/slides/slide25.xml><?xml version="1.0" encoding="utf-8"?>
+<file path=ppt/slides/slide28.xml><?xml version="1.0" encoding="utf-8"?>
 <p:sld xmlns:a="http://schemas.openxmlformats.org/drawingml/2006/main" xmlns:r="http://schemas.openxmlformats.org/officeDocument/2006/relationships" xmlns:p="http://schemas.openxmlformats.org/presentationml/2006/main">
   <p:cSld>
     <p:spTree>
@@ -13291,7 +15096,7 @@
 </p:sld>
 </file>
 
-<file path=ppt/slides/slide26.xml><?xml version="1.0" encoding="utf-8"?>
+<file path=ppt/slides/slide29.xml><?xml version="1.0" encoding="utf-8"?>
 <p:sld xmlns:a="http://schemas.openxmlformats.org/drawingml/2006/main" xmlns:r="http://schemas.openxmlformats.org/officeDocument/2006/relationships" xmlns:p="http://schemas.openxmlformats.org/presentationml/2006/main">
   <p:cSld>
     <p:spTree>
@@ -14481,7 +16286,350 @@
 </p:sld>
 </file>
 
-<file path=ppt/slides/slide27.xml><?xml version="1.0" encoding="utf-8"?>
+<file path=ppt/slides/slide3.xml><?xml version="1.0" encoding="utf-8"?>
+<p:sld xmlns:a="http://schemas.openxmlformats.org/drawingml/2006/main" xmlns:r="http://schemas.openxmlformats.org/officeDocument/2006/relationships" xmlns:p="http://schemas.openxmlformats.org/presentationml/2006/main">
+  <p:cSld>
+    <p:spTree>
+      <p:nvGrpSpPr>
+        <p:cNvPr id="1" name=""/>
+        <p:cNvGrpSpPr/>
+        <p:nvPr/>
+      </p:nvGrpSpPr>
+      <p:grpSpPr>
+        <a:xfrm>
+          <a:off x="0" y="0"/>
+          <a:ext cx="0" cy="0"/>
+          <a:chOff x="0" y="0"/>
+          <a:chExt cx="0" cy="0"/>
+        </a:xfrm>
+      </p:grpSpPr>
+      <p:sp>
+        <p:nvSpPr>
+          <p:cNvPr id="5" name="Inhaltsplatzhalter 4">
+            <a:extLst>
+              <a:ext uri="{FF2B5EF4-FFF2-40B4-BE49-F238E27FC236}">
+                <a16:creationId xmlns:a16="http://schemas.microsoft.com/office/drawing/2014/main" id="{67430165-842A-5F14-A591-01F55A119BD9}"/>
+              </a:ext>
+            </a:extLst>
+          </p:cNvPr>
+          <p:cNvSpPr>
+            <a:spLocks noGrp="1"/>
+          </p:cNvSpPr>
+          <p:nvPr>
+            <p:ph idx="1"/>
+          </p:nvPr>
+        </p:nvSpPr>
+        <p:spPr/>
+        <p:txBody>
+          <a:bodyPr/>
+          <a:lstStyle/>
+          <a:p>
+            <a:r>
+              <a:rPr lang="en-US" sz="4000" b="1" dirty="0"/>
+              <a:t>Introduction to FMI</a:t>
+            </a:r>
+            <a:endParaRPr lang="en-US" dirty="0"/>
+          </a:p>
+        </p:txBody>
+      </p:sp>
+      <p:sp>
+        <p:nvSpPr>
+          <p:cNvPr id="4" name="Titel 3">
+            <a:extLst>
+              <a:ext uri="{FF2B5EF4-FFF2-40B4-BE49-F238E27FC236}">
+                <a16:creationId xmlns:a16="http://schemas.microsoft.com/office/drawing/2014/main" id="{B1C8FE56-2E01-097C-45C4-D3BC2A5ADD27}"/>
+              </a:ext>
+            </a:extLst>
+          </p:cNvPr>
+          <p:cNvSpPr>
+            <a:spLocks noGrp="1"/>
+          </p:cNvSpPr>
+          <p:nvPr>
+            <p:ph type="title"/>
+          </p:nvPr>
+        </p:nvSpPr>
+        <p:spPr/>
+        <p:txBody>
+          <a:bodyPr/>
+          <a:lstStyle/>
+          <a:p>
+            <a:r>
+              <a:rPr lang="en-US" dirty="0"/>
+              <a:t> </a:t>
+            </a:r>
+          </a:p>
+        </p:txBody>
+      </p:sp>
+      <p:pic>
+        <p:nvPicPr>
+          <p:cNvPr id="2" name="Picture 4">
+            <a:extLst>
+              <a:ext uri="{FF2B5EF4-FFF2-40B4-BE49-F238E27FC236}">
+                <a16:creationId xmlns:a16="http://schemas.microsoft.com/office/drawing/2014/main" id="{C6F665E4-16E4-89B7-F29E-C5589A9A5087}"/>
+              </a:ext>
+            </a:extLst>
+          </p:cNvPr>
+          <p:cNvPicPr>
+            <a:picLocks noChangeAspect="1"/>
+          </p:cNvPicPr>
+          <p:nvPr/>
+        </p:nvPicPr>
+        <p:blipFill>
+          <a:blip r:embed="rId2">
+            <a:extLst>
+              <a:ext uri="{28A0092B-C50C-407E-A947-70E740481C1C}">
+                <a14:useLocalDpi xmlns:a14="http://schemas.microsoft.com/office/drawing/2010/main" val="0"/>
+              </a:ext>
+            </a:extLst>
+          </a:blip>
+          <a:stretch>
+            <a:fillRect/>
+          </a:stretch>
+        </p:blipFill>
+        <p:spPr>
+          <a:xfrm>
+            <a:off x="620184" y="3130345"/>
+            <a:ext cx="5818812" cy="2378376"/>
+          </a:xfrm>
+          <a:prstGeom prst="rect">
+            <a:avLst/>
+          </a:prstGeom>
+        </p:spPr>
+      </p:pic>
+      <p:sp>
+        <p:nvSpPr>
+          <p:cNvPr id="3" name="TextBox 2">
+            <a:extLst>
+              <a:ext uri="{FF2B5EF4-FFF2-40B4-BE49-F238E27FC236}">
+                <a16:creationId xmlns:a16="http://schemas.microsoft.com/office/drawing/2014/main" id="{D9B8BF98-CDEA-294F-5A40-BA21B6EEF1E0}"/>
+              </a:ext>
+            </a:extLst>
+          </p:cNvPr>
+          <p:cNvSpPr txBox="1"/>
+          <p:nvPr/>
+        </p:nvSpPr>
+        <p:spPr>
+          <a:xfrm>
+            <a:off x="664119" y="2022364"/>
+            <a:ext cx="4823460" cy="646331"/>
+          </a:xfrm>
+          <a:prstGeom prst="rect">
+            <a:avLst/>
+          </a:prstGeom>
+          <a:noFill/>
+        </p:spPr>
+        <p:txBody>
+          <a:bodyPr wrap="square" rtlCol="0">
+            <a:spAutoFit/>
+          </a:bodyPr>
+          <a:lstStyle/>
+          <a:p>
+            <a:r>
+              <a:rPr lang="en-US" sz="1800" dirty="0">
+                <a:solidFill>
+                  <a:srgbClr val="5E676E"/>
+                </a:solidFill>
+                <a:latin typeface="+mn-lt"/>
+                <a:cs typeface="+mn-cs"/>
+              </a:rPr>
+              <a:t>Presenter:</a:t>
+            </a:r>
+            <a:br>
+              <a:rPr lang="en-US" sz="1800" dirty="0">
+                <a:solidFill>
+                  <a:srgbClr val="5E676E"/>
+                </a:solidFill>
+                <a:latin typeface="+mn-lt"/>
+                <a:cs typeface="+mn-cs"/>
+              </a:rPr>
+            </a:br>
+            <a:r>
+              <a:rPr lang="en-US" sz="1800" dirty="0">
+                <a:solidFill>
+                  <a:srgbClr val="5E676E"/>
+                </a:solidFill>
+                <a:latin typeface="+mn-lt"/>
+                <a:cs typeface="+mn-cs"/>
+              </a:rPr>
+              <a:t>Christian Bertsch, Bosch Research</a:t>
+            </a:r>
+          </a:p>
+        </p:txBody>
+      </p:sp>
+      <p:sp>
+        <p:nvSpPr>
+          <p:cNvPr id="7" name="TextBox 4">
+            <a:extLst>
+              <a:ext uri="{FF2B5EF4-FFF2-40B4-BE49-F238E27FC236}">
+                <a16:creationId xmlns:a16="http://schemas.microsoft.com/office/drawing/2014/main" id="{978ADD06-3B1E-7161-A229-C13B73EE0EAF}"/>
+              </a:ext>
+            </a:extLst>
+          </p:cNvPr>
+          <p:cNvSpPr txBox="1"/>
+          <p:nvPr/>
+        </p:nvSpPr>
+        <p:spPr>
+          <a:xfrm>
+            <a:off x="9619757" y="3586701"/>
+            <a:ext cx="2142256" cy="369332"/>
+          </a:xfrm>
+          <a:prstGeom prst="rect">
+            <a:avLst/>
+          </a:prstGeom>
+          <a:noFill/>
+        </p:spPr>
+        <p:txBody>
+          <a:bodyPr wrap="square" rtlCol="0">
+            <a:spAutoFit/>
+          </a:bodyPr>
+          <a:lstStyle/>
+          <a:p>
+            <a:r>
+              <a:rPr lang="en-US" sz="1800" dirty="0">
+                <a:solidFill>
+                  <a:srgbClr val="5E676E"/>
+                </a:solidFill>
+                <a:latin typeface="+mn-lt"/>
+                <a:cs typeface="+mn-cs"/>
+              </a:rPr>
+              <a:t>Online Materials:</a:t>
+            </a:r>
+          </a:p>
+        </p:txBody>
+      </p:sp>
+      <p:sp>
+        <p:nvSpPr>
+          <p:cNvPr id="10" name="TextBox 6">
+            <a:extLst>
+              <a:ext uri="{FF2B5EF4-FFF2-40B4-BE49-F238E27FC236}">
+                <a16:creationId xmlns:a16="http://schemas.microsoft.com/office/drawing/2014/main" id="{029415F6-21ED-FE69-17BC-A2F9B50AC688}"/>
+              </a:ext>
+            </a:extLst>
+          </p:cNvPr>
+          <p:cNvSpPr txBox="1"/>
+          <p:nvPr/>
+        </p:nvSpPr>
+        <p:spPr>
+          <a:xfrm>
+            <a:off x="9619757" y="5961260"/>
+            <a:ext cx="4823460" cy="738664"/>
+          </a:xfrm>
+          <a:prstGeom prst="rect">
+            <a:avLst/>
+          </a:prstGeom>
+          <a:noFill/>
+        </p:spPr>
+        <p:txBody>
+          <a:bodyPr wrap="square" rtlCol="0">
+            <a:spAutoFit/>
+          </a:bodyPr>
+          <a:lstStyle/>
+          <a:p>
+            <a:r>
+              <a:rPr lang="en-US" sz="1200" dirty="0">
+                <a:solidFill>
+                  <a:srgbClr val="5E676E"/>
+                </a:solidFill>
+                <a:latin typeface="+mn-lt"/>
+                <a:cs typeface="+mn-cs"/>
+                <a:hlinkClick r:id="rId3"/>
+              </a:rPr>
+              <a:t>https://github.com/modelica/</a:t>
+            </a:r>
+            <a:br>
+              <a:rPr lang="en-US" sz="1200" dirty="0">
+                <a:solidFill>
+                  <a:srgbClr val="5E676E"/>
+                </a:solidFill>
+                <a:latin typeface="+mn-lt"/>
+                <a:cs typeface="+mn-cs"/>
+                <a:hlinkClick r:id="rId3"/>
+              </a:rPr>
+            </a:br>
+            <a:r>
+              <a:rPr lang="en-US" sz="1200" dirty="0">
+                <a:solidFill>
+                  <a:srgbClr val="5E676E"/>
+                </a:solidFill>
+                <a:latin typeface="+mn-lt"/>
+                <a:cs typeface="+mn-cs"/>
+                <a:hlinkClick r:id="rId3"/>
+              </a:rPr>
+              <a:t>fmi-beginners-tutorial-2024/tree/main</a:t>
+            </a:r>
+            <a:endParaRPr lang="en-US" sz="1200" dirty="0">
+              <a:solidFill>
+                <a:srgbClr val="5E676E"/>
+              </a:solidFill>
+              <a:latin typeface="+mn-lt"/>
+              <a:cs typeface="+mn-cs"/>
+            </a:endParaRPr>
+          </a:p>
+          <a:p>
+            <a:endParaRPr lang="en-US" sz="1800" dirty="0">
+              <a:solidFill>
+                <a:srgbClr val="5E676E"/>
+              </a:solidFill>
+              <a:latin typeface="+mn-lt"/>
+              <a:cs typeface="+mn-cs"/>
+            </a:endParaRPr>
+          </a:p>
+        </p:txBody>
+      </p:sp>
+      <p:pic>
+        <p:nvPicPr>
+          <p:cNvPr id="11" name="Grafik 10">
+            <a:extLst>
+              <a:ext uri="{FF2B5EF4-FFF2-40B4-BE49-F238E27FC236}">
+                <a16:creationId xmlns:a16="http://schemas.microsoft.com/office/drawing/2014/main" id="{85547DFE-87A6-5D51-B6B2-16817869D8DB}"/>
+              </a:ext>
+            </a:extLst>
+          </p:cNvPr>
+          <p:cNvPicPr>
+            <a:picLocks noChangeAspect="1"/>
+          </p:cNvPicPr>
+          <p:nvPr/>
+        </p:nvPicPr>
+        <p:blipFill>
+          <a:blip r:embed="rId4">
+            <a:extLst>
+              <a:ext uri="{28A0092B-C50C-407E-A947-70E740481C1C}">
+                <a14:useLocalDpi xmlns:a14="http://schemas.microsoft.com/office/drawing/2010/main" val="0"/>
+              </a:ext>
+              <a:ext uri="{96DAC541-7B7A-43D3-8B79-37D633B846F1}">
+                <asvg:svgBlip xmlns:asvg="http://schemas.microsoft.com/office/drawing/2016/SVG/main" r:embed="rId5"/>
+              </a:ext>
+            </a:extLst>
+          </a:blip>
+          <a:stretch>
+            <a:fillRect/>
+          </a:stretch>
+        </p:blipFill>
+        <p:spPr>
+          <a:xfrm>
+            <a:off x="9787923" y="4049318"/>
+            <a:ext cx="1974090" cy="1974090"/>
+          </a:xfrm>
+          <a:prstGeom prst="rect">
+            <a:avLst/>
+          </a:prstGeom>
+        </p:spPr>
+      </p:pic>
+    </p:spTree>
+    <p:extLst>
+      <p:ext uri="{BB962C8B-B14F-4D97-AF65-F5344CB8AC3E}">
+        <p14:creationId xmlns:p14="http://schemas.microsoft.com/office/powerpoint/2010/main" val="3567263522"/>
+      </p:ext>
+    </p:extLst>
+  </p:cSld>
+  <p:clrMapOvr>
+    <a:masterClrMapping/>
+  </p:clrMapOvr>
+  <p:transition/>
+</p:sld>
+</file>
+
+<file path=ppt/slides/slide30.xml><?xml version="1.0" encoding="utf-8"?>
 <p:sld xmlns:a="http://schemas.openxmlformats.org/drawingml/2006/main" xmlns:r="http://schemas.openxmlformats.org/officeDocument/2006/relationships" xmlns:p="http://schemas.openxmlformats.org/presentationml/2006/main">
   <p:cSld>
     <p:bg>
@@ -14580,7 +16728,7 @@
 </p:sld>
 </file>
 
-<file path=ppt/slides/slide28.xml><?xml version="1.0" encoding="utf-8"?>
+<file path=ppt/slides/slide31.xml><?xml version="1.0" encoding="utf-8"?>
 <p:sld xmlns:a="http://schemas.openxmlformats.org/drawingml/2006/main" xmlns:r="http://schemas.openxmlformats.org/officeDocument/2006/relationships" xmlns:p="http://schemas.openxmlformats.org/presentationml/2006/main">
   <p:cSld>
     <p:spTree>
@@ -14999,7 +17147,7 @@
 </p:sld>
 </file>
 
-<file path=ppt/slides/slide29.xml><?xml version="1.0" encoding="utf-8"?>
+<file path=ppt/slides/slide32.xml><?xml version="1.0" encoding="utf-8"?>
 <p:sld xmlns:a="http://schemas.openxmlformats.org/drawingml/2006/main" xmlns:r="http://schemas.openxmlformats.org/officeDocument/2006/relationships" xmlns:p="http://schemas.openxmlformats.org/presentationml/2006/main">
   <p:cSld>
     <p:spTree>
@@ -16472,350 +18620,7 @@
 </p:sld>
 </file>
 
-<file path=ppt/slides/slide3.xml><?xml version="1.0" encoding="utf-8"?>
-<p:sld xmlns:a="http://schemas.openxmlformats.org/drawingml/2006/main" xmlns:r="http://schemas.openxmlformats.org/officeDocument/2006/relationships" xmlns:p="http://schemas.openxmlformats.org/presentationml/2006/main">
-  <p:cSld>
-    <p:spTree>
-      <p:nvGrpSpPr>
-        <p:cNvPr id="1" name=""/>
-        <p:cNvGrpSpPr/>
-        <p:nvPr/>
-      </p:nvGrpSpPr>
-      <p:grpSpPr>
-        <a:xfrm>
-          <a:off x="0" y="0"/>
-          <a:ext cx="0" cy="0"/>
-          <a:chOff x="0" y="0"/>
-          <a:chExt cx="0" cy="0"/>
-        </a:xfrm>
-      </p:grpSpPr>
-      <p:sp>
-        <p:nvSpPr>
-          <p:cNvPr id="5" name="Inhaltsplatzhalter 4">
-            <a:extLst>
-              <a:ext uri="{FF2B5EF4-FFF2-40B4-BE49-F238E27FC236}">
-                <a16:creationId xmlns:a16="http://schemas.microsoft.com/office/drawing/2014/main" id="{67430165-842A-5F14-A591-01F55A119BD9}"/>
-              </a:ext>
-            </a:extLst>
-          </p:cNvPr>
-          <p:cNvSpPr>
-            <a:spLocks noGrp="1"/>
-          </p:cNvSpPr>
-          <p:nvPr>
-            <p:ph idx="1"/>
-          </p:nvPr>
-        </p:nvSpPr>
-        <p:spPr/>
-        <p:txBody>
-          <a:bodyPr/>
-          <a:lstStyle/>
-          <a:p>
-            <a:r>
-              <a:rPr lang="en-US" sz="4000" b="1" dirty="0"/>
-              <a:t>Introduction to FMI</a:t>
-            </a:r>
-            <a:endParaRPr lang="en-US" dirty="0"/>
-          </a:p>
-        </p:txBody>
-      </p:sp>
-      <p:sp>
-        <p:nvSpPr>
-          <p:cNvPr id="4" name="Titel 3">
-            <a:extLst>
-              <a:ext uri="{FF2B5EF4-FFF2-40B4-BE49-F238E27FC236}">
-                <a16:creationId xmlns:a16="http://schemas.microsoft.com/office/drawing/2014/main" id="{B1C8FE56-2E01-097C-45C4-D3BC2A5ADD27}"/>
-              </a:ext>
-            </a:extLst>
-          </p:cNvPr>
-          <p:cNvSpPr>
-            <a:spLocks noGrp="1"/>
-          </p:cNvSpPr>
-          <p:nvPr>
-            <p:ph type="title"/>
-          </p:nvPr>
-        </p:nvSpPr>
-        <p:spPr/>
-        <p:txBody>
-          <a:bodyPr/>
-          <a:lstStyle/>
-          <a:p>
-            <a:r>
-              <a:rPr lang="en-US" dirty="0"/>
-              <a:t> </a:t>
-            </a:r>
-          </a:p>
-        </p:txBody>
-      </p:sp>
-      <p:pic>
-        <p:nvPicPr>
-          <p:cNvPr id="2" name="Picture 4">
-            <a:extLst>
-              <a:ext uri="{FF2B5EF4-FFF2-40B4-BE49-F238E27FC236}">
-                <a16:creationId xmlns:a16="http://schemas.microsoft.com/office/drawing/2014/main" id="{C6F665E4-16E4-89B7-F29E-C5589A9A5087}"/>
-              </a:ext>
-            </a:extLst>
-          </p:cNvPr>
-          <p:cNvPicPr>
-            <a:picLocks noChangeAspect="1"/>
-          </p:cNvPicPr>
-          <p:nvPr/>
-        </p:nvPicPr>
-        <p:blipFill>
-          <a:blip r:embed="rId2">
-            <a:extLst>
-              <a:ext uri="{28A0092B-C50C-407E-A947-70E740481C1C}">
-                <a14:useLocalDpi xmlns:a14="http://schemas.microsoft.com/office/drawing/2010/main" val="0"/>
-              </a:ext>
-            </a:extLst>
-          </a:blip>
-          <a:stretch>
-            <a:fillRect/>
-          </a:stretch>
-        </p:blipFill>
-        <p:spPr>
-          <a:xfrm>
-            <a:off x="620184" y="3130345"/>
-            <a:ext cx="5818812" cy="2378376"/>
-          </a:xfrm>
-          <a:prstGeom prst="rect">
-            <a:avLst/>
-          </a:prstGeom>
-        </p:spPr>
-      </p:pic>
-      <p:sp>
-        <p:nvSpPr>
-          <p:cNvPr id="3" name="TextBox 2">
-            <a:extLst>
-              <a:ext uri="{FF2B5EF4-FFF2-40B4-BE49-F238E27FC236}">
-                <a16:creationId xmlns:a16="http://schemas.microsoft.com/office/drawing/2014/main" id="{D9B8BF98-CDEA-294F-5A40-BA21B6EEF1E0}"/>
-              </a:ext>
-            </a:extLst>
-          </p:cNvPr>
-          <p:cNvSpPr txBox="1"/>
-          <p:nvPr/>
-        </p:nvSpPr>
-        <p:spPr>
-          <a:xfrm>
-            <a:off x="664119" y="2022364"/>
-            <a:ext cx="4823460" cy="646331"/>
-          </a:xfrm>
-          <a:prstGeom prst="rect">
-            <a:avLst/>
-          </a:prstGeom>
-          <a:noFill/>
-        </p:spPr>
-        <p:txBody>
-          <a:bodyPr wrap="square" rtlCol="0">
-            <a:spAutoFit/>
-          </a:bodyPr>
-          <a:lstStyle/>
-          <a:p>
-            <a:r>
-              <a:rPr lang="en-US" sz="1800" dirty="0">
-                <a:solidFill>
-                  <a:srgbClr val="5E676E"/>
-                </a:solidFill>
-                <a:latin typeface="+mn-lt"/>
-                <a:cs typeface="+mn-cs"/>
-              </a:rPr>
-              <a:t>Presenter:</a:t>
-            </a:r>
-            <a:br>
-              <a:rPr lang="en-US" sz="1800" dirty="0">
-                <a:solidFill>
-                  <a:srgbClr val="5E676E"/>
-                </a:solidFill>
-                <a:latin typeface="+mn-lt"/>
-                <a:cs typeface="+mn-cs"/>
-              </a:rPr>
-            </a:br>
-            <a:r>
-              <a:rPr lang="en-US" sz="1800" dirty="0">
-                <a:solidFill>
-                  <a:srgbClr val="5E676E"/>
-                </a:solidFill>
-                <a:latin typeface="+mn-lt"/>
-                <a:cs typeface="+mn-cs"/>
-              </a:rPr>
-              <a:t>Christian Bertsch, Bosch Research</a:t>
-            </a:r>
-          </a:p>
-        </p:txBody>
-      </p:sp>
-      <p:sp>
-        <p:nvSpPr>
-          <p:cNvPr id="7" name="TextBox 4">
-            <a:extLst>
-              <a:ext uri="{FF2B5EF4-FFF2-40B4-BE49-F238E27FC236}">
-                <a16:creationId xmlns:a16="http://schemas.microsoft.com/office/drawing/2014/main" id="{978ADD06-3B1E-7161-A229-C13B73EE0EAF}"/>
-              </a:ext>
-            </a:extLst>
-          </p:cNvPr>
-          <p:cNvSpPr txBox="1"/>
-          <p:nvPr/>
-        </p:nvSpPr>
-        <p:spPr>
-          <a:xfrm>
-            <a:off x="9619757" y="3586701"/>
-            <a:ext cx="2142256" cy="369332"/>
-          </a:xfrm>
-          <a:prstGeom prst="rect">
-            <a:avLst/>
-          </a:prstGeom>
-          <a:noFill/>
-        </p:spPr>
-        <p:txBody>
-          <a:bodyPr wrap="square" rtlCol="0">
-            <a:spAutoFit/>
-          </a:bodyPr>
-          <a:lstStyle/>
-          <a:p>
-            <a:r>
-              <a:rPr lang="en-US" sz="1800" dirty="0">
-                <a:solidFill>
-                  <a:srgbClr val="5E676E"/>
-                </a:solidFill>
-                <a:latin typeface="+mn-lt"/>
-                <a:cs typeface="+mn-cs"/>
-              </a:rPr>
-              <a:t>Online Materials:</a:t>
-            </a:r>
-          </a:p>
-        </p:txBody>
-      </p:sp>
-      <p:sp>
-        <p:nvSpPr>
-          <p:cNvPr id="10" name="TextBox 6">
-            <a:extLst>
-              <a:ext uri="{FF2B5EF4-FFF2-40B4-BE49-F238E27FC236}">
-                <a16:creationId xmlns:a16="http://schemas.microsoft.com/office/drawing/2014/main" id="{029415F6-21ED-FE69-17BC-A2F9B50AC688}"/>
-              </a:ext>
-            </a:extLst>
-          </p:cNvPr>
-          <p:cNvSpPr txBox="1"/>
-          <p:nvPr/>
-        </p:nvSpPr>
-        <p:spPr>
-          <a:xfrm>
-            <a:off x="9619757" y="5961260"/>
-            <a:ext cx="4823460" cy="738664"/>
-          </a:xfrm>
-          <a:prstGeom prst="rect">
-            <a:avLst/>
-          </a:prstGeom>
-          <a:noFill/>
-        </p:spPr>
-        <p:txBody>
-          <a:bodyPr wrap="square" rtlCol="0">
-            <a:spAutoFit/>
-          </a:bodyPr>
-          <a:lstStyle/>
-          <a:p>
-            <a:r>
-              <a:rPr lang="en-US" sz="1200" dirty="0">
-                <a:solidFill>
-                  <a:srgbClr val="5E676E"/>
-                </a:solidFill>
-                <a:latin typeface="+mn-lt"/>
-                <a:cs typeface="+mn-cs"/>
-                <a:hlinkClick r:id="rId3"/>
-              </a:rPr>
-              <a:t>https://github.com/modelica/</a:t>
-            </a:r>
-            <a:br>
-              <a:rPr lang="en-US" sz="1200" dirty="0">
-                <a:solidFill>
-                  <a:srgbClr val="5E676E"/>
-                </a:solidFill>
-                <a:latin typeface="+mn-lt"/>
-                <a:cs typeface="+mn-cs"/>
-                <a:hlinkClick r:id="rId3"/>
-              </a:rPr>
-            </a:br>
-            <a:r>
-              <a:rPr lang="en-US" sz="1200" dirty="0">
-                <a:solidFill>
-                  <a:srgbClr val="5E676E"/>
-                </a:solidFill>
-                <a:latin typeface="+mn-lt"/>
-                <a:cs typeface="+mn-cs"/>
-                <a:hlinkClick r:id="rId3"/>
-              </a:rPr>
-              <a:t>fmi-beginners-tutorial-2024/tree/main</a:t>
-            </a:r>
-            <a:endParaRPr lang="en-US" sz="1200" dirty="0">
-              <a:solidFill>
-                <a:srgbClr val="5E676E"/>
-              </a:solidFill>
-              <a:latin typeface="+mn-lt"/>
-              <a:cs typeface="+mn-cs"/>
-            </a:endParaRPr>
-          </a:p>
-          <a:p>
-            <a:endParaRPr lang="en-US" sz="1800" dirty="0">
-              <a:solidFill>
-                <a:srgbClr val="5E676E"/>
-              </a:solidFill>
-              <a:latin typeface="+mn-lt"/>
-              <a:cs typeface="+mn-cs"/>
-            </a:endParaRPr>
-          </a:p>
-        </p:txBody>
-      </p:sp>
-      <p:pic>
-        <p:nvPicPr>
-          <p:cNvPr id="11" name="Grafik 10">
-            <a:extLst>
-              <a:ext uri="{FF2B5EF4-FFF2-40B4-BE49-F238E27FC236}">
-                <a16:creationId xmlns:a16="http://schemas.microsoft.com/office/drawing/2014/main" id="{85547DFE-87A6-5D51-B6B2-16817869D8DB}"/>
-              </a:ext>
-            </a:extLst>
-          </p:cNvPr>
-          <p:cNvPicPr>
-            <a:picLocks noChangeAspect="1"/>
-          </p:cNvPicPr>
-          <p:nvPr/>
-        </p:nvPicPr>
-        <p:blipFill>
-          <a:blip r:embed="rId4">
-            <a:extLst>
-              <a:ext uri="{28A0092B-C50C-407E-A947-70E740481C1C}">
-                <a14:useLocalDpi xmlns:a14="http://schemas.microsoft.com/office/drawing/2010/main" val="0"/>
-              </a:ext>
-              <a:ext uri="{96DAC541-7B7A-43D3-8B79-37D633B846F1}">
-                <asvg:svgBlip xmlns:asvg="http://schemas.microsoft.com/office/drawing/2016/SVG/main" r:embed="rId5"/>
-              </a:ext>
-            </a:extLst>
-          </a:blip>
-          <a:stretch>
-            <a:fillRect/>
-          </a:stretch>
-        </p:blipFill>
-        <p:spPr>
-          <a:xfrm>
-            <a:off x="9787923" y="4049318"/>
-            <a:ext cx="1974090" cy="1974090"/>
-          </a:xfrm>
-          <a:prstGeom prst="rect">
-            <a:avLst/>
-          </a:prstGeom>
-        </p:spPr>
-      </p:pic>
-    </p:spTree>
-    <p:extLst>
-      <p:ext uri="{BB962C8B-B14F-4D97-AF65-F5344CB8AC3E}">
-        <p14:creationId xmlns:p14="http://schemas.microsoft.com/office/powerpoint/2010/main" val="3567263522"/>
-      </p:ext>
-    </p:extLst>
-  </p:cSld>
-  <p:clrMapOvr>
-    <a:masterClrMapping/>
-  </p:clrMapOvr>
-  <p:transition/>
-</p:sld>
-</file>
-
-<file path=ppt/slides/slide30.xml><?xml version="1.0" encoding="utf-8"?>
+<file path=ppt/slides/slide33.xml><?xml version="1.0" encoding="utf-8"?>
 <p:sld xmlns:a="http://schemas.openxmlformats.org/drawingml/2006/main" xmlns:r="http://schemas.openxmlformats.org/officeDocument/2006/relationships" xmlns:p="http://schemas.openxmlformats.org/presentationml/2006/main">
   <p:cSld>
     <p:spTree>
@@ -17053,7 +18858,7 @@
 </p:sld>
 </file>
 
-<file path=ppt/slides/slide31.xml><?xml version="1.0" encoding="utf-8"?>
+<file path=ppt/slides/slide34.xml><?xml version="1.0" encoding="utf-8"?>
 <p:sld xmlns:a="http://schemas.openxmlformats.org/drawingml/2006/main" xmlns:r="http://schemas.openxmlformats.org/officeDocument/2006/relationships" xmlns:p="http://schemas.openxmlformats.org/presentationml/2006/main">
   <p:cSld>
     <p:spTree>
@@ -18748,14 +20553,6 @@
 <file path=ppt/slides/slide8.xml><?xml version="1.0" encoding="utf-8"?>
 <p:sld xmlns:a="http://schemas.openxmlformats.org/drawingml/2006/main" xmlns:r="http://schemas.openxmlformats.org/officeDocument/2006/relationships" xmlns:p="http://schemas.openxmlformats.org/presentationml/2006/main">
   <p:cSld>
-    <p:bg>
-      <p:bgPr>
-        <a:solidFill>
-          <a:schemeClr val="accent5"/>
-        </a:solidFill>
-        <a:effectLst/>
-      </p:bgPr>
-    </p:bg>
     <p:spTree>
       <p:nvGrpSpPr>
         <p:cNvPr id="1" name=""/>
@@ -18775,7 +20572,7 @@
           <p:cNvPr id="2" name="Inhaltsplatzhalter 1">
             <a:extLst>
               <a:ext uri="{FF2B5EF4-FFF2-40B4-BE49-F238E27FC236}">
-                <a16:creationId xmlns:a16="http://schemas.microsoft.com/office/drawing/2014/main" id="{0942DFE2-B8E9-A1D6-3FAF-EB02B96DC61F}"/>
+                <a16:creationId xmlns:a16="http://schemas.microsoft.com/office/drawing/2014/main" id="{1FFAAB93-E065-3CD9-61F8-6EF6BE3DACF7}"/>
               </a:ext>
             </a:extLst>
           </p:cNvPr>
@@ -18792,18 +20589,73 @@
           <a:lstStyle/>
           <a:p>
             <a:r>
-              <a:rPr lang="en-US" sz="4000" b="1" dirty="0"/>
-              <a:t>FMI: Technical Fundamentals</a:t>
-            </a:r>
-          </a:p>
-          <a:p>
-            <a:endParaRPr lang="en-US" sz="4000" b="1" dirty="0"/>
-          </a:p>
-          <a:p>
-            <a:r>
-              <a:rPr lang="en-US" sz="4000" i="1" dirty="0"/>
-              <a:t>“How does FMI work?”</a:t>
-            </a:r>
+              <a:rPr lang="en-US" b="1" dirty="0"/>
+              <a:t>The Functional Mock-up Interface is the leading free, vendor-neutral standard for the exchange and co-simulation of simulation models</a:t>
+            </a:r>
+          </a:p>
+          <a:p>
+            <a:pPr marL="342900" indent="-342900">
+              <a:buFont typeface="Wingdings" panose="05000000000000000000" pitchFamily="2" charset="2"/>
+              <a:buChar char="§"/>
+            </a:pPr>
+            <a:r>
+              <a:rPr lang="en-US" sz="2000" dirty="0"/>
+              <a:t>Current releases: </a:t>
+            </a:r>
+            <a:r>
+              <a:rPr lang="en-US" sz="2000" b="1" dirty="0"/>
+              <a:t>FMI 2.0.5 </a:t>
+            </a:r>
+            <a:r>
+              <a:rPr lang="en-US" sz="2000" dirty="0"/>
+              <a:t>and </a:t>
+            </a:r>
+            <a:r>
+              <a:rPr lang="en-US" sz="2000" b="1" dirty="0"/>
+              <a:t>FMI 3.0.2</a:t>
+            </a:r>
+          </a:p>
+          <a:p>
+            <a:pPr marL="342900" indent="-342900">
+              <a:buFont typeface="Wingdings" panose="05000000000000000000" pitchFamily="2" charset="2"/>
+              <a:buChar char="§"/>
+            </a:pPr>
+            <a:r>
+              <a:rPr lang="en-US" sz="2000" b="1" dirty="0"/>
+              <a:t>250+ tools </a:t>
+            </a:r>
+            <a:r>
+              <a:rPr lang="en-US" sz="2000" dirty="0"/>
+              <a:t>and libraries </a:t>
+            </a:r>
+            <a:r>
+              <a:rPr lang="en-US" dirty="0"/>
+              <a:t>s</a:t>
+            </a:r>
+            <a:r>
+              <a:rPr lang="en-US" sz="2000" dirty="0"/>
+              <a:t>upport</a:t>
+            </a:r>
+            <a:r>
+              <a:rPr lang="en-US" dirty="0"/>
+              <a:t> FMI (</a:t>
+            </a:r>
+            <a:r>
+              <a:rPr lang="en-US" dirty="0">
+                <a:hlinkClick r:id="rId2"/>
+              </a:rPr>
+              <a:t>https://fmi-standard.org/tools/</a:t>
+            </a:r>
+            <a:r>
+              <a:rPr lang="en-US" dirty="0"/>
+              <a:t>) </a:t>
+            </a:r>
+          </a:p>
+          <a:p>
+            <a:endParaRPr lang="en-US" sz="800" dirty="0"/>
+          </a:p>
+          <a:p>
+            <a:endParaRPr lang="en-US" dirty="0"/>
           </a:p>
         </p:txBody>
       </p:sp>
@@ -18812,7 +20664,7 @@
           <p:cNvPr id="3" name="Titel 2">
             <a:extLst>
               <a:ext uri="{FF2B5EF4-FFF2-40B4-BE49-F238E27FC236}">
-                <a16:creationId xmlns:a16="http://schemas.microsoft.com/office/drawing/2014/main" id="{EF0451EF-4275-B5F4-7844-13C179D59EED}"/>
+                <a16:creationId xmlns:a16="http://schemas.microsoft.com/office/drawing/2014/main" id="{9AA02D14-9ACA-A806-A7E8-69B813F761BD}"/>
               </a:ext>
             </a:extLst>
           </p:cNvPr>
@@ -18830,7 +20682,148 @@
           <a:p>
             <a:r>
               <a:rPr lang="en-US" dirty="0"/>
-              <a:t> </a:t>
+              <a:t>The Functional Mock-Up Interface today		</a:t>
+            </a:r>
+          </a:p>
+        </p:txBody>
+      </p:sp>
+      <p:pic>
+        <p:nvPicPr>
+          <p:cNvPr id="4" name="Picture 4">
+            <a:extLst>
+              <a:ext uri="{FF2B5EF4-FFF2-40B4-BE49-F238E27FC236}">
+                <a16:creationId xmlns:a16="http://schemas.microsoft.com/office/drawing/2014/main" id="{C6F665E4-16E4-89B7-F29E-C5589A9A5087}"/>
+              </a:ext>
+            </a:extLst>
+          </p:cNvPr>
+          <p:cNvPicPr>
+            <a:picLocks noChangeAspect="1"/>
+          </p:cNvPicPr>
+          <p:nvPr/>
+        </p:nvPicPr>
+        <p:blipFill>
+          <a:blip r:embed="rId3">
+            <a:extLst>
+              <a:ext uri="{28A0092B-C50C-407E-A947-70E740481C1C}">
+                <a14:useLocalDpi xmlns:a14="http://schemas.microsoft.com/office/drawing/2010/main" val="0"/>
+              </a:ext>
+            </a:extLst>
+          </a:blip>
+          <a:stretch>
+            <a:fillRect/>
+          </a:stretch>
+        </p:blipFill>
+        <p:spPr>
+          <a:xfrm>
+            <a:off x="975750" y="3697272"/>
+            <a:ext cx="4735849" cy="1935727"/>
+          </a:xfrm>
+          <a:prstGeom prst="rect">
+            <a:avLst/>
+          </a:prstGeom>
+        </p:spPr>
+      </p:pic>
+      <p:pic>
+        <p:nvPicPr>
+          <p:cNvPr id="6" name="Grafik 5">
+            <a:extLst>
+              <a:ext uri="{FF2B5EF4-FFF2-40B4-BE49-F238E27FC236}">
+                <a16:creationId xmlns:a16="http://schemas.microsoft.com/office/drawing/2014/main" id="{AFA14F67-58AE-A76C-F973-960B2BCB0F70}"/>
+              </a:ext>
+            </a:extLst>
+          </p:cNvPr>
+          <p:cNvPicPr>
+            <a:picLocks noChangeAspect="1"/>
+          </p:cNvPicPr>
+          <p:nvPr/>
+        </p:nvPicPr>
+        <p:blipFill>
+          <a:blip r:embed="rId4"/>
+          <a:stretch>
+            <a:fillRect/>
+          </a:stretch>
+        </p:blipFill>
+        <p:spPr>
+          <a:xfrm>
+            <a:off x="9187285" y="2226365"/>
+            <a:ext cx="2075944" cy="3995058"/>
+          </a:xfrm>
+          <a:prstGeom prst="rect">
+            <a:avLst/>
+          </a:prstGeom>
+        </p:spPr>
+      </p:pic>
+      <p:sp>
+        <p:nvSpPr>
+          <p:cNvPr id="5" name="Rectangle 4">
+            <a:extLst>
+              <a:ext uri="{FF2B5EF4-FFF2-40B4-BE49-F238E27FC236}">
+                <a16:creationId xmlns:a16="http://schemas.microsoft.com/office/drawing/2014/main" id="{91DE75F3-32FF-8F63-21C1-0640612FA2C4}"/>
+              </a:ext>
+            </a:extLst>
+          </p:cNvPr>
+          <p:cNvSpPr/>
+          <p:nvPr/>
+        </p:nvSpPr>
+        <p:spPr>
+          <a:xfrm>
+            <a:off x="0" y="6379297"/>
+            <a:ext cx="4629150" cy="326303"/>
+          </a:xfrm>
+          <a:prstGeom prst="rect">
+            <a:avLst/>
+          </a:prstGeom>
+          <a:solidFill>
+            <a:srgbClr val="FFFFFF"/>
+          </a:solidFill>
+          <a:ln>
+            <a:noFill/>
+          </a:ln>
+        </p:spPr>
+        <p:style>
+          <a:lnRef idx="2">
+            <a:schemeClr val="dk1">
+              <a:shade val="15000"/>
+            </a:schemeClr>
+          </a:lnRef>
+          <a:fillRef idx="1">
+            <a:schemeClr val="dk1"/>
+          </a:fillRef>
+          <a:effectRef idx="0">
+            <a:schemeClr val="dk1"/>
+          </a:effectRef>
+          <a:fontRef idx="minor">
+            <a:schemeClr val="lt1"/>
+          </a:fontRef>
+        </p:style>
+        <p:txBody>
+          <a:bodyPr rtlCol="0" anchor="ctr"/>
+          <a:lstStyle/>
+          <a:p>
+            <a:pPr algn="ctr"/>
+            <a:r>
+              <a:rPr lang="de-DE" sz="1000" dirty="0">
+                <a:solidFill>
+                  <a:srgbClr val="C00000"/>
+                </a:solidFill>
+              </a:rPr>
+              <a:t>© 2025 Modelica </a:t>
+            </a:r>
+            <a:r>
+              <a:rPr lang="de-DE" sz="1000" dirty="0" err="1">
+                <a:solidFill>
+                  <a:srgbClr val="C00000"/>
+                </a:solidFill>
+              </a:rPr>
+              <a:t>Association</a:t>
+            </a:r>
+            <a:r>
+              <a:rPr lang="de-DE" sz="1000" dirty="0">
+                <a:solidFill>
+                  <a:srgbClr val="C00000"/>
+                </a:solidFill>
+              </a:rPr>
+              <a:t> Project FMI | fmi-standard.org</a:t>
             </a:r>
           </a:p>
         </p:txBody>
@@ -18838,7 +20831,7 @@
     </p:spTree>
     <p:extLst>
       <p:ext uri="{BB962C8B-B14F-4D97-AF65-F5344CB8AC3E}">
-        <p14:creationId xmlns:p14="http://schemas.microsoft.com/office/powerpoint/2010/main" val="3325233337"/>
+        <p14:creationId xmlns:p14="http://schemas.microsoft.com/office/powerpoint/2010/main" val="581147674"/>
       </p:ext>
     </p:extLst>
   </p:cSld>
@@ -18871,7 +20864,7 @@
           <p:cNvPr id="2" name="Inhaltsplatzhalter 1">
             <a:extLst>
               <a:ext uri="{FF2B5EF4-FFF2-40B4-BE49-F238E27FC236}">
-                <a16:creationId xmlns:a16="http://schemas.microsoft.com/office/drawing/2014/main" id="{6E30A60D-6EC1-A8E9-1E69-3CE6DED3015B}"/>
+                <a16:creationId xmlns:a16="http://schemas.microsoft.com/office/drawing/2014/main" id="{1B269E9D-EA4D-6262-C777-32AB53291884}"/>
               </a:ext>
             </a:extLst>
           </p:cNvPr>
@@ -18888,9 +20881,321 @@
           <a:lstStyle/>
           <a:p>
             <a:r>
-              <a:rPr lang="en-US" dirty="0"/>
-              <a:t> </a:t>
-            </a:r>
+              <a:rPr lang="en-US" sz="2000" dirty="0"/>
+              <a:t>The Modelica Association is a non-profit, non-governmental organization with </a:t>
+            </a:r>
+            <a:br>
+              <a:rPr lang="en-US" sz="2000" dirty="0"/>
+            </a:br>
+            <a:r>
+              <a:rPr lang="en-US" sz="2000" dirty="0"/>
+              <a:t>the aim of </a:t>
+            </a:r>
+            <a:r>
+              <a:rPr lang="en-US" sz="2000" b="1" dirty="0"/>
+              <a:t>developing and promoting open and coordinated standards </a:t>
+            </a:r>
+            <a:br>
+              <a:rPr lang="en-US" sz="2000" b="1" dirty="0"/>
+            </a:br>
+            <a:r>
+              <a:rPr lang="en-US" sz="2000" b="1" dirty="0"/>
+              <a:t>for system modelling and simulation.</a:t>
+            </a:r>
+            <a:endParaRPr lang="en-US" b="1" dirty="0"/>
+          </a:p>
+          <a:p>
+            <a:r>
+              <a:rPr lang="en-US" sz="1600" dirty="0"/>
+              <a:t>MA Projects:</a:t>
+            </a:r>
+          </a:p>
+          <a:p>
+            <a:pPr marL="1876425" lvl="5" indent="-342900">
+              <a:buFont typeface="Wingdings" panose="05000000000000000000" pitchFamily="2" charset="2"/>
+              <a:buChar char="§"/>
+            </a:pPr>
+            <a:r>
+              <a:rPr lang="en-US" sz="1600" dirty="0">
+                <a:solidFill>
+                  <a:schemeClr val="accent4">
+                    <a:lumMod val="50000"/>
+                    <a:lumOff val="50000"/>
+                  </a:schemeClr>
+                </a:solidFill>
+              </a:rPr>
+              <a:t>A project to develop, standardize, and promote Modelica, a language to model and simulate multi-domain cyber physical systems in a convenient </a:t>
+            </a:r>
+            <a:r>
+              <a:rPr lang="en-US" sz="1600" dirty="0" err="1">
+                <a:solidFill>
+                  <a:schemeClr val="accent4">
+                    <a:lumMod val="50000"/>
+                    <a:lumOff val="50000"/>
+                  </a:schemeClr>
+                </a:solidFill>
+              </a:rPr>
+              <a:t>way.</a:t>
+            </a:r>
+            <a:r>
+              <a:rPr lang="en-US" sz="1600" dirty="0" err="1">
+                <a:solidFill>
+                  <a:srgbClr val="AFB2B4"/>
+                </a:solidFill>
+                <a:hlinkClick r:id="rId2">
+                  <a:extLst>
+                    <a:ext uri="{A12FA001-AC4F-418D-AE19-62706E023703}">
+                      <ahyp:hlinkClr xmlns:ahyp="http://schemas.microsoft.com/office/drawing/2018/hyperlinkcolor" val="tx"/>
+                    </a:ext>
+                  </a:extLst>
+                </a:hlinkClick>
+              </a:rPr>
+              <a:t>Modelica</a:t>
+            </a:r>
+            <a:r>
+              <a:rPr lang="en-US" sz="1600" dirty="0">
+                <a:solidFill>
+                  <a:schemeClr val="accent4">
+                    <a:lumMod val="50000"/>
+                    <a:lumOff val="50000"/>
+                  </a:schemeClr>
+                </a:solidFill>
+                <a:hlinkClick r:id="rId2">
+                  <a:extLst>
+                    <a:ext uri="{A12FA001-AC4F-418D-AE19-62706E023703}">
+                      <ahyp:hlinkClr xmlns:ahyp="http://schemas.microsoft.com/office/drawing/2018/hyperlinkcolor" val="tx"/>
+                    </a:ext>
+                  </a:extLst>
+                </a:hlinkClick>
+              </a:rPr>
+              <a:t> Language</a:t>
+            </a:r>
+            <a:endParaRPr lang="en-US" sz="1600" dirty="0">
+              <a:solidFill>
+                <a:schemeClr val="accent4">
+                  <a:lumMod val="50000"/>
+                  <a:lumOff val="50000"/>
+                </a:schemeClr>
+              </a:solidFill>
+            </a:endParaRPr>
+          </a:p>
+          <a:p>
+            <a:pPr marL="1876425" lvl="5" indent="-342900">
+              <a:buFont typeface="Wingdings" panose="05000000000000000000" pitchFamily="2" charset="2"/>
+              <a:buChar char="§"/>
+            </a:pPr>
+            <a:r>
+              <a:rPr lang="en-US" sz="1600" dirty="0">
+                <a:solidFill>
+                  <a:schemeClr val="accent4">
+                    <a:lumMod val="50000"/>
+                    <a:lumOff val="50000"/>
+                  </a:schemeClr>
+                </a:solidFill>
+              </a:rPr>
+              <a:t>A project to develop, maintain, and promote the open source Modelica libraries and model components in many domains based on standardized interface definitions. </a:t>
+            </a:r>
+            <a:r>
+              <a:rPr lang="en-US" sz="1600" dirty="0">
+                <a:solidFill>
+                  <a:schemeClr val="accent4">
+                    <a:lumMod val="50000"/>
+                    <a:lumOff val="50000"/>
+                  </a:schemeClr>
+                </a:solidFill>
+                <a:hlinkClick r:id="rId3">
+                  <a:extLst>
+                    <a:ext uri="{A12FA001-AC4F-418D-AE19-62706E023703}">
+                      <ahyp:hlinkClr xmlns:ahyp="http://schemas.microsoft.com/office/drawing/2018/hyperlinkcolor" val="tx"/>
+                    </a:ext>
+                  </a:extLst>
+                </a:hlinkClick>
+              </a:rPr>
+              <a:t>Modelica Libraries</a:t>
+            </a:r>
+            <a:endParaRPr lang="en-US" sz="1600" dirty="0">
+              <a:solidFill>
+                <a:schemeClr val="accent4">
+                  <a:lumMod val="50000"/>
+                  <a:lumOff val="50000"/>
+                </a:schemeClr>
+              </a:solidFill>
+            </a:endParaRPr>
+          </a:p>
+          <a:p>
+            <a:pPr marL="1876425" lvl="5" indent="-342900">
+              <a:buFont typeface="Wingdings" panose="05000000000000000000" pitchFamily="2" charset="2"/>
+              <a:buChar char="§"/>
+            </a:pPr>
+            <a:r>
+              <a:rPr lang="en-US" sz="1600" dirty="0">
+                <a:solidFill>
+                  <a:schemeClr val="accent4">
+                    <a:lumMod val="50000"/>
+                    <a:lumOff val="50000"/>
+                  </a:schemeClr>
+                </a:solidFill>
+              </a:rPr>
+              <a:t>A free standard that defines a container and interface to exchange dynamic simulation models using a combination of XML files, binaries, and C code. </a:t>
+            </a:r>
+            <a:r>
+              <a:rPr lang="en-US" sz="1600" dirty="0">
+                <a:solidFill>
+                  <a:schemeClr val="accent4">
+                    <a:lumMod val="50000"/>
+                    <a:lumOff val="50000"/>
+                  </a:schemeClr>
+                </a:solidFill>
+                <a:hlinkClick r:id="rId4">
+                  <a:extLst>
+                    <a:ext uri="{A12FA001-AC4F-418D-AE19-62706E023703}">
+                      <ahyp:hlinkClr xmlns:ahyp="http://schemas.microsoft.com/office/drawing/2018/hyperlinkcolor" val="tx"/>
+                    </a:ext>
+                  </a:extLst>
+                </a:hlinkClick>
+              </a:rPr>
+              <a:t>fmi-standard.org</a:t>
+            </a:r>
+            <a:endParaRPr lang="en-US" sz="1600" dirty="0">
+              <a:solidFill>
+                <a:schemeClr val="accent4">
+                  <a:lumMod val="50000"/>
+                  <a:lumOff val="50000"/>
+                </a:schemeClr>
+              </a:solidFill>
+            </a:endParaRPr>
+          </a:p>
+          <a:p>
+            <a:pPr marL="1876425" lvl="5" indent="-342900">
+              <a:buFont typeface="Wingdings" panose="05000000000000000000" pitchFamily="2" charset="2"/>
+              <a:buChar char="§"/>
+            </a:pPr>
+            <a:r>
+              <a:rPr lang="en-US" sz="1600" dirty="0">
+                <a:solidFill>
+                  <a:schemeClr val="accent4">
+                    <a:lumMod val="50000"/>
+                    <a:lumOff val="50000"/>
+                  </a:schemeClr>
+                </a:solidFill>
+              </a:rPr>
+              <a:t>A tool independent standard to define complete systems of one or more FMUs including its parameterization that can be transferred between simulation tools. </a:t>
+            </a:r>
+            <a:r>
+              <a:rPr lang="en-US" sz="1600" dirty="0">
+                <a:solidFill>
+                  <a:schemeClr val="accent4">
+                    <a:lumMod val="50000"/>
+                    <a:lumOff val="50000"/>
+                  </a:schemeClr>
+                </a:solidFill>
+                <a:hlinkClick r:id="rId5">
+                  <a:extLst>
+                    <a:ext uri="{A12FA001-AC4F-418D-AE19-62706E023703}">
+                      <ahyp:hlinkClr xmlns:ahyp="http://schemas.microsoft.com/office/drawing/2018/hyperlinkcolor" val="tx"/>
+                    </a:ext>
+                  </a:extLst>
+                </a:hlinkClick>
+              </a:rPr>
+              <a:t>ssp-standard.org</a:t>
+            </a:r>
+            <a:endParaRPr lang="en-US" sz="1600" dirty="0">
+              <a:solidFill>
+                <a:schemeClr val="accent4">
+                  <a:lumMod val="50000"/>
+                  <a:lumOff val="50000"/>
+                </a:schemeClr>
+              </a:solidFill>
+            </a:endParaRPr>
+          </a:p>
+          <a:p>
+            <a:pPr marL="1876425" lvl="5" indent="-342900">
+              <a:buFont typeface="Wingdings" panose="05000000000000000000" pitchFamily="2" charset="2"/>
+              <a:buChar char="§"/>
+            </a:pPr>
+            <a:r>
+              <a:rPr lang="en-US" sz="1600" dirty="0">
+                <a:solidFill>
+                  <a:schemeClr val="accent4">
+                    <a:lumMod val="50000"/>
+                    <a:lumOff val="50000"/>
+                  </a:schemeClr>
+                </a:solidFill>
+              </a:rPr>
+              <a:t>A platform and communication medium independent standard to integrate models and real-time systems into simulation environments. </a:t>
+            </a:r>
+            <a:r>
+              <a:rPr lang="en-US" sz="1600" dirty="0">
+                <a:solidFill>
+                  <a:schemeClr val="accent4">
+                    <a:lumMod val="50000"/>
+                    <a:lumOff val="50000"/>
+                  </a:schemeClr>
+                </a:solidFill>
+                <a:hlinkClick r:id="rId6">
+                  <a:extLst>
+                    <a:ext uri="{A12FA001-AC4F-418D-AE19-62706E023703}">
+                      <ahyp:hlinkClr xmlns:ahyp="http://schemas.microsoft.com/office/drawing/2018/hyperlinkcolor" val="tx"/>
+                    </a:ext>
+                  </a:extLst>
+                </a:hlinkClick>
+              </a:rPr>
+              <a:t>dcp-standard.org</a:t>
+            </a:r>
+            <a:endParaRPr lang="en-US" sz="1600" dirty="0">
+              <a:solidFill>
+                <a:schemeClr val="accent4">
+                  <a:lumMod val="50000"/>
+                  <a:lumOff val="50000"/>
+                </a:schemeClr>
+              </a:solidFill>
+            </a:endParaRPr>
+          </a:p>
+          <a:p>
+            <a:pPr marL="1876425" lvl="5" indent="-342900">
+              <a:buFont typeface="Wingdings" panose="05000000000000000000" pitchFamily="2" charset="2"/>
+              <a:buChar char="§"/>
+            </a:pPr>
+            <a:r>
+              <a:rPr lang="en-US" sz="1600" dirty="0">
+                <a:solidFill>
+                  <a:schemeClr val="accent4">
+                    <a:lumMod val="50000"/>
+                    <a:lumOff val="50000"/>
+                  </a:schemeClr>
+                </a:solidFill>
+              </a:rPr>
+              <a:t>A standard to seamlessly integrate physics design models of systems with their electronic controls development. </a:t>
+            </a:r>
+            <a:r>
+              <a:rPr lang="en-US" sz="1600" dirty="0">
+                <a:solidFill>
+                  <a:schemeClr val="accent4">
+                    <a:lumMod val="50000"/>
+                    <a:lumOff val="50000"/>
+                  </a:schemeClr>
+                </a:solidFill>
+                <a:hlinkClick r:id="rId7">
+                  <a:extLst>
+                    <a:ext uri="{A12FA001-AC4F-418D-AE19-62706E023703}">
+                      <ahyp:hlinkClr xmlns:ahyp="http://schemas.microsoft.com/office/drawing/2018/hyperlinkcolor" val="tx"/>
+                    </a:ext>
+                  </a:extLst>
+                </a:hlinkClick>
+              </a:rPr>
+              <a:t>efmi-standard.org</a:t>
+            </a:r>
+            <a:endParaRPr lang="en-US" sz="1600" dirty="0">
+              <a:solidFill>
+                <a:schemeClr val="accent4">
+                  <a:lumMod val="50000"/>
+                  <a:lumOff val="50000"/>
+                </a:schemeClr>
+              </a:solidFill>
+            </a:endParaRPr>
+          </a:p>
+          <a:p>
+            <a:endParaRPr lang="en-US" dirty="0"/>
           </a:p>
         </p:txBody>
       </p:sp>
@@ -18899,7 +21204,7 @@
           <p:cNvPr id="3" name="Titel 2">
             <a:extLst>
               <a:ext uri="{FF2B5EF4-FFF2-40B4-BE49-F238E27FC236}">
-                <a16:creationId xmlns:a16="http://schemas.microsoft.com/office/drawing/2014/main" id="{D6192EB5-44BC-97D1-4460-5710216A5101}"/>
+                <a16:creationId xmlns:a16="http://schemas.microsoft.com/office/drawing/2014/main" id="{0F65D651-008C-D9B7-9404-5C5F347E36EF}"/>
               </a:ext>
             </a:extLst>
           </p:cNvPr>
@@ -18917,779 +21222,17 @@
           <a:p>
             <a:r>
               <a:rPr lang="en-US" dirty="0"/>
-              <a:t>Exporting vs. Importing tool</a:t>
-            </a:r>
-          </a:p>
-        </p:txBody>
-      </p:sp>
-      <p:sp>
-        <p:nvSpPr>
-          <p:cNvPr id="138" name="TextBox 156">
-            <a:extLst>
-              <a:ext uri="{FF2B5EF4-FFF2-40B4-BE49-F238E27FC236}">
-                <a16:creationId xmlns:a16="http://schemas.microsoft.com/office/drawing/2014/main" id="{45E3F80A-360F-F324-4396-74ED16B437AC}"/>
-              </a:ext>
-            </a:extLst>
-          </p:cNvPr>
-          <p:cNvSpPr txBox="1"/>
-          <p:nvPr/>
-        </p:nvSpPr>
-        <p:spPr>
-          <a:xfrm>
-            <a:off x="6297810" y="2540427"/>
-            <a:ext cx="4977973" cy="323236"/>
-          </a:xfrm>
-          <a:prstGeom prst="rect">
-            <a:avLst/>
-          </a:prstGeom>
-          <a:noFill/>
-        </p:spPr>
-        <p:txBody>
-          <a:bodyPr wrap="square" lIns="0" tIns="0" rIns="0" bIns="0" rtlCol="0">
-            <a:noAutofit/>
-          </a:bodyPr>
-          <a:lstStyle/>
-          <a:p>
-            <a:pPr marL="228600" marR="0" indent="-228600" defTabSz="914400" eaLnBrk="1" fontAlgn="auto" latinLnBrk="0" hangingPunct="1">
-              <a:lnSpc>
-                <a:spcPts val="2300"/>
-              </a:lnSpc>
-              <a:spcBef>
-                <a:spcPts val="500"/>
-              </a:spcBef>
-              <a:spcAft>
-                <a:spcPts val="0"/>
-              </a:spcAft>
-              <a:buClrTx/>
-              <a:buSzTx/>
-              <a:buFont typeface="+mj-lt"/>
-              <a:buAutoNum type="arabicPeriod" startAt="2"/>
-              <a:tabLst/>
-            </a:pPr>
-            <a:r>
-              <a:rPr kumimoji="0" lang="en-US" b="0" i="0" u="none" strike="noStrike" kern="0" cap="none" spc="0" normalizeH="0" baseline="0" noProof="0" dirty="0">
-                <a:ln>
-                  <a:noFill/>
-                </a:ln>
-                <a:solidFill>
-                  <a:srgbClr val="000000"/>
-                </a:solidFill>
-                <a:effectLst/>
-                <a:uLnTx/>
-                <a:uFillTx/>
-              </a:rPr>
-              <a:t>export as </a:t>
-            </a:r>
-            <a:r>
-              <a:rPr kumimoji="0" lang="en-US" b="1" i="0" u="none" strike="noStrike" kern="0" cap="none" spc="0" normalizeH="0" baseline="0" noProof="0" dirty="0">
-                <a:ln>
-                  <a:noFill/>
-                </a:ln>
-                <a:solidFill>
-                  <a:srgbClr val="000000"/>
-                </a:solidFill>
-                <a:effectLst/>
-                <a:uLnTx/>
-                <a:uFillTx/>
-              </a:rPr>
-              <a:t>Functional Mockup Unit (FMU)</a:t>
-            </a:r>
-            <a:r>
-              <a:rPr kumimoji="0" lang="en-US" b="0" i="0" u="none" strike="noStrike" kern="0" cap="none" spc="0" normalizeH="0" baseline="0" noProof="0" dirty="0">
-                <a:ln>
-                  <a:noFill/>
-                </a:ln>
-                <a:solidFill>
-                  <a:srgbClr val="000000"/>
-                </a:solidFill>
-                <a:effectLst/>
-                <a:uLnTx/>
-                <a:uFillTx/>
-              </a:rPr>
-              <a:t> according</a:t>
-            </a:r>
-            <a:r>
-              <a:rPr lang="en-US" kern="0" dirty="0">
-                <a:solidFill>
-                  <a:srgbClr val="000000"/>
-                </a:solidFill>
-              </a:rPr>
-              <a:t>g to the </a:t>
-            </a:r>
-            <a:r>
-              <a:rPr lang="en-US" b="1" kern="0" dirty="0">
-                <a:solidFill>
-                  <a:srgbClr val="000000"/>
-                </a:solidFill>
-              </a:rPr>
-              <a:t>FMI Standard</a:t>
-            </a:r>
-            <a:endParaRPr kumimoji="0" lang="en-US" b="1" i="0" u="none" strike="noStrike" kern="0" cap="none" spc="0" normalizeH="0" baseline="0" noProof="0" dirty="0">
-              <a:ln>
-                <a:noFill/>
-              </a:ln>
-              <a:solidFill>
-                <a:srgbClr val="000000"/>
-              </a:solidFill>
-              <a:effectLst/>
-              <a:uLnTx/>
-              <a:uFillTx/>
-            </a:endParaRPr>
-          </a:p>
-        </p:txBody>
-      </p:sp>
-      <p:cxnSp>
-        <p:nvCxnSpPr>
-          <p:cNvPr id="139" name="Straight Arrow Connector 160">
-            <a:extLst>
-              <a:ext uri="{FF2B5EF4-FFF2-40B4-BE49-F238E27FC236}">
-                <a16:creationId xmlns:a16="http://schemas.microsoft.com/office/drawing/2014/main" id="{EFDD8117-50B2-D754-4320-F9C53BA7EC34}"/>
-              </a:ext>
-            </a:extLst>
-          </p:cNvPr>
-          <p:cNvCxnSpPr>
-            <a:cxnSpLocks/>
-            <a:endCxn id="141" idx="0"/>
-          </p:cNvCxnSpPr>
-          <p:nvPr/>
-        </p:nvCxnSpPr>
-        <p:spPr>
-          <a:xfrm>
-            <a:off x="5698783" y="3203115"/>
-            <a:ext cx="0" cy="309022"/>
-          </a:xfrm>
-          <a:prstGeom prst="straightConnector1">
-            <a:avLst/>
-          </a:prstGeom>
-          <a:ln>
-            <a:solidFill>
-              <a:schemeClr val="accent1"/>
-            </a:solidFill>
-            <a:tailEnd type="triangle"/>
-          </a:ln>
-        </p:spPr>
-        <p:style>
-          <a:lnRef idx="1">
-            <a:srgbClr val="007BC0"/>
-          </a:lnRef>
-          <a:fillRef idx="0">
-            <a:srgbClr val="007BC0"/>
-          </a:fillRef>
-          <a:effectRef idx="0">
-            <a:srgbClr val="007BC0"/>
-          </a:effectRef>
-          <a:fontRef idx="minor">
-            <a:schemeClr val="tx1"/>
-          </a:fontRef>
-        </p:style>
-      </p:cxnSp>
-      <p:sp>
-        <p:nvSpPr>
-          <p:cNvPr id="140" name="TextBox 165">
-            <a:extLst>
-              <a:ext uri="{FF2B5EF4-FFF2-40B4-BE49-F238E27FC236}">
-                <a16:creationId xmlns:a16="http://schemas.microsoft.com/office/drawing/2014/main" id="{B9A767D2-96C5-D46E-C2FA-20A8514CFAA9}"/>
-              </a:ext>
-            </a:extLst>
-          </p:cNvPr>
-          <p:cNvSpPr txBox="1"/>
-          <p:nvPr/>
-        </p:nvSpPr>
-        <p:spPr>
-          <a:xfrm>
-            <a:off x="6297810" y="2093694"/>
-            <a:ext cx="4265669" cy="328916"/>
-          </a:xfrm>
-          <a:prstGeom prst="rect">
-            <a:avLst/>
-          </a:prstGeom>
-          <a:noFill/>
-        </p:spPr>
-        <p:txBody>
-          <a:bodyPr wrap="square" lIns="0" tIns="0" rIns="0" bIns="0" rtlCol="0">
-            <a:noAutofit/>
-          </a:bodyPr>
-          <a:lstStyle/>
-          <a:p>
-            <a:pPr marL="228600" marR="0" indent="-228600" defTabSz="914400" eaLnBrk="1" fontAlgn="auto" latinLnBrk="0" hangingPunct="1">
-              <a:lnSpc>
-                <a:spcPts val="2300"/>
-              </a:lnSpc>
-              <a:spcBef>
-                <a:spcPts val="500"/>
-              </a:spcBef>
-              <a:spcAft>
-                <a:spcPts val="0"/>
-              </a:spcAft>
-              <a:buClrTx/>
-              <a:buSzTx/>
-              <a:buFont typeface="+mj-lt"/>
-              <a:buAutoNum type="arabicPeriod"/>
-              <a:tabLst/>
-            </a:pPr>
-            <a:r>
-              <a:rPr lang="en-US" kern="0" dirty="0">
-                <a:solidFill>
-                  <a:srgbClr val="000000"/>
-                </a:solidFill>
-              </a:rPr>
-              <a:t>develop model</a:t>
-            </a:r>
-            <a:endParaRPr kumimoji="0" lang="en-US" b="0" i="0" u="none" strike="noStrike" kern="0" cap="none" spc="0" normalizeH="0" baseline="0" noProof="0" dirty="0">
-              <a:ln>
-                <a:noFill/>
-              </a:ln>
-              <a:solidFill>
-                <a:srgbClr val="000000"/>
-              </a:solidFill>
-              <a:effectLst/>
-              <a:uLnTx/>
-              <a:uFillTx/>
-            </a:endParaRPr>
-          </a:p>
-        </p:txBody>
-      </p:sp>
-      <p:sp>
-        <p:nvSpPr>
-          <p:cNvPr id="141" name="Rectangle 8">
-            <a:extLst>
-              <a:ext uri="{FF2B5EF4-FFF2-40B4-BE49-F238E27FC236}">
-                <a16:creationId xmlns:a16="http://schemas.microsoft.com/office/drawing/2014/main" id="{2064C99B-969F-48AC-1571-860BF13D81F4}"/>
-              </a:ext>
-            </a:extLst>
-          </p:cNvPr>
-          <p:cNvSpPr/>
-          <p:nvPr/>
-        </p:nvSpPr>
-        <p:spPr>
-          <a:xfrm>
-            <a:off x="5295195" y="3512137"/>
-            <a:ext cx="807175" cy="346965"/>
-          </a:xfrm>
-          <a:prstGeom prst="rect">
-            <a:avLst/>
-          </a:prstGeom>
-          <a:solidFill>
-            <a:schemeClr val="accent6">
-              <a:lumMod val="75000"/>
-            </a:schemeClr>
-          </a:solidFill>
-          <a:ln w="28575" cap="flat" cmpd="sng" algn="ctr">
-            <a:solidFill>
-              <a:schemeClr val="bg1"/>
-            </a:solidFill>
-            <a:prstDash val="solid"/>
-          </a:ln>
-          <a:effectLst/>
-        </p:spPr>
-        <p:txBody>
-          <a:bodyPr rtlCol="0" anchor="ctr"/>
-          <a:lstStyle/>
-          <a:p>
-            <a:pPr marL="0" marR="0" indent="0" algn="ctr" defTabSz="914400" eaLnBrk="1" fontAlgn="auto" latinLnBrk="0" hangingPunct="1">
-              <a:lnSpc>
-                <a:spcPct val="100000"/>
-              </a:lnSpc>
-              <a:spcBef>
-                <a:spcPts val="0"/>
-              </a:spcBef>
-              <a:spcAft>
-                <a:spcPts val="0"/>
-              </a:spcAft>
-              <a:buClrTx/>
-              <a:buSzTx/>
-              <a:buFontTx/>
-              <a:buNone/>
-              <a:tabLst/>
-            </a:pPr>
-            <a:r>
-              <a:rPr kumimoji="0" lang="en-US" sz="1800" b="0" i="0" u="none" strike="noStrike" kern="0" cap="none" spc="0" normalizeH="0" baseline="0" noProof="0" dirty="0">
-                <a:ln>
-                  <a:noFill/>
-                </a:ln>
-                <a:solidFill>
-                  <a:srgbClr val="FFFFFF"/>
-                </a:solidFill>
-                <a:effectLst/>
-                <a:uLnTx/>
-                <a:uFillTx/>
-                <a:latin typeface="+mn-lt"/>
-                <a:ea typeface="+mn-ea"/>
-                <a:cs typeface="+mn-cs"/>
-              </a:rPr>
-              <a:t>FMU</a:t>
-            </a:r>
-          </a:p>
-        </p:txBody>
-      </p:sp>
-      <p:sp>
-        <p:nvSpPr>
-          <p:cNvPr id="144" name="TextBox 173">
-            <a:extLst>
-              <a:ext uri="{FF2B5EF4-FFF2-40B4-BE49-F238E27FC236}">
-                <a16:creationId xmlns:a16="http://schemas.microsoft.com/office/drawing/2014/main" id="{B3ABB214-0855-F674-1A1A-109FAC2964D4}"/>
-              </a:ext>
-            </a:extLst>
-          </p:cNvPr>
-          <p:cNvSpPr txBox="1"/>
-          <p:nvPr/>
-        </p:nvSpPr>
-        <p:spPr>
-          <a:xfrm>
-            <a:off x="2526120" y="4377669"/>
-            <a:ext cx="2405109" cy="891017"/>
-          </a:xfrm>
-          <a:prstGeom prst="rect">
-            <a:avLst/>
-          </a:prstGeom>
-          <a:noFill/>
-        </p:spPr>
-        <p:txBody>
-          <a:bodyPr wrap="square" lIns="0" tIns="0" rIns="0" bIns="0" rtlCol="0">
-            <a:noAutofit/>
-          </a:bodyPr>
-          <a:lstStyle/>
-          <a:p>
-            <a:pPr marL="228600" marR="0" indent="-228600" defTabSz="914400" eaLnBrk="1" fontAlgn="auto" latinLnBrk="0" hangingPunct="1">
-              <a:lnSpc>
-                <a:spcPts val="2300"/>
-              </a:lnSpc>
-              <a:spcBef>
-                <a:spcPts val="500"/>
-              </a:spcBef>
-              <a:spcAft>
-                <a:spcPts val="0"/>
-              </a:spcAft>
-              <a:buClrTx/>
-              <a:buSzTx/>
-              <a:buFont typeface="+mj-lt"/>
-              <a:buAutoNum type="arabicPeriod" startAt="3"/>
-              <a:tabLst/>
-            </a:pPr>
-            <a:r>
-              <a:rPr kumimoji="0" lang="en-US" b="1" i="0" u="none" strike="noStrike" kern="0" cap="none" spc="0" normalizeH="0" baseline="0" noProof="0" dirty="0">
-                <a:ln>
-                  <a:noFill/>
-                </a:ln>
-                <a:solidFill>
-                  <a:srgbClr val="000000"/>
-                </a:solidFill>
-                <a:effectLst/>
-                <a:uLnTx/>
-                <a:uFillTx/>
-              </a:rPr>
-              <a:t>import FMU </a:t>
-            </a:r>
-          </a:p>
-          <a:p>
-            <a:pPr marL="228600" indent="-228600" eaLnBrk="1" fontAlgn="auto" hangingPunct="1">
-              <a:lnSpc>
-                <a:spcPts val="2300"/>
-              </a:lnSpc>
-              <a:spcBef>
-                <a:spcPts val="500"/>
-              </a:spcBef>
-              <a:spcAft>
-                <a:spcPts val="0"/>
-              </a:spcAft>
-              <a:buFont typeface="+mj-lt"/>
-              <a:buAutoNum type="arabicPeriod" startAt="3"/>
-            </a:pPr>
-            <a:r>
-              <a:rPr lang="en-US" sz="1600" kern="0" dirty="0">
-                <a:solidFill>
-                  <a:srgbClr val="000000"/>
-                </a:solidFill>
-              </a:rPr>
-              <a:t>(co-) </a:t>
-            </a:r>
-            <a:r>
-              <a:rPr lang="en-US" sz="1600" b="1" kern="0" dirty="0">
-                <a:solidFill>
-                  <a:srgbClr val="000000"/>
-                </a:solidFill>
-              </a:rPr>
-              <a:t>simulate model </a:t>
-            </a:r>
-            <a:endParaRPr kumimoji="0" lang="en-US" sz="1600" b="1" i="0" u="none" strike="noStrike" kern="0" cap="none" spc="0" normalizeH="0" baseline="0" noProof="0" dirty="0">
-              <a:ln>
-                <a:noFill/>
-              </a:ln>
-              <a:solidFill>
-                <a:srgbClr val="000000"/>
-              </a:solidFill>
-              <a:effectLst/>
-              <a:uLnTx/>
-              <a:uFillTx/>
-            </a:endParaRPr>
-          </a:p>
-          <a:p>
-            <a:pPr marL="228600" marR="0" indent="-228600" defTabSz="914400" eaLnBrk="1" fontAlgn="auto" latinLnBrk="0" hangingPunct="1">
-              <a:lnSpc>
-                <a:spcPts val="2300"/>
-              </a:lnSpc>
-              <a:spcBef>
-                <a:spcPts val="500"/>
-              </a:spcBef>
-              <a:spcAft>
-                <a:spcPts val="0"/>
-              </a:spcAft>
-              <a:buClrTx/>
-              <a:buSzTx/>
-              <a:buFont typeface="+mj-lt"/>
-              <a:buAutoNum type="arabicPeriod" startAt="3"/>
-              <a:tabLst/>
-            </a:pPr>
-            <a:endParaRPr kumimoji="0" lang="en-US" b="0" i="0" u="none" strike="noStrike" kern="0" cap="none" spc="0" normalizeH="0" baseline="0" noProof="0" dirty="0">
-              <a:ln>
-                <a:noFill/>
-              </a:ln>
-              <a:solidFill>
-                <a:srgbClr val="000000"/>
-              </a:solidFill>
-              <a:effectLst/>
-              <a:uLnTx/>
-              <a:uFillTx/>
-            </a:endParaRPr>
-          </a:p>
-        </p:txBody>
-      </p:sp>
-      <p:cxnSp>
-        <p:nvCxnSpPr>
-          <p:cNvPr id="146" name="Straight Arrow Connector 157">
-            <a:extLst>
-              <a:ext uri="{FF2B5EF4-FFF2-40B4-BE49-F238E27FC236}">
-                <a16:creationId xmlns:a16="http://schemas.microsoft.com/office/drawing/2014/main" id="{55E41A82-12DB-8AF0-99FD-7E3E86F7B38C}"/>
-              </a:ext>
-            </a:extLst>
-          </p:cNvPr>
-          <p:cNvCxnSpPr>
-            <a:cxnSpLocks/>
-          </p:cNvCxnSpPr>
-          <p:nvPr/>
-        </p:nvCxnSpPr>
-        <p:spPr>
-          <a:xfrm>
-            <a:off x="5698782" y="3870346"/>
-            <a:ext cx="0" cy="309022"/>
-          </a:xfrm>
-          <a:prstGeom prst="straightConnector1">
-            <a:avLst/>
-          </a:prstGeom>
-          <a:ln>
-            <a:solidFill>
-              <a:schemeClr val="accent1"/>
-            </a:solidFill>
-            <a:tailEnd type="triangle"/>
-          </a:ln>
-        </p:spPr>
-        <p:style>
-          <a:lnRef idx="1">
-            <a:srgbClr val="007BC0"/>
-          </a:lnRef>
-          <a:fillRef idx="0">
-            <a:srgbClr val="007BC0"/>
-          </a:fillRef>
-          <a:effectRef idx="0">
-            <a:srgbClr val="007BC0"/>
-          </a:effectRef>
-          <a:fontRef idx="minor">
-            <a:schemeClr val="tx1"/>
-          </a:fontRef>
-        </p:style>
-      </p:cxnSp>
-      <p:sp>
-        <p:nvSpPr>
-          <p:cNvPr id="147" name="TextBox 146">
-            <a:extLst>
-              <a:ext uri="{FF2B5EF4-FFF2-40B4-BE49-F238E27FC236}">
-                <a16:creationId xmlns:a16="http://schemas.microsoft.com/office/drawing/2014/main" id="{837EBB6A-3627-727A-EB38-D3A9E1159390}"/>
-              </a:ext>
-            </a:extLst>
-          </p:cNvPr>
-          <p:cNvSpPr txBox="1"/>
-          <p:nvPr/>
-        </p:nvSpPr>
-        <p:spPr>
-          <a:xfrm>
-            <a:off x="2152602" y="1585602"/>
-            <a:ext cx="1689886" cy="338554"/>
-          </a:xfrm>
-          <a:prstGeom prst="rect">
-            <a:avLst/>
-          </a:prstGeom>
-          <a:noFill/>
-        </p:spPr>
-        <p:txBody>
-          <a:bodyPr wrap="none" rtlCol="0">
-            <a:spAutoFit/>
-          </a:bodyPr>
-          <a:lstStyle/>
-          <a:p>
-            <a:r>
-              <a:rPr lang="en-US" b="1" dirty="0">
-                <a:solidFill>
-                  <a:schemeClr val="accent6">
-                    <a:lumMod val="75000"/>
-                  </a:schemeClr>
-                </a:solidFill>
-              </a:rPr>
-              <a:t>Exporting tools</a:t>
-            </a:r>
-          </a:p>
-        </p:txBody>
-      </p:sp>
-      <p:sp>
-        <p:nvSpPr>
-          <p:cNvPr id="148" name="TextBox 147">
-            <a:extLst>
-              <a:ext uri="{FF2B5EF4-FFF2-40B4-BE49-F238E27FC236}">
-                <a16:creationId xmlns:a16="http://schemas.microsoft.com/office/drawing/2014/main" id="{A4FB0666-6CC6-4722-4DA1-E5563B231A85}"/>
-              </a:ext>
-            </a:extLst>
-          </p:cNvPr>
-          <p:cNvSpPr txBox="1"/>
-          <p:nvPr/>
-        </p:nvSpPr>
-        <p:spPr>
-          <a:xfrm>
-            <a:off x="5274512" y="5498548"/>
-            <a:ext cx="1566454" cy="338554"/>
-          </a:xfrm>
-          <a:prstGeom prst="rect">
-            <a:avLst/>
-          </a:prstGeom>
-          <a:noFill/>
-        </p:spPr>
-        <p:txBody>
-          <a:bodyPr wrap="none" rtlCol="0">
-            <a:spAutoFit/>
-          </a:bodyPr>
-          <a:lstStyle/>
-          <a:p>
-            <a:r>
-              <a:rPr lang="en-US" b="1" dirty="0">
-                <a:solidFill>
-                  <a:schemeClr val="accent6">
-                    <a:lumMod val="75000"/>
-                  </a:schemeClr>
-                </a:solidFill>
-              </a:rPr>
-              <a:t>Importing tool</a:t>
-            </a:r>
-          </a:p>
-        </p:txBody>
-      </p:sp>
-      <p:sp>
-        <p:nvSpPr>
-          <p:cNvPr id="4" name="Rectangle 3">
-            <a:extLst>
-              <a:ext uri="{FF2B5EF4-FFF2-40B4-BE49-F238E27FC236}">
-                <a16:creationId xmlns:a16="http://schemas.microsoft.com/office/drawing/2014/main" id="{C4E4F902-8D9D-E7F9-9C9E-672F33F101E6}"/>
-              </a:ext>
-            </a:extLst>
-          </p:cNvPr>
-          <p:cNvSpPr/>
-          <p:nvPr/>
-        </p:nvSpPr>
-        <p:spPr bwMode="auto">
-          <a:xfrm>
-            <a:off x="2253345" y="1994792"/>
-            <a:ext cx="3849025" cy="1206329"/>
-          </a:xfrm>
-          <a:prstGeom prst="rect">
-            <a:avLst/>
-          </a:prstGeom>
-          <a:noFill/>
-          <a:ln w="9525" cap="flat" cmpd="sng" algn="ctr">
-            <a:solidFill>
-              <a:schemeClr val="accent6">
-                <a:lumMod val="75000"/>
-              </a:schemeClr>
-            </a:solidFill>
-            <a:prstDash val="solid"/>
-            <a:round/>
-            <a:headEnd type="none" w="med" len="med"/>
-            <a:tailEnd type="arrow" w="med" len="med"/>
-          </a:ln>
-          <a:effectLst/>
-        </p:spPr>
-        <p:txBody>
-          <a:bodyPr vert="horz" wrap="square" lIns="90000" tIns="46800" rIns="36000" bIns="46800" numCol="1" rtlCol="0" anchor="t" anchorCtr="0" compatLnSpc="1">
-            <a:prstTxWarp prst="textNoShape">
-              <a:avLst/>
-            </a:prstTxWarp>
-            <a:spAutoFit/>
-          </a:bodyPr>
-          <a:lstStyle/>
-          <a:p>
-            <a:pPr marL="0" marR="0" indent="0" algn="l" defTabSz="914400" rtl="0" eaLnBrk="0" fontAlgn="base" latinLnBrk="0" hangingPunct="0">
-              <a:lnSpc>
-                <a:spcPct val="100000"/>
-              </a:lnSpc>
-              <a:spcBef>
-                <a:spcPct val="50000"/>
-              </a:spcBef>
-              <a:spcAft>
-                <a:spcPct val="0"/>
-              </a:spcAft>
-              <a:buClrTx/>
-              <a:buSzTx/>
-              <a:buFontTx/>
-              <a:buNone/>
-              <a:tabLst/>
-            </a:pPr>
-            <a:endParaRPr kumimoji="0" lang="en-US" sz="1600" b="0" i="0" u="none" strike="noStrike" cap="none" normalizeH="0" baseline="0">
-              <a:ln>
-                <a:noFill/>
-              </a:ln>
-              <a:solidFill>
-                <a:srgbClr val="120C80"/>
-              </a:solidFill>
-              <a:effectLst/>
-              <a:latin typeface="Arial" charset="0"/>
-              <a:cs typeface="Arial" charset="0"/>
-            </a:endParaRPr>
-          </a:p>
-        </p:txBody>
-      </p:sp>
-      <p:sp>
-        <p:nvSpPr>
-          <p:cNvPr id="150" name="Rectangle 149">
-            <a:extLst>
-              <a:ext uri="{FF2B5EF4-FFF2-40B4-BE49-F238E27FC236}">
-                <a16:creationId xmlns:a16="http://schemas.microsoft.com/office/drawing/2014/main" id="{CB265A1F-7F90-8B44-3E24-F893093748DA}"/>
-              </a:ext>
-            </a:extLst>
-          </p:cNvPr>
-          <p:cNvSpPr/>
-          <p:nvPr/>
-        </p:nvSpPr>
-        <p:spPr bwMode="auto">
-          <a:xfrm>
-            <a:off x="5274513" y="4170118"/>
-            <a:ext cx="2715602" cy="1206329"/>
-          </a:xfrm>
-          <a:prstGeom prst="rect">
-            <a:avLst/>
-          </a:prstGeom>
-          <a:noFill/>
-          <a:ln w="9525" cap="flat" cmpd="sng" algn="ctr">
-            <a:solidFill>
-              <a:schemeClr val="accent6">
-                <a:lumMod val="75000"/>
-              </a:schemeClr>
-            </a:solidFill>
-            <a:prstDash val="solid"/>
-            <a:round/>
-            <a:headEnd type="none" w="med" len="med"/>
-            <a:tailEnd type="arrow" w="med" len="med"/>
-          </a:ln>
-          <a:effectLst/>
-        </p:spPr>
-        <p:txBody>
-          <a:bodyPr vert="horz" wrap="square" lIns="90000" tIns="46800" rIns="36000" bIns="46800" numCol="1" rtlCol="0" anchor="t" anchorCtr="0" compatLnSpc="1">
-            <a:prstTxWarp prst="textNoShape">
-              <a:avLst/>
-            </a:prstTxWarp>
-            <a:spAutoFit/>
-          </a:bodyPr>
-          <a:lstStyle/>
-          <a:p>
-            <a:pPr marL="0" marR="0" indent="0" algn="l" defTabSz="914400" rtl="0" eaLnBrk="0" fontAlgn="base" latinLnBrk="0" hangingPunct="0">
-              <a:lnSpc>
-                <a:spcPct val="100000"/>
-              </a:lnSpc>
-              <a:spcBef>
-                <a:spcPct val="50000"/>
-              </a:spcBef>
-              <a:spcAft>
-                <a:spcPct val="0"/>
-              </a:spcAft>
-              <a:buClrTx/>
-              <a:buSzTx/>
-              <a:buFontTx/>
-              <a:buNone/>
-              <a:tabLst/>
-            </a:pPr>
-            <a:endParaRPr kumimoji="0" lang="en-US" sz="1600" b="0" i="0" u="none" strike="noStrike" cap="none" normalizeH="0" baseline="0">
-              <a:ln>
-                <a:noFill/>
-              </a:ln>
-              <a:solidFill>
-                <a:srgbClr val="120C80"/>
-              </a:solidFill>
-              <a:effectLst/>
-              <a:latin typeface="Arial" charset="0"/>
-              <a:cs typeface="Arial" charset="0"/>
-            </a:endParaRPr>
+              <a:t>The Modelica Association</a:t>
+            </a:r>
           </a:p>
         </p:txBody>
       </p:sp>
       <p:pic>
         <p:nvPicPr>
-          <p:cNvPr id="152" name="Picture 151">
+          <p:cNvPr id="9" name="Grafik 8">
             <a:extLst>
               <a:ext uri="{FF2B5EF4-FFF2-40B4-BE49-F238E27FC236}">
-                <a16:creationId xmlns:a16="http://schemas.microsoft.com/office/drawing/2014/main" id="{214385AA-7F75-E093-2563-CB48FF21F492}"/>
-              </a:ext>
-            </a:extLst>
-          </p:cNvPr>
-          <p:cNvPicPr>
-            <a:picLocks noChangeAspect="1"/>
-          </p:cNvPicPr>
-          <p:nvPr/>
-        </p:nvPicPr>
-        <p:blipFill rotWithShape="1">
-          <a:blip r:embed="rId2"/>
-          <a:srcRect b="50593"/>
-          <a:stretch/>
-        </p:blipFill>
-        <p:spPr>
-          <a:xfrm>
-            <a:off x="2345824" y="2136065"/>
-            <a:ext cx="1700127" cy="911542"/>
-          </a:xfrm>
-          <a:prstGeom prst="rect">
-            <a:avLst/>
-          </a:prstGeom>
-        </p:spPr>
-      </p:pic>
-      <p:pic>
-        <p:nvPicPr>
-          <p:cNvPr id="153" name="Picture 152">
-            <a:extLst>
-              <a:ext uri="{FF2B5EF4-FFF2-40B4-BE49-F238E27FC236}">
-                <a16:creationId xmlns:a16="http://schemas.microsoft.com/office/drawing/2014/main" id="{DC094FE4-04D7-2506-0745-48FAC2034FDA}"/>
-              </a:ext>
-            </a:extLst>
-          </p:cNvPr>
-          <p:cNvPicPr>
-            <a:picLocks noChangeAspect="1"/>
-          </p:cNvPicPr>
-          <p:nvPr/>
-        </p:nvPicPr>
-        <p:blipFill rotWithShape="1">
-          <a:blip r:embed="rId2"/>
-          <a:srcRect t="45923"/>
-          <a:stretch/>
-        </p:blipFill>
-        <p:spPr>
-          <a:xfrm>
-            <a:off x="4104372" y="2049883"/>
-            <a:ext cx="1700127" cy="997724"/>
-          </a:xfrm>
-          <a:prstGeom prst="rect">
-            <a:avLst/>
-          </a:prstGeom>
-        </p:spPr>
-      </p:pic>
-      <p:pic>
-        <p:nvPicPr>
-          <p:cNvPr id="155" name="Picture 154">
-            <a:extLst>
-              <a:ext uri="{FF2B5EF4-FFF2-40B4-BE49-F238E27FC236}">
-                <a16:creationId xmlns:a16="http://schemas.microsoft.com/office/drawing/2014/main" id="{DB39975B-FB5C-96E8-2997-B4B11670AC35}"/>
+                <a16:creationId xmlns:a16="http://schemas.microsoft.com/office/drawing/2014/main" id="{0F2269C4-FB89-7680-8C86-8E408A4F1F17}"/>
               </a:ext>
             </a:extLst>
           </p:cNvPr>
@@ -19699,15 +21242,21 @@
           <p:nvPr/>
         </p:nvPicPr>
         <p:blipFill>
-          <a:blip r:embed="rId3"/>
+          <a:blip r:embed="rId8">
+            <a:extLst>
+              <a:ext uri="{28A0092B-C50C-407E-A947-70E740481C1C}">
+                <a14:useLocalDpi xmlns:a14="http://schemas.microsoft.com/office/drawing/2010/main" val="0"/>
+              </a:ext>
+            </a:extLst>
+          </a:blip>
           <a:stretch>
             <a:fillRect/>
           </a:stretch>
         </p:blipFill>
         <p:spPr>
           <a:xfrm>
-            <a:off x="5698782" y="4384625"/>
-            <a:ext cx="1434220" cy="877103"/>
+            <a:off x="10092248" y="1349375"/>
+            <a:ext cx="1568469" cy="747176"/>
           </a:xfrm>
           <a:prstGeom prst="rect">
             <a:avLst/>
@@ -19716,10 +21265,10 @@
       </p:pic>
       <p:pic>
         <p:nvPicPr>
-          <p:cNvPr id="157" name="Picture 156">
+          <p:cNvPr id="11" name="Grafik 10">
             <a:extLst>
               <a:ext uri="{FF2B5EF4-FFF2-40B4-BE49-F238E27FC236}">
-                <a16:creationId xmlns:a16="http://schemas.microsoft.com/office/drawing/2014/main" id="{B59A83F1-834A-F9D4-8ECA-F74FE98AC59A}"/>
+                <a16:creationId xmlns:a16="http://schemas.microsoft.com/office/drawing/2014/main" id="{1033E766-FD10-E71D-42B5-2F2E17FF7144}"/>
               </a:ext>
             </a:extLst>
           </p:cNvPr>
@@ -19729,25 +21278,280 @@
           <p:nvPr/>
         </p:nvPicPr>
         <p:blipFill>
-          <a:blip r:embed="rId4"/>
+          <a:blip r:embed="rId9">
+            <a:extLst>
+              <a:ext uri="{28A0092B-C50C-407E-A947-70E740481C1C}">
+                <a14:useLocalDpi xmlns:a14="http://schemas.microsoft.com/office/drawing/2010/main" val="0"/>
+              </a:ext>
+            </a:extLst>
+          </a:blip>
           <a:stretch>
             <a:fillRect/>
           </a:stretch>
         </p:blipFill>
         <p:spPr>
           <a:xfrm>
-            <a:off x="6415892" y="3383849"/>
-            <a:ext cx="2186483" cy="603541"/>
+            <a:off x="681645" y="3915513"/>
+            <a:ext cx="1073927" cy="380633"/>
           </a:xfrm>
           <a:prstGeom prst="rect">
             <a:avLst/>
           </a:prstGeom>
         </p:spPr>
       </p:pic>
+      <p:pic>
+        <p:nvPicPr>
+          <p:cNvPr id="13" name="Grafik 12">
+            <a:extLst>
+              <a:ext uri="{FF2B5EF4-FFF2-40B4-BE49-F238E27FC236}">
+                <a16:creationId xmlns:a16="http://schemas.microsoft.com/office/drawing/2014/main" id="{2E796F10-026A-D649-142C-595D8C0BA7FB}"/>
+              </a:ext>
+            </a:extLst>
+          </p:cNvPr>
+          <p:cNvPicPr>
+            <a:picLocks noChangeAspect="1"/>
+          </p:cNvPicPr>
+          <p:nvPr/>
+        </p:nvPicPr>
+        <p:blipFill>
+          <a:blip r:embed="rId10">
+            <a:extLst>
+              <a:ext uri="{28A0092B-C50C-407E-A947-70E740481C1C}">
+                <a14:useLocalDpi xmlns:a14="http://schemas.microsoft.com/office/drawing/2010/main" val="0"/>
+              </a:ext>
+            </a:extLst>
+          </a:blip>
+          <a:stretch>
+            <a:fillRect/>
+          </a:stretch>
+        </p:blipFill>
+        <p:spPr>
+          <a:xfrm>
+            <a:off x="681645" y="2831325"/>
+            <a:ext cx="760295" cy="380633"/>
+          </a:xfrm>
+          <a:prstGeom prst="rect">
+            <a:avLst/>
+          </a:prstGeom>
+        </p:spPr>
+      </p:pic>
+      <p:pic>
+        <p:nvPicPr>
+          <p:cNvPr id="15" name="Grafik 14">
+            <a:extLst>
+              <a:ext uri="{FF2B5EF4-FFF2-40B4-BE49-F238E27FC236}">
+                <a16:creationId xmlns:a16="http://schemas.microsoft.com/office/drawing/2014/main" id="{D570ABF2-C041-2C17-D643-C1577667DDAD}"/>
+              </a:ext>
+            </a:extLst>
+          </p:cNvPr>
+          <p:cNvPicPr>
+            <a:picLocks noChangeAspect="1"/>
+          </p:cNvPicPr>
+          <p:nvPr/>
+        </p:nvPicPr>
+        <p:blipFill>
+          <a:blip r:embed="rId11">
+            <a:extLst>
+              <a:ext uri="{28A0092B-C50C-407E-A947-70E740481C1C}">
+                <a14:useLocalDpi xmlns:a14="http://schemas.microsoft.com/office/drawing/2010/main" val="0"/>
+              </a:ext>
+            </a:extLst>
+          </a:blip>
+          <a:stretch>
+            <a:fillRect/>
+          </a:stretch>
+        </p:blipFill>
+        <p:spPr>
+          <a:xfrm>
+            <a:off x="664119" y="3323913"/>
+            <a:ext cx="801171" cy="380633"/>
+          </a:xfrm>
+          <a:prstGeom prst="rect">
+            <a:avLst/>
+          </a:prstGeom>
+        </p:spPr>
+      </p:pic>
+      <p:pic>
+        <p:nvPicPr>
+          <p:cNvPr id="17" name="Grafik 16">
+            <a:extLst>
+              <a:ext uri="{FF2B5EF4-FFF2-40B4-BE49-F238E27FC236}">
+                <a16:creationId xmlns:a16="http://schemas.microsoft.com/office/drawing/2014/main" id="{D33CE156-AE82-DC9E-C09B-0201662F83E7}"/>
+              </a:ext>
+            </a:extLst>
+          </p:cNvPr>
+          <p:cNvPicPr>
+            <a:picLocks noChangeAspect="1"/>
+          </p:cNvPicPr>
+          <p:nvPr/>
+        </p:nvPicPr>
+        <p:blipFill>
+          <a:blip r:embed="rId12">
+            <a:extLst>
+              <a:ext uri="{28A0092B-C50C-407E-A947-70E740481C1C}">
+                <a14:useLocalDpi xmlns:a14="http://schemas.microsoft.com/office/drawing/2010/main" val="0"/>
+              </a:ext>
+            </a:extLst>
+          </a:blip>
+          <a:stretch>
+            <a:fillRect/>
+          </a:stretch>
+        </p:blipFill>
+        <p:spPr>
+          <a:xfrm>
+            <a:off x="681645" y="4507113"/>
+            <a:ext cx="1440151" cy="269472"/>
+          </a:xfrm>
+          <a:prstGeom prst="rect">
+            <a:avLst/>
+          </a:prstGeom>
+        </p:spPr>
+      </p:pic>
+      <p:pic>
+        <p:nvPicPr>
+          <p:cNvPr id="19" name="Grafik 18">
+            <a:extLst>
+              <a:ext uri="{FF2B5EF4-FFF2-40B4-BE49-F238E27FC236}">
+                <a16:creationId xmlns:a16="http://schemas.microsoft.com/office/drawing/2014/main" id="{BA663A5C-6DA3-45D3-C65E-A3C145F960FD}"/>
+              </a:ext>
+            </a:extLst>
+          </p:cNvPr>
+          <p:cNvPicPr>
+            <a:picLocks noChangeAspect="1"/>
+          </p:cNvPicPr>
+          <p:nvPr/>
+        </p:nvPicPr>
+        <p:blipFill>
+          <a:blip r:embed="rId13">
+            <a:extLst>
+              <a:ext uri="{28A0092B-C50C-407E-A947-70E740481C1C}">
+                <a14:useLocalDpi xmlns:a14="http://schemas.microsoft.com/office/drawing/2010/main" val="0"/>
+              </a:ext>
+            </a:extLst>
+          </a:blip>
+          <a:stretch>
+            <a:fillRect/>
+          </a:stretch>
+        </p:blipFill>
+        <p:spPr>
+          <a:xfrm>
+            <a:off x="681645" y="5010062"/>
+            <a:ext cx="1261856" cy="353051"/>
+          </a:xfrm>
+          <a:prstGeom prst="rect">
+            <a:avLst/>
+          </a:prstGeom>
+        </p:spPr>
+      </p:pic>
+      <p:pic>
+        <p:nvPicPr>
+          <p:cNvPr id="21" name="Grafik 20">
+            <a:extLst>
+              <a:ext uri="{FF2B5EF4-FFF2-40B4-BE49-F238E27FC236}">
+                <a16:creationId xmlns:a16="http://schemas.microsoft.com/office/drawing/2014/main" id="{1DEBB3D1-5FDB-4521-BD0E-5AA9C64F2A72}"/>
+              </a:ext>
+            </a:extLst>
+          </p:cNvPr>
+          <p:cNvPicPr>
+            <a:picLocks noChangeAspect="1"/>
+          </p:cNvPicPr>
+          <p:nvPr/>
+        </p:nvPicPr>
+        <p:blipFill>
+          <a:blip r:embed="rId14"/>
+          <a:stretch>
+            <a:fillRect/>
+          </a:stretch>
+        </p:blipFill>
+        <p:spPr>
+          <a:xfrm>
+            <a:off x="681645" y="5637215"/>
+            <a:ext cx="1440152" cy="360788"/>
+          </a:xfrm>
+          <a:prstGeom prst="rect">
+            <a:avLst/>
+          </a:prstGeom>
+        </p:spPr>
+      </p:pic>
+      <p:sp>
+        <p:nvSpPr>
+          <p:cNvPr id="4" name="Rectangle 3">
+            <a:extLst>
+              <a:ext uri="{FF2B5EF4-FFF2-40B4-BE49-F238E27FC236}">
+                <a16:creationId xmlns:a16="http://schemas.microsoft.com/office/drawing/2014/main" id="{35D7F6AF-1099-C61C-93C0-E002C7094DB5}"/>
+              </a:ext>
+            </a:extLst>
+          </p:cNvPr>
+          <p:cNvSpPr/>
+          <p:nvPr/>
+        </p:nvSpPr>
+        <p:spPr>
+          <a:xfrm>
+            <a:off x="0" y="6379297"/>
+            <a:ext cx="4629150" cy="326303"/>
+          </a:xfrm>
+          <a:prstGeom prst="rect">
+            <a:avLst/>
+          </a:prstGeom>
+          <a:solidFill>
+            <a:srgbClr val="FFFFFF"/>
+          </a:solidFill>
+          <a:ln>
+            <a:noFill/>
+          </a:ln>
+        </p:spPr>
+        <p:style>
+          <a:lnRef idx="2">
+            <a:schemeClr val="dk1">
+              <a:shade val="15000"/>
+            </a:schemeClr>
+          </a:lnRef>
+          <a:fillRef idx="1">
+            <a:schemeClr val="dk1"/>
+          </a:fillRef>
+          <a:effectRef idx="0">
+            <a:schemeClr val="dk1"/>
+          </a:effectRef>
+          <a:fontRef idx="minor">
+            <a:schemeClr val="lt1"/>
+          </a:fontRef>
+        </p:style>
+        <p:txBody>
+          <a:bodyPr rtlCol="0" anchor="ctr"/>
+          <a:lstStyle/>
+          <a:p>
+            <a:pPr algn="ctr"/>
+            <a:r>
+              <a:rPr lang="de-DE" sz="1000" dirty="0">
+                <a:solidFill>
+                  <a:srgbClr val="C00000"/>
+                </a:solidFill>
+              </a:rPr>
+              <a:t>© 2025 Modelica </a:t>
+            </a:r>
+            <a:r>
+              <a:rPr lang="de-DE" sz="1000" dirty="0" err="1">
+                <a:solidFill>
+                  <a:srgbClr val="C00000"/>
+                </a:solidFill>
+              </a:rPr>
+              <a:t>Association</a:t>
+            </a:r>
+            <a:r>
+              <a:rPr lang="de-DE" sz="1000" dirty="0">
+                <a:solidFill>
+                  <a:srgbClr val="C00000"/>
+                </a:solidFill>
+              </a:rPr>
+              <a:t> Project FMI | fmi-standard.org</a:t>
+            </a:r>
+          </a:p>
+        </p:txBody>
+      </p:sp>
     </p:spTree>
     <p:extLst>
       <p:ext uri="{BB962C8B-B14F-4D97-AF65-F5344CB8AC3E}">
-        <p14:creationId xmlns:p14="http://schemas.microsoft.com/office/powerpoint/2010/main" val="157138638"/>
+        <p14:creationId xmlns:p14="http://schemas.microsoft.com/office/powerpoint/2010/main" val="3158725597"/>
       </p:ext>
     </p:extLst>
   </p:cSld>

</xml_diff>

<commit_message>
update slides and PDFs
</commit_message>
<xml_diff>
--- a/part1/Introduction-to-FMI.pptx
+++ b/part1/Introduction-to-FMI.pptx
@@ -588,7 +588,7 @@
               <a:pPr>
                 <a:defRPr/>
               </a:pPr>
-              <a:t>8/7/2025</a:t>
+              <a:t>8/11/2025</a:t>
             </a:fld>
             <a:endParaRPr lang="en-US"/>
           </a:p>
@@ -13370,7 +13370,7 @@
           <a:p>
             <a:r>
               <a:rPr lang="en-US" dirty="0"/>
-              <a:t>Motivation for FMI 3.0</a:t>
+              <a:t>Motivation for FMI 3.0 (Modelica Conference 2021)</a:t>
             </a:r>
           </a:p>
         </p:txBody>
@@ -22536,12 +22536,6 @@
 </file>
 
 <file path=customXml/item1.xml><?xml version="1.0" encoding="utf-8"?>
-<p:properties xmlns:p="http://schemas.microsoft.com/office/2006/metadata/properties" xmlns:xsi="http://www.w3.org/2001/XMLSchema-instance" xmlns:pc="http://schemas.microsoft.com/office/infopath/2007/PartnerControls">
-  <documentManagement/>
-</p:properties>
-</file>
-
-<file path=customXml/item2.xml><?xml version="1.0" encoding="utf-8"?>
 <ct:contentTypeSchema xmlns:ct="http://schemas.microsoft.com/office/2006/metadata/contentType" xmlns:ma="http://schemas.microsoft.com/office/2006/metadata/properties/metaAttributes" ct:_="" ma:_="" ma:contentTypeName="Document" ma:contentTypeID="0x0101004E5FCAD8E6222F478CF98AE6458717E4" ma:contentTypeVersion="0" ma:contentTypeDescription="Create a new document." ma:contentTypeScope="" ma:versionID="ae4c969974cdc097ec4092e4953e579e">
   <xsd:schema xmlns:xsd="http://www.w3.org/2001/XMLSchema" xmlns:p="http://schemas.microsoft.com/office/2006/metadata/properties" targetNamespace="http://schemas.microsoft.com/office/2006/metadata/properties" ma:root="true" ma:fieldsID="9684e7e44b4b32ae9d4fdaa413507a5d">
     <xsd:element name="properties">
@@ -22590,7 +22584,28 @@
 </ct:contentTypeSchema>
 </file>
 
+<file path=customXml/item2.xml><?xml version="1.0" encoding="utf-8"?>
+<p:properties xmlns:p="http://schemas.microsoft.com/office/2006/metadata/properties" xmlns:xsi="http://www.w3.org/2001/XMLSchema-instance" xmlns:pc="http://schemas.microsoft.com/office/infopath/2007/PartnerControls">
+  <documentManagement/>
+</p:properties>
+</file>
+
 <file path=customXml/itemProps1.xml><?xml version="1.0" encoding="utf-8"?>
+<ds:datastoreItem xmlns:ds="http://schemas.openxmlformats.org/officeDocument/2006/customXml" ds:itemID="{D6DDF4F8-48B7-40A7-A044-30F13F7F87CD}">
+  <ds:schemaRefs>
+    <ds:schemaRef ds:uri="http://schemas.microsoft.com/office/2006/metadata/contentType"/>
+    <ds:schemaRef ds:uri="http://schemas.microsoft.com/office/2006/metadata/properties/metaAttributes"/>
+    <ds:schemaRef ds:uri="http://www.w3.org/2001/XMLSchema"/>
+    <ds:schemaRef ds:uri="http://schemas.microsoft.com/office/2006/metadata/properties"/>
+    <ds:schemaRef ds:uri="http://schemas.openxmlformats.org/package/2006/metadata/core-properties"/>
+    <ds:schemaRef ds:uri="http://purl.org/dc/elements/1.1/"/>
+    <ds:schemaRef ds:uri="http://purl.org/dc/terms/"/>
+    <ds:schemaRef ds:uri="http://schemas.microsoft.com/office/internal/2005/internalDocumentation"/>
+  </ds:schemaRefs>
+</ds:datastoreItem>
+</file>
+
+<file path=customXml/itemProps2.xml><?xml version="1.0" encoding="utf-8"?>
 <ds:datastoreItem xmlns:ds="http://schemas.openxmlformats.org/officeDocument/2006/customXml" ds:itemID="{2605D1E8-C791-4C95-A083-CBF3AF871BEC}">
   <ds:schemaRefs>
     <ds:schemaRef ds:uri="http://purl.org/dc/terms/"/>
@@ -22603,19 +22618,4 @@
     <ds:schemaRef ds:uri="http://schemas.microsoft.com/office/infopath/2007/PartnerControls"/>
   </ds:schemaRefs>
 </ds:datastoreItem>
-</file>
-
-<file path=customXml/itemProps2.xml><?xml version="1.0" encoding="utf-8"?>
-<ds:datastoreItem xmlns:ds="http://schemas.openxmlformats.org/officeDocument/2006/customXml" ds:itemID="{D6DDF4F8-48B7-40A7-A044-30F13F7F87CD}">
-  <ds:schemaRefs>
-    <ds:schemaRef ds:uri="http://schemas.microsoft.com/office/2006/metadata/contentType"/>
-    <ds:schemaRef ds:uri="http://schemas.microsoft.com/office/2006/metadata/properties/metaAttributes"/>
-    <ds:schemaRef ds:uri="http://www.w3.org/2001/XMLSchema"/>
-    <ds:schemaRef ds:uri="http://schemas.microsoft.com/office/2006/metadata/properties"/>
-    <ds:schemaRef ds:uri="http://schemas.openxmlformats.org/package/2006/metadata/core-properties"/>
-    <ds:schemaRef ds:uri="http://purl.org/dc/elements/1.1/"/>
-    <ds:schemaRef ds:uri="http://purl.org/dc/terms/"/>
-    <ds:schemaRef ds:uri="http://schemas.microsoft.com/office/internal/2005/internalDocumentation"/>
-  </ds:schemaRefs>
-</ds:datastoreItem>
 </file>
</xml_diff>

<commit_message>
updates, use Colab instead of Binder
</commit_message>
<xml_diff>
--- a/part1/Introduction-to-FMI.pptx
+++ b/part1/Introduction-to-FMI.pptx
@@ -588,7 +588,7 @@
               <a:pPr>
                 <a:defRPr/>
               </a:pPr>
-              <a:t>8/11/2025</a:t>
+              <a:t>9/7/2025</a:t>
             </a:fld>
             <a:endParaRPr lang="en-US"/>
           </a:p>
@@ -6113,7 +6113,7 @@
             </a:r>
             <a:r>
               <a:rPr lang="en-US" dirty="0"/>
-              <a:t>(from the FMI 3.0.1 glossary)</a:t>
+              <a:t>(from the FMI 3.0.2 glossary)</a:t>
             </a:r>
           </a:p>
           <a:p>
@@ -14887,7 +14887,7 @@
         <p:spPr>
           <a:xfrm>
             <a:off x="620183" y="4118776"/>
-            <a:ext cx="10893305" cy="1815882"/>
+            <a:ext cx="10893305" cy="1384995"/>
           </a:xfrm>
           <a:prstGeom prst="rect">
             <a:avLst/>
@@ -14899,9 +14899,6 @@
             <a:spAutoFit/>
           </a:bodyPr>
           <a:lstStyle/>
-          <a:p>
-            <a:endParaRPr lang="en-GB" sz="2800" dirty="0"/>
-          </a:p>
           <a:p>
             <a:endParaRPr lang="en-GB" sz="2800" dirty="0"/>
           </a:p>
@@ -16268,6 +16265,41 @@
             <a:r>
               <a:rPr lang="en-US" dirty="0"/>
               <a:t>FMI 3.0: Main Improvements</a:t>
+            </a:r>
+          </a:p>
+        </p:txBody>
+      </p:sp>
+      <p:sp>
+        <p:nvSpPr>
+          <p:cNvPr id="4" name="Textfeld 3">
+            <a:extLst>
+              <a:ext uri="{FF2B5EF4-FFF2-40B4-BE49-F238E27FC236}">
+                <a16:creationId xmlns:a16="http://schemas.microsoft.com/office/drawing/2014/main" id="{1B6A60EB-3445-8566-B889-CF61219E50FC}"/>
+              </a:ext>
+            </a:extLst>
+          </p:cNvPr>
+          <p:cNvSpPr txBox="1"/>
+          <p:nvPr/>
+        </p:nvSpPr>
+        <p:spPr>
+          <a:xfrm>
+            <a:off x="9511748" y="5804452"/>
+            <a:ext cx="1773242" cy="338554"/>
+          </a:xfrm>
+          <a:prstGeom prst="rect">
+            <a:avLst/>
+          </a:prstGeom>
+          <a:noFill/>
+        </p:spPr>
+        <p:txBody>
+          <a:bodyPr wrap="none" rtlCol="0">
+            <a:spAutoFit/>
+          </a:bodyPr>
+          <a:lstStyle/>
+          <a:p>
+            <a:r>
+              <a:rPr lang="en-US" dirty="0"/>
+              <a:t>… more in part 4!</a:t>
             </a:r>
           </a:p>
         </p:txBody>
@@ -19503,6 +19535,19 @@
           </a:p>
           <a:p>
             <a:pPr marL="342900" indent="-342900">
+              <a:lnSpc>
+                <a:spcPct val="150000"/>
+              </a:lnSpc>
+              <a:buFont typeface="Wingdings" panose="05000000000000000000" pitchFamily="2" charset="2"/>
+              <a:buChar char="§"/>
+            </a:pPr>
+            <a:r>
+              <a:rPr lang="en-US" dirty="0"/>
+              <a:t>2024, 25: Release of FMI Layered Standards FMI-LS-XCP, FMI-LS-XCP</a:t>
+            </a:r>
+          </a:p>
+          <a:p>
+            <a:pPr marL="342900" indent="-342900">
               <a:buFont typeface="Wingdings" panose="05000000000000000000" pitchFamily="2" charset="2"/>
               <a:buChar char="§"/>
             </a:pPr>
@@ -20054,7 +20099,7 @@
                 <a:ea typeface="+mj-ea"/>
                 <a:cs typeface="+mj-cs"/>
               </a:rPr>
-              <a:t>„FMI 2.0.4“</a:t>
+              <a:t>„FMI 3.0.2“</a:t>
             </a:r>
             <a:endParaRPr lang="en-US" sz="2800" b="1" dirty="0">
               <a:solidFill>
@@ -21568,6 +21613,8 @@
   <p:tag name="EMPOWERCHARTSPROPERTIES_SLOT" val="A"/>
   <p:tag name="EMPOWERCHARTSPROPERTIES_LASTWRITEDATE" val="638888928185137095"/>
   <p:tag name="EMPOWERCHARTSPROPERTIES_A_LENGTH" val="24576"/>
+  <p:tag name="COAUTHORING_SESSION_ID" val="66e2bfa7-088c-4f8b-8bcf-6c9b723e9fac"/>
+  <p:tag name="UNDO_REDO_REVISION" val="3"/>
 </p:tagLst>
 </file>
 

</xml_diff>